<commit_message>
zenn 741e79cf2e9bf2: overview, shm, CUDA IPC and SAR figures for the opening
</commit_message>
<xml_diff>
--- a/zenn/articles/741e79cf2e9bf2/source/figs.pptx
+++ b/zenn/articles/741e79cf2e9bf2/source/figs.pptx
@@ -20,6 +20,10 @@
     <p:sldId id="262" r:id="rId6"/>
     <p:sldId id="263" r:id="rId5"/>
     <p:sldId id="264" r:id="rId4"/>
+    <p:sldId id="265" r:id="rId3"/>
+    <p:sldId id="266" r:id="rId2"/>
+    <p:sldId id="267" r:id="rId20"/>
+    <p:sldId id="268" r:id="rId21"/>
   </p:sldIdLst>
   <p:sldSz cx="12192000" cy="6858000"/>
   <p:notesSz cx="6858000" cy="9144000"/>
@@ -3678,6 +3682,3836 @@
                 <a:cs typeface="メイリオ"/>
               </a:rPr>
               <a:t>By default, same-node data does not go through the EFA device</a:t>
+            </a:r>
+          </a:p>
+        </p:txBody>
+      </p:sp>
+    </p:spTree>
+  </p:cSld>
+  <p:clrMapOvr>
+    <a:masterClrMapping/>
+  </p:clrMapOvr>
+</p:sld>
+</file>
+
+<file path=ppt/slides/slide10.xml><?xml version="1.0" encoding="utf-8"?>
+<p:sld xmlns:a="http://schemas.openxmlformats.org/drawingml/2006/main" xmlns:p="http://schemas.openxmlformats.org/presentationml/2006/main" xmlns:r="http://schemas.openxmlformats.org/officeDocument/2006/relationships" showMasterSp="0">
+  <p:cSld>
+    <p:spTree>
+      <p:nvGrpSpPr>
+        <p:cNvPr id="1" name=""/>
+        <p:cNvGrpSpPr/>
+        <p:nvPr/>
+      </p:nvGrpSpPr>
+      <p:grpSpPr/>
+      <p:sp>
+        <p:nvSpPr>
+          <p:cNvPr id="2" name="TextBox 1"/>
+          <p:cNvSpPr txBox="1"/>
+          <p:nvPr/>
+        </p:nvSpPr>
+        <p:spPr>
+          <a:xfrm>
+            <a:off x="409575" y="247650"/>
+            <a:ext cx="11334750" cy="438150"/>
+          </a:xfrm>
+          <a:prstGeom prst="rect">
+            <a:avLst/>
+          </a:prstGeom>
+          <a:noFill/>
+        </p:spPr>
+        <p:txBody>
+          <a:bodyPr wrap="square" lIns="0" rIns="0" tIns="0" bIns="0" anchor="ctr">
+            <a:spAutoFit/>
+          </a:bodyPr>
+          <a:lstStyle/>
+          <a:p>
+            <a:pPr algn="l">
+              <a:lnSpc>
+                <a:spcPct val="122000"/>
+              </a:lnSpc>
+            </a:pPr>
+            <a:r>
+              <a:rPr sz="3000" b="1">
+                <a:solidFill>
+                  <a:srgbClr val="F5F5F8"/>
+                </a:solidFill>
+                <a:latin typeface="Amazon Ember"/>
+                <a:ea typeface="メイリオ"/>
+                <a:cs typeface="メイリオ"/>
+              </a:rPr>
+              <a:t>Where the bytes go</a:t>
+            </a:r>
+          </a:p>
+        </p:txBody>
+      </p:sp>
+      <p:sp>
+        <p:nvSpPr>
+          <p:cNvPr id="3" name="TextBox 2"/>
+          <p:cNvSpPr txBox="1"/>
+          <p:nvPr/>
+        </p:nvSpPr>
+        <p:spPr>
+          <a:xfrm>
+            <a:off x="409575" y="685800"/>
+            <a:ext cx="11334750" cy="247650"/>
+          </a:xfrm>
+          <a:prstGeom prst="rect">
+            <a:avLst/>
+          </a:prstGeom>
+          <a:noFill/>
+        </p:spPr>
+        <p:txBody>
+          <a:bodyPr wrap="square" lIns="0" rIns="0" tIns="0" bIns="0" anchor="ctr">
+            <a:spAutoFit/>
+          </a:bodyPr>
+          <a:lstStyle/>
+          <a:p>
+            <a:pPr algn="l">
+              <a:lnSpc>
+                <a:spcPct val="122000"/>
+              </a:lnSpc>
+            </a:pPr>
+            <a:r>
+              <a:rPr sz="1600" b="0">
+                <a:solidFill>
+                  <a:srgbClr val="96969E"/>
+                </a:solidFill>
+                <a:latin typeface="Amazon Ember"/>
+                <a:ea typeface="メイリオ"/>
+                <a:cs typeface="メイリオ"/>
+              </a:rPr>
+              <a:t>libfabric with FI_PROVIDER=efa: another node vs the same node</a:t>
+            </a:r>
+          </a:p>
+        </p:txBody>
+      </p:sp>
+      <p:sp>
+        <p:nvSpPr>
+          <p:cNvPr id="4" name="Rounded Rectangle 3"/>
+          <p:cNvSpPr/>
+          <p:nvPr/>
+        </p:nvSpPr>
+        <p:spPr>
+          <a:xfrm>
+            <a:off x="409575" y="1143000"/>
+            <a:ext cx="5334000" cy="4476750"/>
+          </a:xfrm>
+          <a:prstGeom prst="roundRect">
+            <a:avLst>
+              <a:gd name="adj" fmla="val 4000"/>
+            </a:avLst>
+          </a:prstGeom>
+          <a:solidFill>
+            <a:srgbClr val="161A1E"/>
+          </a:solidFill>
+          <a:ln w="15875">
+            <a:solidFill>
+              <a:srgbClr val="464A50"/>
+            </a:solidFill>
+          </a:ln>
+          <a:effectLst/>
+        </p:spPr>
+        <p:style>
+          <a:lnRef idx="1">
+            <a:schemeClr val="accent1"/>
+          </a:lnRef>
+          <a:fillRef idx="3">
+            <a:schemeClr val="accent1"/>
+          </a:fillRef>
+          <a:effectRef idx="2">
+            <a:schemeClr val="accent1"/>
+          </a:effectRef>
+          <a:fontRef idx="minor">
+            <a:schemeClr val="lt1"/>
+          </a:fontRef>
+        </p:style>
+        <p:txBody>
+          <a:bodyPr rtlCol="0" anchor="ctr"/>
+          <a:lstStyle/>
+          <a:p>
+            <a:pPr algn="ctr"/>
+          </a:p>
+        </p:txBody>
+      </p:sp>
+      <p:sp>
+        <p:nvSpPr>
+          <p:cNvPr id="5" name="TextBox 4"/>
+          <p:cNvSpPr txBox="1"/>
+          <p:nvPr/>
+        </p:nvSpPr>
+        <p:spPr>
+          <a:xfrm>
+            <a:off x="600075" y="1219200"/>
+            <a:ext cx="4953000" cy="285750"/>
+          </a:xfrm>
+          <a:prstGeom prst="rect">
+            <a:avLst/>
+          </a:prstGeom>
+          <a:noFill/>
+        </p:spPr>
+        <p:txBody>
+          <a:bodyPr wrap="square" lIns="0" rIns="0" tIns="0" bIns="0" anchor="ctr">
+            <a:spAutoFit/>
+          </a:bodyPr>
+          <a:lstStyle/>
+          <a:p>
+            <a:pPr algn="l">
+              <a:lnSpc>
+                <a:spcPct val="122000"/>
+              </a:lnSpc>
+            </a:pPr>
+            <a:r>
+              <a:rPr sz="1800" b="1">
+                <a:solidFill>
+                  <a:srgbClr val="F5F5F8"/>
+                </a:solidFill>
+                <a:latin typeface="Amazon Ember"/>
+                <a:ea typeface="メイリオ"/>
+                <a:cs typeface="メイリオ"/>
+              </a:rPr>
+              <a:t>peer on another node</a:t>
+            </a:r>
+          </a:p>
+        </p:txBody>
+      </p:sp>
+      <p:sp>
+        <p:nvSpPr>
+          <p:cNvPr id="6" name="Rounded Rectangle 5"/>
+          <p:cNvSpPr/>
+          <p:nvPr/>
+        </p:nvSpPr>
+        <p:spPr>
+          <a:xfrm>
+            <a:off x="695325" y="1666875"/>
+            <a:ext cx="2095500" cy="571500"/>
+          </a:xfrm>
+          <a:prstGeom prst="roundRect">
+            <a:avLst>
+              <a:gd name="adj" fmla="val 10000"/>
+            </a:avLst>
+          </a:prstGeom>
+          <a:solidFill>
+            <a:srgbClr val="124022"/>
+          </a:solidFill>
+          <a:ln w="15875">
+            <a:solidFill>
+              <a:srgbClr val="24A046"/>
+            </a:solidFill>
+          </a:ln>
+          <a:effectLst/>
+        </p:spPr>
+        <p:style>
+          <a:lnRef idx="1">
+            <a:schemeClr val="accent1"/>
+          </a:lnRef>
+          <a:fillRef idx="3">
+            <a:schemeClr val="accent1"/>
+          </a:fillRef>
+          <a:effectRef idx="2">
+            <a:schemeClr val="accent1"/>
+          </a:effectRef>
+          <a:fontRef idx="minor">
+            <a:schemeClr val="lt1"/>
+          </a:fontRef>
+        </p:style>
+        <p:txBody>
+          <a:bodyPr rtlCol="0" anchor="ctr" wrap="square" lIns="19050" rIns="19050" tIns="19050" bIns="19050"/>
+          <a:lstStyle/>
+          <a:p>
+            <a:pPr algn="ctr">
+              <a:lnSpc>
+                <a:spcPct val="122000"/>
+              </a:lnSpc>
+            </a:pPr>
+            <a:r>
+              <a:rPr sz="1500" b="1">
+                <a:solidFill>
+                  <a:srgbClr val="F5F5F8"/>
+                </a:solidFill>
+                <a:latin typeface="Amazon Ember"/>
+                <a:ea typeface="メイリオ"/>
+                <a:cs typeface="メイリオ"/>
+              </a:rPr>
+              <a:t>GPU (node A)</a:t>
+            </a:r>
+          </a:p>
+        </p:txBody>
+      </p:sp>
+      <p:sp>
+        <p:nvSpPr>
+          <p:cNvPr id="7" name="Rounded Rectangle 6"/>
+          <p:cNvSpPr/>
+          <p:nvPr/>
+        </p:nvSpPr>
+        <p:spPr>
+          <a:xfrm>
+            <a:off x="3362325" y="1666875"/>
+            <a:ext cx="2095500" cy="571500"/>
+          </a:xfrm>
+          <a:prstGeom prst="roundRect">
+            <a:avLst>
+              <a:gd name="adj" fmla="val 10000"/>
+            </a:avLst>
+          </a:prstGeom>
+          <a:solidFill>
+            <a:srgbClr val="124022"/>
+          </a:solidFill>
+          <a:ln w="15875">
+            <a:solidFill>
+              <a:srgbClr val="24A046"/>
+            </a:solidFill>
+          </a:ln>
+          <a:effectLst/>
+        </p:spPr>
+        <p:style>
+          <a:lnRef idx="1">
+            <a:schemeClr val="accent1"/>
+          </a:lnRef>
+          <a:fillRef idx="3">
+            <a:schemeClr val="accent1"/>
+          </a:fillRef>
+          <a:effectRef idx="2">
+            <a:schemeClr val="accent1"/>
+          </a:effectRef>
+          <a:fontRef idx="minor">
+            <a:schemeClr val="lt1"/>
+          </a:fontRef>
+        </p:style>
+        <p:txBody>
+          <a:bodyPr rtlCol="0" anchor="ctr" wrap="square" lIns="19050" rIns="19050" tIns="19050" bIns="19050"/>
+          <a:lstStyle/>
+          <a:p>
+            <a:pPr algn="ctr">
+              <a:lnSpc>
+                <a:spcPct val="122000"/>
+              </a:lnSpc>
+            </a:pPr>
+            <a:r>
+              <a:rPr sz="1500" b="1">
+                <a:solidFill>
+                  <a:srgbClr val="F5F5F8"/>
+                </a:solidFill>
+                <a:latin typeface="Amazon Ember"/>
+                <a:ea typeface="メイリオ"/>
+                <a:cs typeface="メイリオ"/>
+              </a:rPr>
+              <a:t>GPU (node B)</a:t>
+            </a:r>
+          </a:p>
+        </p:txBody>
+      </p:sp>
+      <p:sp>
+        <p:nvSpPr>
+          <p:cNvPr id="8" name="Rounded Rectangle 7"/>
+          <p:cNvSpPr/>
+          <p:nvPr/>
+        </p:nvSpPr>
+        <p:spPr>
+          <a:xfrm>
+            <a:off x="695325" y="2762250"/>
+            <a:ext cx="2095500" cy="571500"/>
+          </a:xfrm>
+          <a:prstGeom prst="roundRect">
+            <a:avLst>
+              <a:gd name="adj" fmla="val 10000"/>
+            </a:avLst>
+          </a:prstGeom>
+          <a:solidFill>
+            <a:srgbClr val="102C48"/>
+          </a:solidFill>
+          <a:ln w="15875">
+            <a:solidFill>
+              <a:srgbClr val="2896F0"/>
+            </a:solidFill>
+          </a:ln>
+          <a:effectLst/>
+        </p:spPr>
+        <p:style>
+          <a:lnRef idx="1">
+            <a:schemeClr val="accent1"/>
+          </a:lnRef>
+          <a:fillRef idx="3">
+            <a:schemeClr val="accent1"/>
+          </a:fillRef>
+          <a:effectRef idx="2">
+            <a:schemeClr val="accent1"/>
+          </a:effectRef>
+          <a:fontRef idx="minor">
+            <a:schemeClr val="lt1"/>
+          </a:fontRef>
+        </p:style>
+        <p:txBody>
+          <a:bodyPr rtlCol="0" anchor="ctr" wrap="square" lIns="19050" rIns="19050" tIns="19050" bIns="19050"/>
+          <a:lstStyle/>
+          <a:p>
+            <a:pPr algn="ctr">
+              <a:lnSpc>
+                <a:spcPct val="122000"/>
+              </a:lnSpc>
+            </a:pPr>
+            <a:r>
+              <a:rPr sz="1500" b="1">
+                <a:solidFill>
+                  <a:srgbClr val="F5F5F8"/>
+                </a:solidFill>
+                <a:latin typeface="Amazon Ember"/>
+                <a:ea typeface="メイリオ"/>
+                <a:cs typeface="メイリオ"/>
+              </a:rPr>
+              <a:t>efa provider</a:t>
+            </a:r>
+          </a:p>
+        </p:txBody>
+      </p:sp>
+      <p:sp>
+        <p:nvSpPr>
+          <p:cNvPr id="9" name="Rounded Rectangle 8"/>
+          <p:cNvSpPr/>
+          <p:nvPr/>
+        </p:nvSpPr>
+        <p:spPr>
+          <a:xfrm>
+            <a:off x="3362325" y="2762250"/>
+            <a:ext cx="2095500" cy="571500"/>
+          </a:xfrm>
+          <a:prstGeom prst="roundRect">
+            <a:avLst>
+              <a:gd name="adj" fmla="val 10000"/>
+            </a:avLst>
+          </a:prstGeom>
+          <a:solidFill>
+            <a:srgbClr val="102C48"/>
+          </a:solidFill>
+          <a:ln w="15875">
+            <a:solidFill>
+              <a:srgbClr val="2896F0"/>
+            </a:solidFill>
+          </a:ln>
+          <a:effectLst/>
+        </p:spPr>
+        <p:style>
+          <a:lnRef idx="1">
+            <a:schemeClr val="accent1"/>
+          </a:lnRef>
+          <a:fillRef idx="3">
+            <a:schemeClr val="accent1"/>
+          </a:fillRef>
+          <a:effectRef idx="2">
+            <a:schemeClr val="accent1"/>
+          </a:effectRef>
+          <a:fontRef idx="minor">
+            <a:schemeClr val="lt1"/>
+          </a:fontRef>
+        </p:style>
+        <p:txBody>
+          <a:bodyPr rtlCol="0" anchor="ctr" wrap="square" lIns="19050" rIns="19050" tIns="19050" bIns="19050"/>
+          <a:lstStyle/>
+          <a:p>
+            <a:pPr algn="ctr">
+              <a:lnSpc>
+                <a:spcPct val="122000"/>
+              </a:lnSpc>
+            </a:pPr>
+            <a:r>
+              <a:rPr sz="1500" b="1">
+                <a:solidFill>
+                  <a:srgbClr val="F5F5F8"/>
+                </a:solidFill>
+                <a:latin typeface="Amazon Ember"/>
+                <a:ea typeface="メイリオ"/>
+                <a:cs typeface="メイリオ"/>
+              </a:rPr>
+              <a:t>efa provider</a:t>
+            </a:r>
+          </a:p>
+        </p:txBody>
+      </p:sp>
+      <p:sp>
+        <p:nvSpPr>
+          <p:cNvPr id="10" name="Rounded Rectangle 9"/>
+          <p:cNvSpPr/>
+          <p:nvPr/>
+        </p:nvSpPr>
+        <p:spPr>
+          <a:xfrm>
+            <a:off x="695325" y="3857625"/>
+            <a:ext cx="2095500" cy="571500"/>
+          </a:xfrm>
+          <a:prstGeom prst="roundRect">
+            <a:avLst>
+              <a:gd name="adj" fmla="val 10000"/>
+            </a:avLst>
+          </a:prstGeom>
+          <a:solidFill>
+            <a:srgbClr val="343840"/>
+          </a:solidFill>
+          <a:ln w="15875">
+            <a:solidFill>
+              <a:srgbClr val="464A50"/>
+            </a:solidFill>
+          </a:ln>
+          <a:effectLst/>
+        </p:spPr>
+        <p:style>
+          <a:lnRef idx="1">
+            <a:schemeClr val="accent1"/>
+          </a:lnRef>
+          <a:fillRef idx="3">
+            <a:schemeClr val="accent1"/>
+          </a:fillRef>
+          <a:effectRef idx="2">
+            <a:schemeClr val="accent1"/>
+          </a:effectRef>
+          <a:fontRef idx="minor">
+            <a:schemeClr val="lt1"/>
+          </a:fontRef>
+        </p:style>
+        <p:txBody>
+          <a:bodyPr rtlCol="0" anchor="ctr" wrap="square" lIns="19050" rIns="19050" tIns="19050" bIns="19050"/>
+          <a:lstStyle/>
+          <a:p>
+            <a:pPr algn="ctr">
+              <a:lnSpc>
+                <a:spcPct val="122000"/>
+              </a:lnSpc>
+            </a:pPr>
+            <a:r>
+              <a:rPr sz="1500" b="1">
+                <a:solidFill>
+                  <a:srgbClr val="F5F5F8"/>
+                </a:solidFill>
+                <a:latin typeface="Amazon Ember"/>
+                <a:ea typeface="メイリオ"/>
+                <a:cs typeface="メイリオ"/>
+              </a:rPr>
+              <a:t>EFA device</a:t>
+            </a:r>
+          </a:p>
+        </p:txBody>
+      </p:sp>
+      <p:sp>
+        <p:nvSpPr>
+          <p:cNvPr id="11" name="Rounded Rectangle 10"/>
+          <p:cNvSpPr/>
+          <p:nvPr/>
+        </p:nvSpPr>
+        <p:spPr>
+          <a:xfrm>
+            <a:off x="3362325" y="3857625"/>
+            <a:ext cx="2095500" cy="571500"/>
+          </a:xfrm>
+          <a:prstGeom prst="roundRect">
+            <a:avLst>
+              <a:gd name="adj" fmla="val 10000"/>
+            </a:avLst>
+          </a:prstGeom>
+          <a:solidFill>
+            <a:srgbClr val="343840"/>
+          </a:solidFill>
+          <a:ln w="15875">
+            <a:solidFill>
+              <a:srgbClr val="464A50"/>
+            </a:solidFill>
+          </a:ln>
+          <a:effectLst/>
+        </p:spPr>
+        <p:style>
+          <a:lnRef idx="1">
+            <a:schemeClr val="accent1"/>
+          </a:lnRef>
+          <a:fillRef idx="3">
+            <a:schemeClr val="accent1"/>
+          </a:fillRef>
+          <a:effectRef idx="2">
+            <a:schemeClr val="accent1"/>
+          </a:effectRef>
+          <a:fontRef idx="minor">
+            <a:schemeClr val="lt1"/>
+          </a:fontRef>
+        </p:style>
+        <p:txBody>
+          <a:bodyPr rtlCol="0" anchor="ctr" wrap="square" lIns="19050" rIns="19050" tIns="19050" bIns="19050"/>
+          <a:lstStyle/>
+          <a:p>
+            <a:pPr algn="ctr">
+              <a:lnSpc>
+                <a:spcPct val="122000"/>
+              </a:lnSpc>
+            </a:pPr>
+            <a:r>
+              <a:rPr sz="1500" b="1">
+                <a:solidFill>
+                  <a:srgbClr val="F5F5F8"/>
+                </a:solidFill>
+                <a:latin typeface="Amazon Ember"/>
+                <a:ea typeface="メイリオ"/>
+                <a:cs typeface="メイリオ"/>
+              </a:rPr>
+              <a:t>EFA device</a:t>
+            </a:r>
+          </a:p>
+        </p:txBody>
+      </p:sp>
+      <p:cxnSp>
+        <p:nvCxnSpPr>
+          <p:cNvPr id="12" name="Connector 11"/>
+          <p:cNvCxnSpPr/>
+          <p:nvPr/>
+        </p:nvCxnSpPr>
+        <p:spPr>
+          <a:xfrm>
+            <a:off x="1743075" y="2238375"/>
+            <a:ext cx="0" cy="523875"/>
+          </a:xfrm>
+          <a:prstGeom prst="line">
+            <a:avLst/>
+          </a:prstGeom>
+          <a:ln w="25400">
+            <a:solidFill>
+              <a:srgbClr val="F5F5F8"/>
+            </a:solidFill>
+            <a:tailEnd type="triangle" w="med" len="med"/>
+          </a:ln>
+          <a:effectLst/>
+        </p:spPr>
+        <p:style>
+          <a:lnRef idx="2">
+            <a:schemeClr val="accent1"/>
+          </a:lnRef>
+          <a:fillRef idx="0">
+            <a:schemeClr val="accent1"/>
+          </a:fillRef>
+          <a:effectRef idx="1">
+            <a:schemeClr val="accent1"/>
+          </a:effectRef>
+          <a:fontRef idx="minor">
+            <a:schemeClr val="tx1"/>
+          </a:fontRef>
+        </p:style>
+      </p:cxnSp>
+      <p:cxnSp>
+        <p:nvCxnSpPr>
+          <p:cNvPr id="13" name="Connector 12"/>
+          <p:cNvCxnSpPr/>
+          <p:nvPr/>
+        </p:nvCxnSpPr>
+        <p:spPr>
+          <a:xfrm>
+            <a:off x="1743075" y="3333750"/>
+            <a:ext cx="0" cy="523875"/>
+          </a:xfrm>
+          <a:prstGeom prst="line">
+            <a:avLst/>
+          </a:prstGeom>
+          <a:ln w="25400">
+            <a:solidFill>
+              <a:srgbClr val="F5F5F8"/>
+            </a:solidFill>
+            <a:tailEnd type="triangle" w="med" len="med"/>
+          </a:ln>
+          <a:effectLst/>
+        </p:spPr>
+        <p:style>
+          <a:lnRef idx="2">
+            <a:schemeClr val="accent1"/>
+          </a:lnRef>
+          <a:fillRef idx="0">
+            <a:schemeClr val="accent1"/>
+          </a:fillRef>
+          <a:effectRef idx="1">
+            <a:schemeClr val="accent1"/>
+          </a:effectRef>
+          <a:fontRef idx="minor">
+            <a:schemeClr val="tx1"/>
+          </a:fontRef>
+        </p:style>
+      </p:cxnSp>
+      <p:cxnSp>
+        <p:nvCxnSpPr>
+          <p:cNvPr id="14" name="Connector 13"/>
+          <p:cNvCxnSpPr/>
+          <p:nvPr/>
+        </p:nvCxnSpPr>
+        <p:spPr>
+          <a:xfrm>
+            <a:off x="2790825" y="4143375"/>
+            <a:ext cx="571500" cy="0"/>
+          </a:xfrm>
+          <a:prstGeom prst="line">
+            <a:avLst/>
+          </a:prstGeom>
+          <a:ln w="38100">
+            <a:solidFill>
+              <a:srgbClr val="3BD16F"/>
+            </a:solidFill>
+            <a:tailEnd type="triangle" w="med" len="med"/>
+          </a:ln>
+          <a:effectLst/>
+        </p:spPr>
+        <p:style>
+          <a:lnRef idx="2">
+            <a:schemeClr val="accent1"/>
+          </a:lnRef>
+          <a:fillRef idx="0">
+            <a:schemeClr val="accent1"/>
+          </a:fillRef>
+          <a:effectRef idx="1">
+            <a:schemeClr val="accent1"/>
+          </a:effectRef>
+          <a:fontRef idx="minor">
+            <a:schemeClr val="tx1"/>
+          </a:fontRef>
+        </p:style>
+      </p:cxnSp>
+      <p:cxnSp>
+        <p:nvCxnSpPr>
+          <p:cNvPr id="15" name="Connector 14"/>
+          <p:cNvCxnSpPr/>
+          <p:nvPr/>
+        </p:nvCxnSpPr>
+        <p:spPr>
+          <a:xfrm flipV="1">
+            <a:off x="4410075" y="3333750"/>
+            <a:ext cx="0" cy="523875"/>
+          </a:xfrm>
+          <a:prstGeom prst="line">
+            <a:avLst/>
+          </a:prstGeom>
+          <a:ln w="25400">
+            <a:solidFill>
+              <a:srgbClr val="F5F5F8"/>
+            </a:solidFill>
+            <a:tailEnd type="triangle" w="med" len="med"/>
+          </a:ln>
+          <a:effectLst/>
+        </p:spPr>
+        <p:style>
+          <a:lnRef idx="2">
+            <a:schemeClr val="accent1"/>
+          </a:lnRef>
+          <a:fillRef idx="0">
+            <a:schemeClr val="accent1"/>
+          </a:fillRef>
+          <a:effectRef idx="1">
+            <a:schemeClr val="accent1"/>
+          </a:effectRef>
+          <a:fontRef idx="minor">
+            <a:schemeClr val="tx1"/>
+          </a:fontRef>
+        </p:style>
+      </p:cxnSp>
+      <p:cxnSp>
+        <p:nvCxnSpPr>
+          <p:cNvPr id="16" name="Connector 15"/>
+          <p:cNvCxnSpPr/>
+          <p:nvPr/>
+        </p:nvCxnSpPr>
+        <p:spPr>
+          <a:xfrm flipV="1">
+            <a:off x="4410075" y="2238375"/>
+            <a:ext cx="0" cy="523875"/>
+          </a:xfrm>
+          <a:prstGeom prst="line">
+            <a:avLst/>
+          </a:prstGeom>
+          <a:ln w="25400">
+            <a:solidFill>
+              <a:srgbClr val="F5F5F8"/>
+            </a:solidFill>
+            <a:tailEnd type="triangle" w="med" len="med"/>
+          </a:ln>
+          <a:effectLst/>
+        </p:spPr>
+        <p:style>
+          <a:lnRef idx="2">
+            <a:schemeClr val="accent1"/>
+          </a:lnRef>
+          <a:fillRef idx="0">
+            <a:schemeClr val="accent1"/>
+          </a:fillRef>
+          <a:effectRef idx="1">
+            <a:schemeClr val="accent1"/>
+          </a:effectRef>
+          <a:fontRef idx="minor">
+            <a:schemeClr val="tx1"/>
+          </a:fontRef>
+        </p:style>
+      </p:cxnSp>
+      <p:sp>
+        <p:nvSpPr>
+          <p:cNvPr id="17" name="TextBox 16"/>
+          <p:cNvSpPr txBox="1"/>
+          <p:nvPr/>
+        </p:nvSpPr>
+        <p:spPr>
+          <a:xfrm>
+            <a:off x="695325" y="4667250"/>
+            <a:ext cx="4762500" cy="571500"/>
+          </a:xfrm>
+          <a:prstGeom prst="rect">
+            <a:avLst/>
+          </a:prstGeom>
+          <a:noFill/>
+        </p:spPr>
+        <p:txBody>
+          <a:bodyPr wrap="square" lIns="0" rIns="0" tIns="0" bIns="0" anchor="ctr">
+            <a:spAutoFit/>
+          </a:bodyPr>
+          <a:lstStyle/>
+          <a:p>
+            <a:pPr algn="ctr">
+              <a:lnSpc>
+                <a:spcPct val="122000"/>
+              </a:lnSpc>
+            </a:pPr>
+            <a:r>
+              <a:rPr sz="1500" b="0">
+                <a:solidFill>
+                  <a:srgbClr val="3BD16F"/>
+                </a:solidFill>
+                <a:latin typeface="Amazon Ember"/>
+                <a:ea typeface="メイリオ"/>
+                <a:cs typeface="メイリオ"/>
+              </a:rPr>
+              <a:t>through the network</a:t>
+            </a:r>
+          </a:p>
+        </p:txBody>
+      </p:sp>
+      <p:sp>
+        <p:nvSpPr>
+          <p:cNvPr id="18" name="Rounded Rectangle 17"/>
+          <p:cNvSpPr/>
+          <p:nvPr/>
+        </p:nvSpPr>
+        <p:spPr>
+          <a:xfrm>
+            <a:off x="6448425" y="1143000"/>
+            <a:ext cx="5334000" cy="4476750"/>
+          </a:xfrm>
+          <a:prstGeom prst="roundRect">
+            <a:avLst>
+              <a:gd name="adj" fmla="val 4000"/>
+            </a:avLst>
+          </a:prstGeom>
+          <a:solidFill>
+            <a:srgbClr val="161A1E"/>
+          </a:solidFill>
+          <a:ln w="15875">
+            <a:solidFill>
+              <a:srgbClr val="464A50"/>
+            </a:solidFill>
+          </a:ln>
+          <a:effectLst/>
+        </p:spPr>
+        <p:style>
+          <a:lnRef idx="1">
+            <a:schemeClr val="accent1"/>
+          </a:lnRef>
+          <a:fillRef idx="3">
+            <a:schemeClr val="accent1"/>
+          </a:fillRef>
+          <a:effectRef idx="2">
+            <a:schemeClr val="accent1"/>
+          </a:effectRef>
+          <a:fontRef idx="minor">
+            <a:schemeClr val="lt1"/>
+          </a:fontRef>
+        </p:style>
+        <p:txBody>
+          <a:bodyPr rtlCol="0" anchor="ctr"/>
+          <a:lstStyle/>
+          <a:p>
+            <a:pPr algn="ctr"/>
+          </a:p>
+        </p:txBody>
+      </p:sp>
+      <p:sp>
+        <p:nvSpPr>
+          <p:cNvPr id="19" name="TextBox 18"/>
+          <p:cNvSpPr txBox="1"/>
+          <p:nvPr/>
+        </p:nvSpPr>
+        <p:spPr>
+          <a:xfrm>
+            <a:off x="6638925" y="1219200"/>
+            <a:ext cx="4953000" cy="285750"/>
+          </a:xfrm>
+          <a:prstGeom prst="rect">
+            <a:avLst/>
+          </a:prstGeom>
+          <a:noFill/>
+        </p:spPr>
+        <p:txBody>
+          <a:bodyPr wrap="square" lIns="0" rIns="0" tIns="0" bIns="0" anchor="ctr">
+            <a:spAutoFit/>
+          </a:bodyPr>
+          <a:lstStyle/>
+          <a:p>
+            <a:pPr algn="l">
+              <a:lnSpc>
+                <a:spcPct val="122000"/>
+              </a:lnSpc>
+            </a:pPr>
+            <a:r>
+              <a:rPr sz="1800" b="1">
+                <a:solidFill>
+                  <a:srgbClr val="F5F5F8"/>
+                </a:solidFill>
+                <a:latin typeface="Amazon Ember"/>
+                <a:ea typeface="メイリオ"/>
+                <a:cs typeface="メイリオ"/>
+              </a:rPr>
+              <a:t>peer on the same node</a:t>
+            </a:r>
+          </a:p>
+        </p:txBody>
+      </p:sp>
+      <p:sp>
+        <p:nvSpPr>
+          <p:cNvPr id="20" name="Rounded Rectangle 19"/>
+          <p:cNvSpPr/>
+          <p:nvPr/>
+        </p:nvSpPr>
+        <p:spPr>
+          <a:xfrm>
+            <a:off x="6734175" y="1666875"/>
+            <a:ext cx="2095500" cy="571500"/>
+          </a:xfrm>
+          <a:prstGeom prst="roundRect">
+            <a:avLst>
+              <a:gd name="adj" fmla="val 10000"/>
+            </a:avLst>
+          </a:prstGeom>
+          <a:solidFill>
+            <a:srgbClr val="124022"/>
+          </a:solidFill>
+          <a:ln w="15875">
+            <a:solidFill>
+              <a:srgbClr val="24A046"/>
+            </a:solidFill>
+          </a:ln>
+          <a:effectLst/>
+        </p:spPr>
+        <p:style>
+          <a:lnRef idx="1">
+            <a:schemeClr val="accent1"/>
+          </a:lnRef>
+          <a:fillRef idx="3">
+            <a:schemeClr val="accent1"/>
+          </a:fillRef>
+          <a:effectRef idx="2">
+            <a:schemeClr val="accent1"/>
+          </a:effectRef>
+          <a:fontRef idx="minor">
+            <a:schemeClr val="lt1"/>
+          </a:fontRef>
+        </p:style>
+        <p:txBody>
+          <a:bodyPr rtlCol="0" anchor="ctr" wrap="square" lIns="19050" rIns="19050" tIns="19050" bIns="19050"/>
+          <a:lstStyle/>
+          <a:p>
+            <a:pPr algn="ctr">
+              <a:lnSpc>
+                <a:spcPct val="122000"/>
+              </a:lnSpc>
+            </a:pPr>
+            <a:r>
+              <a:rPr sz="1500" b="1">
+                <a:solidFill>
+                  <a:srgbClr val="F5F5F8"/>
+                </a:solidFill>
+                <a:latin typeface="Amazon Ember"/>
+                <a:ea typeface="メイリオ"/>
+                <a:cs typeface="メイリオ"/>
+              </a:rPr>
+              <a:t>GPU of process A</a:t>
+            </a:r>
+          </a:p>
+        </p:txBody>
+      </p:sp>
+      <p:sp>
+        <p:nvSpPr>
+          <p:cNvPr id="21" name="Rounded Rectangle 20"/>
+          <p:cNvSpPr/>
+          <p:nvPr/>
+        </p:nvSpPr>
+        <p:spPr>
+          <a:xfrm>
+            <a:off x="9401175" y="1666875"/>
+            <a:ext cx="2095500" cy="571500"/>
+          </a:xfrm>
+          <a:prstGeom prst="roundRect">
+            <a:avLst>
+              <a:gd name="adj" fmla="val 10000"/>
+            </a:avLst>
+          </a:prstGeom>
+          <a:solidFill>
+            <a:srgbClr val="124022"/>
+          </a:solidFill>
+          <a:ln w="15875">
+            <a:solidFill>
+              <a:srgbClr val="24A046"/>
+            </a:solidFill>
+          </a:ln>
+          <a:effectLst/>
+        </p:spPr>
+        <p:style>
+          <a:lnRef idx="1">
+            <a:schemeClr val="accent1"/>
+          </a:lnRef>
+          <a:fillRef idx="3">
+            <a:schemeClr val="accent1"/>
+          </a:fillRef>
+          <a:effectRef idx="2">
+            <a:schemeClr val="accent1"/>
+          </a:effectRef>
+          <a:fontRef idx="minor">
+            <a:schemeClr val="lt1"/>
+          </a:fontRef>
+        </p:style>
+        <p:txBody>
+          <a:bodyPr rtlCol="0" anchor="ctr" wrap="square" lIns="19050" rIns="19050" tIns="19050" bIns="19050"/>
+          <a:lstStyle/>
+          <a:p>
+            <a:pPr algn="ctr">
+              <a:lnSpc>
+                <a:spcPct val="122000"/>
+              </a:lnSpc>
+            </a:pPr>
+            <a:r>
+              <a:rPr sz="1500" b="1">
+                <a:solidFill>
+                  <a:srgbClr val="F5F5F8"/>
+                </a:solidFill>
+                <a:latin typeface="Amazon Ember"/>
+                <a:ea typeface="メイリオ"/>
+                <a:cs typeface="メイリオ"/>
+              </a:rPr>
+              <a:t>GPU of process B</a:t>
+            </a:r>
+          </a:p>
+        </p:txBody>
+      </p:sp>
+      <p:sp>
+        <p:nvSpPr>
+          <p:cNvPr id="22" name="Rounded Rectangle 21"/>
+          <p:cNvSpPr/>
+          <p:nvPr/>
+        </p:nvSpPr>
+        <p:spPr>
+          <a:xfrm>
+            <a:off x="6734175" y="2571750"/>
+            <a:ext cx="4762500" cy="514350"/>
+          </a:xfrm>
+          <a:prstGeom prst="roundRect">
+            <a:avLst>
+              <a:gd name="adj" fmla="val 10000"/>
+            </a:avLst>
+          </a:prstGeom>
+          <a:solidFill>
+            <a:srgbClr val="102C48"/>
+          </a:solidFill>
+          <a:ln w="15875">
+            <a:solidFill>
+              <a:srgbClr val="2896F0"/>
+            </a:solidFill>
+          </a:ln>
+          <a:effectLst/>
+        </p:spPr>
+        <p:style>
+          <a:lnRef idx="1">
+            <a:schemeClr val="accent1"/>
+          </a:lnRef>
+          <a:fillRef idx="3">
+            <a:schemeClr val="accent1"/>
+          </a:fillRef>
+          <a:effectRef idx="2">
+            <a:schemeClr val="accent1"/>
+          </a:effectRef>
+          <a:fontRef idx="minor">
+            <a:schemeClr val="lt1"/>
+          </a:fontRef>
+        </p:style>
+        <p:txBody>
+          <a:bodyPr rtlCol="0" anchor="ctr" wrap="square" lIns="19050" rIns="19050" tIns="19050" bIns="19050"/>
+          <a:lstStyle/>
+          <a:p>
+            <a:pPr algn="ctr">
+              <a:lnSpc>
+                <a:spcPct val="122000"/>
+              </a:lnSpc>
+            </a:pPr>
+            <a:r>
+              <a:rPr sz="1500" b="1">
+                <a:solidFill>
+                  <a:srgbClr val="F5F5F8"/>
+                </a:solidFill>
+                <a:latin typeface="Amazon Ember"/>
+                <a:ea typeface="メイリオ"/>
+                <a:cs typeface="メイリオ"/>
+              </a:rPr>
+              <a:t>efa provider: the peer is local</a:t>
+            </a:r>
+          </a:p>
+        </p:txBody>
+      </p:sp>
+      <p:sp>
+        <p:nvSpPr>
+          <p:cNvPr id="23" name="Rounded Rectangle 22"/>
+          <p:cNvSpPr/>
+          <p:nvPr/>
+        </p:nvSpPr>
+        <p:spPr>
+          <a:xfrm>
+            <a:off x="6734175" y="3524250"/>
+            <a:ext cx="2286000" cy="1047750"/>
+          </a:xfrm>
+          <a:prstGeom prst="roundRect">
+            <a:avLst>
+              <a:gd name="adj" fmla="val 10000"/>
+            </a:avLst>
+          </a:prstGeom>
+          <a:solidFill>
+            <a:srgbClr val="50420E"/>
+          </a:solidFill>
+          <a:ln w="15875">
+            <a:solidFill>
+              <a:srgbClr val="FBD332"/>
+            </a:solidFill>
+          </a:ln>
+          <a:effectLst/>
+        </p:spPr>
+        <p:style>
+          <a:lnRef idx="1">
+            <a:schemeClr val="accent1"/>
+          </a:lnRef>
+          <a:fillRef idx="3">
+            <a:schemeClr val="accent1"/>
+          </a:fillRef>
+          <a:effectRef idx="2">
+            <a:schemeClr val="accent1"/>
+          </a:effectRef>
+          <a:fontRef idx="minor">
+            <a:schemeClr val="lt1"/>
+          </a:fontRef>
+        </p:style>
+        <p:txBody>
+          <a:bodyPr rtlCol="0" anchor="ctr" wrap="square" lIns="19050" rIns="19050" tIns="19050" bIns="19050"/>
+          <a:lstStyle/>
+          <a:p>
+            <a:pPr algn="ctr">
+              <a:lnSpc>
+                <a:spcPct val="122000"/>
+              </a:lnSpc>
+            </a:pPr>
+            <a:r>
+              <a:rPr sz="1500" b="1">
+                <a:solidFill>
+                  <a:srgbClr val="F5F5F8"/>
+                </a:solidFill>
+                <a:latin typeface="Amazon Ember"/>
+                <a:ea typeface="メイリオ"/>
+                <a:cs typeface="メイリオ"/>
+              </a:rPr>
+              <a:t>default (=1)</a:t>
+            </a:r>
+          </a:p>
+          <a:p>
+            <a:pPr algn="ctr">
+              <a:lnSpc>
+                <a:spcPct val="122000"/>
+              </a:lnSpc>
+            </a:pPr>
+            <a:r>
+              <a:rPr sz="1500" b="1">
+                <a:solidFill>
+                  <a:srgbClr val="F5F5F8"/>
+                </a:solidFill>
+                <a:latin typeface="Amazon Ember"/>
+                <a:ea typeface="メイリオ"/>
+                <a:cs typeface="メイリオ"/>
+              </a:rPr>
+              <a:t>shm provider</a:t>
+            </a:r>
+          </a:p>
+          <a:p>
+            <a:pPr algn="ctr">
+              <a:lnSpc>
+                <a:spcPct val="122000"/>
+              </a:lnSpc>
+            </a:pPr>
+            <a:r>
+              <a:rPr sz="1500" b="1">
+                <a:solidFill>
+                  <a:srgbClr val="F5F5F8"/>
+                </a:solidFill>
+                <a:latin typeface="Amazon Ember"/>
+                <a:ea typeface="メイリオ"/>
+                <a:cs typeface="メイリオ"/>
+              </a:rPr>
+              <a:t>CUDA IPC or SAR</a:t>
+            </a:r>
+          </a:p>
+        </p:txBody>
+      </p:sp>
+      <p:sp>
+        <p:nvSpPr>
+          <p:cNvPr id="24" name="Rounded Rectangle 23"/>
+          <p:cNvSpPr/>
+          <p:nvPr/>
+        </p:nvSpPr>
+        <p:spPr>
+          <a:xfrm>
+            <a:off x="9210675" y="3524250"/>
+            <a:ext cx="2286000" cy="1047750"/>
+          </a:xfrm>
+          <a:prstGeom prst="roundRect">
+            <a:avLst>
+              <a:gd name="adj" fmla="val 10000"/>
+            </a:avLst>
+          </a:prstGeom>
+          <a:solidFill>
+            <a:srgbClr val="124022"/>
+          </a:solidFill>
+          <a:ln w="15875">
+            <a:solidFill>
+              <a:srgbClr val="3BD16F"/>
+            </a:solidFill>
+          </a:ln>
+          <a:effectLst/>
+        </p:spPr>
+        <p:style>
+          <a:lnRef idx="1">
+            <a:schemeClr val="accent1"/>
+          </a:lnRef>
+          <a:fillRef idx="3">
+            <a:schemeClr val="accent1"/>
+          </a:fillRef>
+          <a:effectRef idx="2">
+            <a:schemeClr val="accent1"/>
+          </a:effectRef>
+          <a:fontRef idx="minor">
+            <a:schemeClr val="lt1"/>
+          </a:fontRef>
+        </p:style>
+        <p:txBody>
+          <a:bodyPr rtlCol="0" anchor="ctr" wrap="square" lIns="19050" rIns="19050" tIns="19050" bIns="19050"/>
+          <a:lstStyle/>
+          <a:p>
+            <a:pPr algn="ctr">
+              <a:lnSpc>
+                <a:spcPct val="122000"/>
+              </a:lnSpc>
+            </a:pPr>
+            <a:r>
+              <a:rPr sz="1500" b="1">
+                <a:solidFill>
+                  <a:srgbClr val="F5F5F8"/>
+                </a:solidFill>
+                <a:latin typeface="Amazon Ember"/>
+                <a:ea typeface="メイリオ"/>
+                <a:cs typeface="メイリオ"/>
+              </a:rPr>
+              <a:t>=0</a:t>
+            </a:r>
+          </a:p>
+          <a:p>
+            <a:pPr algn="ctr">
+              <a:lnSpc>
+                <a:spcPct val="122000"/>
+              </a:lnSpc>
+            </a:pPr>
+            <a:r>
+              <a:rPr sz="1500" b="1">
+                <a:solidFill>
+                  <a:srgbClr val="F5F5F8"/>
+                </a:solidFill>
+                <a:latin typeface="Amazon Ember"/>
+                <a:ea typeface="メイリオ"/>
+                <a:cs typeface="メイリオ"/>
+              </a:rPr>
+              <a:t>EFA device</a:t>
+            </a:r>
+          </a:p>
+          <a:p>
+            <a:pPr algn="ctr">
+              <a:lnSpc>
+                <a:spcPct val="122000"/>
+              </a:lnSpc>
+            </a:pPr>
+            <a:r>
+              <a:rPr sz="1500" b="1">
+                <a:solidFill>
+                  <a:srgbClr val="F5F5F8"/>
+                </a:solidFill>
+                <a:latin typeface="Amazon Ember"/>
+                <a:ea typeface="メイリオ"/>
+                <a:cs typeface="メイリオ"/>
+              </a:rPr>
+              <a:t>(measured: RDMA write)</a:t>
+            </a:r>
+          </a:p>
+        </p:txBody>
+      </p:sp>
+      <p:cxnSp>
+        <p:nvCxnSpPr>
+          <p:cNvPr id="25" name="Connector 24"/>
+          <p:cNvCxnSpPr/>
+          <p:nvPr/>
+        </p:nvCxnSpPr>
+        <p:spPr>
+          <a:xfrm>
+            <a:off x="7781925" y="2238375"/>
+            <a:ext cx="0" cy="333375"/>
+          </a:xfrm>
+          <a:prstGeom prst="line">
+            <a:avLst/>
+          </a:prstGeom>
+          <a:ln w="25400">
+            <a:solidFill>
+              <a:srgbClr val="F5F5F8"/>
+            </a:solidFill>
+            <a:tailEnd type="triangle" w="med" len="med"/>
+          </a:ln>
+          <a:effectLst/>
+        </p:spPr>
+        <p:style>
+          <a:lnRef idx="2">
+            <a:schemeClr val="accent1"/>
+          </a:lnRef>
+          <a:fillRef idx="0">
+            <a:schemeClr val="accent1"/>
+          </a:fillRef>
+          <a:effectRef idx="1">
+            <a:schemeClr val="accent1"/>
+          </a:effectRef>
+          <a:fontRef idx="minor">
+            <a:schemeClr val="tx1"/>
+          </a:fontRef>
+        </p:style>
+      </p:cxnSp>
+      <p:cxnSp>
+        <p:nvCxnSpPr>
+          <p:cNvPr id="26" name="Connector 25"/>
+          <p:cNvCxnSpPr/>
+          <p:nvPr/>
+        </p:nvCxnSpPr>
+        <p:spPr>
+          <a:xfrm>
+            <a:off x="7877175" y="3086100"/>
+            <a:ext cx="0" cy="438150"/>
+          </a:xfrm>
+          <a:prstGeom prst="line">
+            <a:avLst/>
+          </a:prstGeom>
+          <a:ln w="31750">
+            <a:solidFill>
+              <a:srgbClr val="FBD332"/>
+            </a:solidFill>
+            <a:tailEnd type="triangle" w="med" len="med"/>
+          </a:ln>
+          <a:effectLst/>
+        </p:spPr>
+        <p:style>
+          <a:lnRef idx="2">
+            <a:schemeClr val="accent1"/>
+          </a:lnRef>
+          <a:fillRef idx="0">
+            <a:schemeClr val="accent1"/>
+          </a:fillRef>
+          <a:effectRef idx="1">
+            <a:schemeClr val="accent1"/>
+          </a:effectRef>
+          <a:fontRef idx="minor">
+            <a:schemeClr val="tx1"/>
+          </a:fontRef>
+        </p:style>
+      </p:cxnSp>
+      <p:cxnSp>
+        <p:nvCxnSpPr>
+          <p:cNvPr id="27" name="Connector 26"/>
+          <p:cNvCxnSpPr/>
+          <p:nvPr/>
+        </p:nvCxnSpPr>
+        <p:spPr>
+          <a:xfrm>
+            <a:off x="10353675" y="3086100"/>
+            <a:ext cx="0" cy="438150"/>
+          </a:xfrm>
+          <a:prstGeom prst="line">
+            <a:avLst/>
+          </a:prstGeom>
+          <a:ln w="31750">
+            <a:solidFill>
+              <a:srgbClr val="3BD16F"/>
+            </a:solidFill>
+            <a:tailEnd type="triangle" w="med" len="med"/>
+          </a:ln>
+          <a:effectLst/>
+        </p:spPr>
+        <p:style>
+          <a:lnRef idx="2">
+            <a:schemeClr val="accent1"/>
+          </a:lnRef>
+          <a:fillRef idx="0">
+            <a:schemeClr val="accent1"/>
+          </a:fillRef>
+          <a:effectRef idx="1">
+            <a:schemeClr val="accent1"/>
+          </a:effectRef>
+          <a:fontRef idx="minor">
+            <a:schemeClr val="tx1"/>
+          </a:fontRef>
+        </p:style>
+      </p:cxnSp>
+      <p:sp>
+        <p:nvSpPr>
+          <p:cNvPr id="28" name="TextBox 27"/>
+          <p:cNvSpPr txBox="1"/>
+          <p:nvPr/>
+        </p:nvSpPr>
+        <p:spPr>
+          <a:xfrm>
+            <a:off x="6734175" y="4714875"/>
+            <a:ext cx="4762500" cy="571500"/>
+          </a:xfrm>
+          <a:prstGeom prst="rect">
+            <a:avLst/>
+          </a:prstGeom>
+          <a:noFill/>
+        </p:spPr>
+        <p:txBody>
+          <a:bodyPr wrap="square" lIns="0" rIns="0" tIns="0" bIns="0" anchor="ctr">
+            <a:spAutoFit/>
+          </a:bodyPr>
+          <a:lstStyle/>
+          <a:p>
+            <a:pPr algn="ctr">
+              <a:lnSpc>
+                <a:spcPct val="122000"/>
+              </a:lnSpc>
+            </a:pPr>
+            <a:r>
+              <a:rPr sz="1500" b="0">
+                <a:solidFill>
+                  <a:srgbClr val="FBD332"/>
+                </a:solidFill>
+                <a:latin typeface="Amazon Ember"/>
+                <a:ea typeface="メイリオ"/>
+                <a:cs typeface="メイリオ"/>
+              </a:rPr>
+              <a:t>FI_EFA_ENABLE_SHM_TRANSFER</a:t>
+            </a:r>
+          </a:p>
+          <a:p>
+            <a:pPr algn="ctr">
+              <a:lnSpc>
+                <a:spcPct val="122000"/>
+              </a:lnSpc>
+            </a:pPr>
+            <a:r>
+              <a:rPr sz="1500" b="0">
+                <a:solidFill>
+                  <a:srgbClr val="FBD332"/>
+                </a:solidFill>
+                <a:latin typeface="Amazon Ember"/>
+                <a:ea typeface="メイリオ"/>
+                <a:cs typeface="メイリオ"/>
+              </a:rPr>
+              <a:t>decides which one</a:t>
+            </a:r>
+          </a:p>
+        </p:txBody>
+      </p:sp>
+    </p:spTree>
+  </p:cSld>
+  <p:clrMapOvr>
+    <a:masterClrMapping/>
+  </p:clrMapOvr>
+</p:sld>
+</file>
+
+<file path=ppt/slides/slide11.xml><?xml version="1.0" encoding="utf-8"?>
+<p:sld xmlns:a="http://schemas.openxmlformats.org/drawingml/2006/main" xmlns:p="http://schemas.openxmlformats.org/presentationml/2006/main" xmlns:r="http://schemas.openxmlformats.org/officeDocument/2006/relationships" showMasterSp="0">
+  <p:cSld>
+    <p:spTree>
+      <p:nvGrpSpPr>
+        <p:cNvPr id="1" name=""/>
+        <p:cNvGrpSpPr/>
+        <p:nvPr/>
+      </p:nvGrpSpPr>
+      <p:grpSpPr/>
+      <p:sp>
+        <p:nvSpPr>
+          <p:cNvPr id="2" name="TextBox 1"/>
+          <p:cNvSpPr txBox="1"/>
+          <p:nvPr/>
+        </p:nvSpPr>
+        <p:spPr>
+          <a:xfrm>
+            <a:off x="409575" y="247650"/>
+            <a:ext cx="11334750" cy="438150"/>
+          </a:xfrm>
+          <a:prstGeom prst="rect">
+            <a:avLst/>
+          </a:prstGeom>
+          <a:noFill/>
+        </p:spPr>
+        <p:txBody>
+          <a:bodyPr wrap="square" lIns="0" rIns="0" tIns="0" bIns="0" anchor="ctr">
+            <a:spAutoFit/>
+          </a:bodyPr>
+          <a:lstStyle/>
+          <a:p>
+            <a:pPr algn="l">
+              <a:lnSpc>
+                <a:spcPct val="122000"/>
+              </a:lnSpc>
+            </a:pPr>
+            <a:r>
+              <a:rPr sz="3000" b="1">
+                <a:solidFill>
+                  <a:srgbClr val="F5F5F8"/>
+                </a:solidFill>
+                <a:latin typeface="Amazon Ember"/>
+                <a:ea typeface="メイリオ"/>
+                <a:cs typeface="メイリオ"/>
+              </a:rPr>
+              <a:t>shm provider</a:t>
+            </a:r>
+          </a:p>
+        </p:txBody>
+      </p:sp>
+      <p:sp>
+        <p:nvSpPr>
+          <p:cNvPr id="3" name="TextBox 2"/>
+          <p:cNvSpPr txBox="1"/>
+          <p:nvPr/>
+        </p:nvSpPr>
+        <p:spPr>
+          <a:xfrm>
+            <a:off x="409575" y="685800"/>
+            <a:ext cx="11334750" cy="247650"/>
+          </a:xfrm>
+          <a:prstGeom prst="rect">
+            <a:avLst/>
+          </a:prstGeom>
+          <a:noFill/>
+        </p:spPr>
+        <p:txBody>
+          <a:bodyPr wrap="square" lIns="0" rIns="0" tIns="0" bIns="0" anchor="ctr">
+            <a:spAutoFit/>
+          </a:bodyPr>
+          <a:lstStyle/>
+          <a:p>
+            <a:pPr algn="l">
+              <a:lnSpc>
+                <a:spcPct val="122000"/>
+              </a:lnSpc>
+            </a:pPr>
+            <a:r>
+              <a:rPr sz="1600" b="0">
+                <a:solidFill>
+                  <a:srgbClr val="96969E"/>
+                </a:solidFill>
+                <a:latin typeface="Amazon Ember"/>
+                <a:ea typeface="メイリオ"/>
+                <a:cs typeface="メイリオ"/>
+              </a:rPr>
+              <a:t>Commands and responses go through regions of host memory; how the data moves depends on the protocol</a:t>
+            </a:r>
+          </a:p>
+        </p:txBody>
+      </p:sp>
+      <p:sp>
+        <p:nvSpPr>
+          <p:cNvPr id="4" name="Rounded Rectangle 3"/>
+          <p:cNvSpPr/>
+          <p:nvPr/>
+        </p:nvSpPr>
+        <p:spPr>
+          <a:xfrm>
+            <a:off x="409575" y="1428750"/>
+            <a:ext cx="2857500" cy="1047750"/>
+          </a:xfrm>
+          <a:prstGeom prst="roundRect">
+            <a:avLst>
+              <a:gd name="adj" fmla="val 10000"/>
+            </a:avLst>
+          </a:prstGeom>
+          <a:solidFill>
+            <a:srgbClr val="124022"/>
+          </a:solidFill>
+          <a:ln w="15875">
+            <a:solidFill>
+              <a:srgbClr val="24A046"/>
+            </a:solidFill>
+          </a:ln>
+          <a:effectLst/>
+        </p:spPr>
+        <p:style>
+          <a:lnRef idx="1">
+            <a:schemeClr val="accent1"/>
+          </a:lnRef>
+          <a:fillRef idx="3">
+            <a:schemeClr val="accent1"/>
+          </a:fillRef>
+          <a:effectRef idx="2">
+            <a:schemeClr val="accent1"/>
+          </a:effectRef>
+          <a:fontRef idx="minor">
+            <a:schemeClr val="lt1"/>
+          </a:fontRef>
+        </p:style>
+        <p:txBody>
+          <a:bodyPr rtlCol="0" anchor="ctr" wrap="square" lIns="19050" rIns="19050" tIns="19050" bIns="19050"/>
+          <a:lstStyle/>
+          <a:p>
+            <a:pPr algn="ctr">
+              <a:lnSpc>
+                <a:spcPct val="122000"/>
+              </a:lnSpc>
+            </a:pPr>
+            <a:r>
+              <a:rPr sz="1700" b="1">
+                <a:solidFill>
+                  <a:srgbClr val="F5F5F8"/>
+                </a:solidFill>
+                <a:latin typeface="Amazon Ember"/>
+                <a:ea typeface="メイリオ"/>
+                <a:cs typeface="メイリオ"/>
+              </a:rPr>
+              <a:t>process A</a:t>
+            </a:r>
+          </a:p>
+          <a:p>
+            <a:pPr algn="ctr">
+              <a:lnSpc>
+                <a:spcPct val="122000"/>
+              </a:lnSpc>
+            </a:pPr>
+            <a:r>
+              <a:rPr sz="1700" b="1">
+                <a:solidFill>
+                  <a:srgbClr val="F5F5F8"/>
+                </a:solidFill>
+                <a:latin typeface="Amazon Ember"/>
+                <a:ea typeface="メイリオ"/>
+                <a:cs typeface="メイリオ"/>
+              </a:rPr>
+              <a:t>(sender)</a:t>
+            </a:r>
+          </a:p>
+        </p:txBody>
+      </p:sp>
+      <p:sp>
+        <p:nvSpPr>
+          <p:cNvPr id="5" name="Rounded Rectangle 4"/>
+          <p:cNvSpPr/>
+          <p:nvPr/>
+        </p:nvSpPr>
+        <p:spPr>
+          <a:xfrm>
+            <a:off x="8924925" y="1428750"/>
+            <a:ext cx="2857500" cy="1047750"/>
+          </a:xfrm>
+          <a:prstGeom prst="roundRect">
+            <a:avLst>
+              <a:gd name="adj" fmla="val 10000"/>
+            </a:avLst>
+          </a:prstGeom>
+          <a:solidFill>
+            <a:srgbClr val="102C48"/>
+          </a:solidFill>
+          <a:ln w="15875">
+            <a:solidFill>
+              <a:srgbClr val="2896F0"/>
+            </a:solidFill>
+          </a:ln>
+          <a:effectLst/>
+        </p:spPr>
+        <p:style>
+          <a:lnRef idx="1">
+            <a:schemeClr val="accent1"/>
+          </a:lnRef>
+          <a:fillRef idx="3">
+            <a:schemeClr val="accent1"/>
+          </a:fillRef>
+          <a:effectRef idx="2">
+            <a:schemeClr val="accent1"/>
+          </a:effectRef>
+          <a:fontRef idx="minor">
+            <a:schemeClr val="lt1"/>
+          </a:fontRef>
+        </p:style>
+        <p:txBody>
+          <a:bodyPr rtlCol="0" anchor="ctr" wrap="square" lIns="19050" rIns="19050" tIns="19050" bIns="19050"/>
+          <a:lstStyle/>
+          <a:p>
+            <a:pPr algn="ctr">
+              <a:lnSpc>
+                <a:spcPct val="122000"/>
+              </a:lnSpc>
+            </a:pPr>
+            <a:r>
+              <a:rPr sz="1700" b="1">
+                <a:solidFill>
+                  <a:srgbClr val="F5F5F8"/>
+                </a:solidFill>
+                <a:latin typeface="Amazon Ember"/>
+                <a:ea typeface="メイリオ"/>
+                <a:cs typeface="メイリオ"/>
+              </a:rPr>
+              <a:t>process B</a:t>
+            </a:r>
+          </a:p>
+          <a:p>
+            <a:pPr algn="ctr">
+              <a:lnSpc>
+                <a:spcPct val="122000"/>
+              </a:lnSpc>
+            </a:pPr>
+            <a:r>
+              <a:rPr sz="1700" b="1">
+                <a:solidFill>
+                  <a:srgbClr val="F5F5F8"/>
+                </a:solidFill>
+                <a:latin typeface="Amazon Ember"/>
+                <a:ea typeface="メイリオ"/>
+                <a:cs typeface="メイリオ"/>
+              </a:rPr>
+              <a:t>(receiver)</a:t>
+            </a:r>
+          </a:p>
+        </p:txBody>
+      </p:sp>
+      <p:sp>
+        <p:nvSpPr>
+          <p:cNvPr id="6" name="Rounded Rectangle 5"/>
+          <p:cNvSpPr/>
+          <p:nvPr/>
+        </p:nvSpPr>
+        <p:spPr>
+          <a:xfrm>
+            <a:off x="3838575" y="1143000"/>
+            <a:ext cx="4514850" cy="1905000"/>
+          </a:xfrm>
+          <a:prstGeom prst="roundRect">
+            <a:avLst>
+              <a:gd name="adj" fmla="val 5000"/>
+            </a:avLst>
+          </a:prstGeom>
+          <a:solidFill>
+            <a:srgbClr val="161A1E"/>
+          </a:solidFill>
+          <a:ln w="15875">
+            <a:solidFill>
+              <a:srgbClr val="FBD332"/>
+            </a:solidFill>
+          </a:ln>
+          <a:effectLst/>
+        </p:spPr>
+        <p:style>
+          <a:lnRef idx="1">
+            <a:schemeClr val="accent1"/>
+          </a:lnRef>
+          <a:fillRef idx="3">
+            <a:schemeClr val="accent1"/>
+          </a:fillRef>
+          <a:effectRef idx="2">
+            <a:schemeClr val="accent1"/>
+          </a:effectRef>
+          <a:fontRef idx="minor">
+            <a:schemeClr val="lt1"/>
+          </a:fontRef>
+        </p:style>
+        <p:txBody>
+          <a:bodyPr rtlCol="0" anchor="ctr"/>
+          <a:lstStyle/>
+          <a:p>
+            <a:pPr algn="ctr"/>
+          </a:p>
+        </p:txBody>
+      </p:sp>
+      <p:sp>
+        <p:nvSpPr>
+          <p:cNvPr id="7" name="TextBox 6"/>
+          <p:cNvSpPr txBox="1"/>
+          <p:nvPr/>
+        </p:nvSpPr>
+        <p:spPr>
+          <a:xfrm>
+            <a:off x="3933825" y="1219200"/>
+            <a:ext cx="4324350" cy="285750"/>
+          </a:xfrm>
+          <a:prstGeom prst="rect">
+            <a:avLst/>
+          </a:prstGeom>
+          <a:noFill/>
+        </p:spPr>
+        <p:txBody>
+          <a:bodyPr wrap="square" lIns="0" rIns="0" tIns="0" bIns="0" anchor="ctr">
+            <a:spAutoFit/>
+          </a:bodyPr>
+          <a:lstStyle/>
+          <a:p>
+            <a:pPr algn="ctr">
+              <a:lnSpc>
+                <a:spcPct val="122000"/>
+              </a:lnSpc>
+            </a:pPr>
+            <a:r>
+              <a:rPr sz="1500" b="0">
+                <a:solidFill>
+                  <a:srgbClr val="FBD332"/>
+                </a:solidFill>
+                <a:latin typeface="Amazon Ember"/>
+                <a:ea typeface="メイリオ"/>
+                <a:cs typeface="メイリオ"/>
+              </a:rPr>
+              <a:t>receiver's region in host memory</a:t>
+            </a:r>
+          </a:p>
+        </p:txBody>
+      </p:sp>
+      <p:sp>
+        <p:nvSpPr>
+          <p:cNvPr id="8" name="Rounded Rectangle 7"/>
+          <p:cNvSpPr/>
+          <p:nvPr/>
+        </p:nvSpPr>
+        <p:spPr>
+          <a:xfrm>
+            <a:off x="4124325" y="1571625"/>
+            <a:ext cx="3943350" cy="571500"/>
+          </a:xfrm>
+          <a:prstGeom prst="roundRect">
+            <a:avLst>
+              <a:gd name="adj" fmla="val 10000"/>
+            </a:avLst>
+          </a:prstGeom>
+          <a:solidFill>
+            <a:srgbClr val="343840"/>
+          </a:solidFill>
+          <a:ln w="15875">
+            <a:solidFill>
+              <a:srgbClr val="464A50"/>
+            </a:solidFill>
+          </a:ln>
+          <a:effectLst/>
+        </p:spPr>
+        <p:style>
+          <a:lnRef idx="1">
+            <a:schemeClr val="accent1"/>
+          </a:lnRef>
+          <a:fillRef idx="3">
+            <a:schemeClr val="accent1"/>
+          </a:fillRef>
+          <a:effectRef idx="2">
+            <a:schemeClr val="accent1"/>
+          </a:effectRef>
+          <a:fontRef idx="minor">
+            <a:schemeClr val="lt1"/>
+          </a:fontRef>
+        </p:style>
+        <p:txBody>
+          <a:bodyPr rtlCol="0" anchor="ctr" wrap="square" lIns="19050" rIns="19050" tIns="19050" bIns="19050"/>
+          <a:lstStyle/>
+          <a:p>
+            <a:pPr algn="ctr">
+              <a:lnSpc>
+                <a:spcPct val="122000"/>
+              </a:lnSpc>
+            </a:pPr>
+            <a:r>
+              <a:rPr sz="1500" b="1">
+                <a:solidFill>
+                  <a:srgbClr val="F5F5F8"/>
+                </a:solidFill>
+                <a:latin typeface="Amazon Ember"/>
+                <a:ea typeface="メイリオ"/>
+                <a:cs typeface="メイリオ"/>
+              </a:rPr>
+              <a:t>command queue</a:t>
+            </a:r>
+          </a:p>
+        </p:txBody>
+      </p:sp>
+      <p:sp>
+        <p:nvSpPr>
+          <p:cNvPr id="9" name="Rounded Rectangle 8"/>
+          <p:cNvSpPr/>
+          <p:nvPr/>
+        </p:nvSpPr>
+        <p:spPr>
+          <a:xfrm>
+            <a:off x="4124325" y="2286000"/>
+            <a:ext cx="3943350" cy="571500"/>
+          </a:xfrm>
+          <a:prstGeom prst="roundRect">
+            <a:avLst>
+              <a:gd name="adj" fmla="val 10000"/>
+            </a:avLst>
+          </a:prstGeom>
+          <a:solidFill>
+            <a:srgbClr val="343840"/>
+          </a:solidFill>
+          <a:ln w="15875">
+            <a:solidFill>
+              <a:srgbClr val="464A50"/>
+            </a:solidFill>
+          </a:ln>
+          <a:effectLst/>
+        </p:spPr>
+        <p:style>
+          <a:lnRef idx="1">
+            <a:schemeClr val="accent1"/>
+          </a:lnRef>
+          <a:fillRef idx="3">
+            <a:schemeClr val="accent1"/>
+          </a:fillRef>
+          <a:effectRef idx="2">
+            <a:schemeClr val="accent1"/>
+          </a:effectRef>
+          <a:fontRef idx="minor">
+            <a:schemeClr val="lt1"/>
+          </a:fontRef>
+        </p:style>
+        <p:txBody>
+          <a:bodyPr rtlCol="0" anchor="ctr" wrap="square" lIns="19050" rIns="19050" tIns="19050" bIns="19050"/>
+          <a:lstStyle/>
+          <a:p>
+            <a:pPr algn="ctr">
+              <a:lnSpc>
+                <a:spcPct val="122000"/>
+              </a:lnSpc>
+            </a:pPr>
+            <a:r>
+              <a:rPr sz="1500" b="1">
+                <a:solidFill>
+                  <a:srgbClr val="F5F5F8"/>
+                </a:solidFill>
+                <a:latin typeface="Amazon Ember"/>
+                <a:ea typeface="メイリオ"/>
+                <a:cs typeface="メイリオ"/>
+              </a:rPr>
+              <a:t>SAR bounce buffers</a:t>
+            </a:r>
+          </a:p>
+        </p:txBody>
+      </p:sp>
+      <p:cxnSp>
+        <p:nvCxnSpPr>
+          <p:cNvPr id="10" name="Connector 9"/>
+          <p:cNvCxnSpPr/>
+          <p:nvPr/>
+        </p:nvCxnSpPr>
+        <p:spPr>
+          <a:xfrm>
+            <a:off x="3267075" y="1857375"/>
+            <a:ext cx="857250" cy="0"/>
+          </a:xfrm>
+          <a:prstGeom prst="line">
+            <a:avLst/>
+          </a:prstGeom>
+          <a:ln w="31750">
+            <a:solidFill>
+              <a:srgbClr val="FBD332"/>
+            </a:solidFill>
+            <a:tailEnd type="triangle" w="med" len="med"/>
+          </a:ln>
+          <a:effectLst/>
+        </p:spPr>
+        <p:style>
+          <a:lnRef idx="2">
+            <a:schemeClr val="accent1"/>
+          </a:lnRef>
+          <a:fillRef idx="0">
+            <a:schemeClr val="accent1"/>
+          </a:fillRef>
+          <a:effectRef idx="1">
+            <a:schemeClr val="accent1"/>
+          </a:effectRef>
+          <a:fontRef idx="minor">
+            <a:schemeClr val="tx1"/>
+          </a:fontRef>
+        </p:style>
+      </p:cxnSp>
+      <p:cxnSp>
+        <p:nvCxnSpPr>
+          <p:cNvPr id="11" name="Connector 10"/>
+          <p:cNvCxnSpPr/>
+          <p:nvPr/>
+        </p:nvCxnSpPr>
+        <p:spPr>
+          <a:xfrm>
+            <a:off x="8067675" y="1857375"/>
+            <a:ext cx="857250" cy="0"/>
+          </a:xfrm>
+          <a:prstGeom prst="line">
+            <a:avLst/>
+          </a:prstGeom>
+          <a:ln w="31750">
+            <a:solidFill>
+              <a:srgbClr val="FBD332"/>
+            </a:solidFill>
+            <a:tailEnd type="triangle" w="med" len="med"/>
+          </a:ln>
+          <a:effectLst/>
+        </p:spPr>
+        <p:style>
+          <a:lnRef idx="2">
+            <a:schemeClr val="accent1"/>
+          </a:lnRef>
+          <a:fillRef idx="0">
+            <a:schemeClr val="accent1"/>
+          </a:fillRef>
+          <a:effectRef idx="1">
+            <a:schemeClr val="accent1"/>
+          </a:effectRef>
+          <a:fontRef idx="minor">
+            <a:schemeClr val="tx1"/>
+          </a:fontRef>
+        </p:style>
+      </p:cxnSp>
+      <p:sp>
+        <p:nvSpPr>
+          <p:cNvPr id="12" name="Rounded Rectangle 11"/>
+          <p:cNvSpPr/>
+          <p:nvPr/>
+        </p:nvSpPr>
+        <p:spPr>
+          <a:xfrm>
+            <a:off x="3838575" y="3524250"/>
+            <a:ext cx="4514850" cy="1238250"/>
+          </a:xfrm>
+          <a:prstGeom prst="roundRect">
+            <a:avLst>
+              <a:gd name="adj" fmla="val 5000"/>
+            </a:avLst>
+          </a:prstGeom>
+          <a:solidFill>
+            <a:srgbClr val="161A1E"/>
+          </a:solidFill>
+          <a:ln w="15875">
+            <a:solidFill>
+              <a:srgbClr val="464A50"/>
+            </a:solidFill>
+          </a:ln>
+          <a:effectLst/>
+        </p:spPr>
+        <p:style>
+          <a:lnRef idx="1">
+            <a:schemeClr val="accent1"/>
+          </a:lnRef>
+          <a:fillRef idx="3">
+            <a:schemeClr val="accent1"/>
+          </a:fillRef>
+          <a:effectRef idx="2">
+            <a:schemeClr val="accent1"/>
+          </a:effectRef>
+          <a:fontRef idx="minor">
+            <a:schemeClr val="lt1"/>
+          </a:fontRef>
+        </p:style>
+        <p:txBody>
+          <a:bodyPr rtlCol="0" anchor="ctr"/>
+          <a:lstStyle/>
+          <a:p>
+            <a:pPr algn="ctr"/>
+          </a:p>
+        </p:txBody>
+      </p:sp>
+      <p:sp>
+        <p:nvSpPr>
+          <p:cNvPr id="13" name="TextBox 12"/>
+          <p:cNvSpPr txBox="1"/>
+          <p:nvPr/>
+        </p:nvSpPr>
+        <p:spPr>
+          <a:xfrm>
+            <a:off x="3933825" y="3600450"/>
+            <a:ext cx="4324350" cy="285750"/>
+          </a:xfrm>
+          <a:prstGeom prst="rect">
+            <a:avLst/>
+          </a:prstGeom>
+          <a:noFill/>
+        </p:spPr>
+        <p:txBody>
+          <a:bodyPr wrap="square" lIns="0" rIns="0" tIns="0" bIns="0" anchor="ctr">
+            <a:spAutoFit/>
+          </a:bodyPr>
+          <a:lstStyle/>
+          <a:p>
+            <a:pPr algn="ctr">
+              <a:lnSpc>
+                <a:spcPct val="122000"/>
+              </a:lnSpc>
+            </a:pPr>
+            <a:r>
+              <a:rPr sz="1500" b="0">
+                <a:solidFill>
+                  <a:srgbClr val="96969E"/>
+                </a:solidFill>
+                <a:latin typeface="Amazon Ember"/>
+                <a:ea typeface="メイリオ"/>
+                <a:cs typeface="メイリオ"/>
+              </a:rPr>
+              <a:t>sender's region in host memory</a:t>
+            </a:r>
+          </a:p>
+        </p:txBody>
+      </p:sp>
+      <p:sp>
+        <p:nvSpPr>
+          <p:cNvPr id="14" name="Rounded Rectangle 13"/>
+          <p:cNvSpPr/>
+          <p:nvPr/>
+        </p:nvSpPr>
+        <p:spPr>
+          <a:xfrm>
+            <a:off x="4124325" y="3952875"/>
+            <a:ext cx="3943350" cy="571500"/>
+          </a:xfrm>
+          <a:prstGeom prst="roundRect">
+            <a:avLst>
+              <a:gd name="adj" fmla="val 10000"/>
+            </a:avLst>
+          </a:prstGeom>
+          <a:solidFill>
+            <a:srgbClr val="343840"/>
+          </a:solidFill>
+          <a:ln w="15875">
+            <a:solidFill>
+              <a:srgbClr val="464A50"/>
+            </a:solidFill>
+          </a:ln>
+          <a:effectLst/>
+        </p:spPr>
+        <p:style>
+          <a:lnRef idx="1">
+            <a:schemeClr val="accent1"/>
+          </a:lnRef>
+          <a:fillRef idx="3">
+            <a:schemeClr val="accent1"/>
+          </a:fillRef>
+          <a:effectRef idx="2">
+            <a:schemeClr val="accent1"/>
+          </a:effectRef>
+          <a:fontRef idx="minor">
+            <a:schemeClr val="lt1"/>
+          </a:fontRef>
+        </p:style>
+        <p:txBody>
+          <a:bodyPr rtlCol="0" anchor="ctr" wrap="square" lIns="19050" rIns="19050" tIns="19050" bIns="19050"/>
+          <a:lstStyle/>
+          <a:p>
+            <a:pPr algn="ctr">
+              <a:lnSpc>
+                <a:spcPct val="122000"/>
+              </a:lnSpc>
+            </a:pPr>
+            <a:r>
+              <a:rPr sz="1500" b="1">
+                <a:solidFill>
+                  <a:srgbClr val="F5F5F8"/>
+                </a:solidFill>
+                <a:latin typeface="Amazon Ember"/>
+                <a:ea typeface="メイリオ"/>
+                <a:cs typeface="メイリオ"/>
+              </a:rPr>
+              <a:t>response queue</a:t>
+            </a:r>
+          </a:p>
+        </p:txBody>
+      </p:sp>
+      <p:cxnSp>
+        <p:nvCxnSpPr>
+          <p:cNvPr id="15" name="Connector 14"/>
+          <p:cNvCxnSpPr/>
+          <p:nvPr/>
+        </p:nvCxnSpPr>
+        <p:spPr>
+          <a:xfrm flipH="1">
+            <a:off x="8067675" y="2476500"/>
+            <a:ext cx="1076325" cy="1619250"/>
+          </a:xfrm>
+          <a:prstGeom prst="line">
+            <a:avLst/>
+          </a:prstGeom>
+          <a:ln w="25400">
+            <a:solidFill>
+              <a:srgbClr val="96969E"/>
+            </a:solidFill>
+            <a:tailEnd type="triangle" w="med" len="med"/>
+          </a:ln>
+          <a:effectLst/>
+        </p:spPr>
+        <p:style>
+          <a:lnRef idx="2">
+            <a:schemeClr val="accent1"/>
+          </a:lnRef>
+          <a:fillRef idx="0">
+            <a:schemeClr val="accent1"/>
+          </a:fillRef>
+          <a:effectRef idx="1">
+            <a:schemeClr val="accent1"/>
+          </a:effectRef>
+          <a:fontRef idx="minor">
+            <a:schemeClr val="tx1"/>
+          </a:fontRef>
+        </p:style>
+      </p:cxnSp>
+      <p:cxnSp>
+        <p:nvCxnSpPr>
+          <p:cNvPr id="16" name="Connector 15"/>
+          <p:cNvCxnSpPr/>
+          <p:nvPr/>
+        </p:nvCxnSpPr>
+        <p:spPr>
+          <a:xfrm flipH="1" flipV="1">
+            <a:off x="3048000" y="2476500"/>
+            <a:ext cx="1076325" cy="1619250"/>
+          </a:xfrm>
+          <a:prstGeom prst="line">
+            <a:avLst/>
+          </a:prstGeom>
+          <a:ln w="25400">
+            <a:solidFill>
+              <a:srgbClr val="96969E"/>
+            </a:solidFill>
+            <a:tailEnd type="triangle" w="med" len="med"/>
+          </a:ln>
+          <a:effectLst/>
+        </p:spPr>
+        <p:style>
+          <a:lnRef idx="2">
+            <a:schemeClr val="accent1"/>
+          </a:lnRef>
+          <a:fillRef idx="0">
+            <a:schemeClr val="accent1"/>
+          </a:fillRef>
+          <a:effectRef idx="1">
+            <a:schemeClr val="accent1"/>
+          </a:effectRef>
+          <a:fontRef idx="minor">
+            <a:schemeClr val="tx1"/>
+          </a:fontRef>
+        </p:style>
+      </p:cxnSp>
+      <p:sp>
+        <p:nvSpPr>
+          <p:cNvPr id="17" name="TextBox 16"/>
+          <p:cNvSpPr txBox="1"/>
+          <p:nvPr/>
+        </p:nvSpPr>
+        <p:spPr>
+          <a:xfrm>
+            <a:off x="409575" y="2667000"/>
+            <a:ext cx="2476500" cy="571500"/>
+          </a:xfrm>
+          <a:prstGeom prst="rect">
+            <a:avLst/>
+          </a:prstGeom>
+          <a:noFill/>
+        </p:spPr>
+        <p:txBody>
+          <a:bodyPr wrap="square" lIns="0" rIns="0" tIns="0" bIns="0" anchor="ctr">
+            <a:spAutoFit/>
+          </a:bodyPr>
+          <a:lstStyle/>
+          <a:p>
+            <a:pPr algn="l">
+              <a:lnSpc>
+                <a:spcPct val="122000"/>
+              </a:lnSpc>
+            </a:pPr>
+            <a:r>
+              <a:rPr sz="1400" b="0">
+                <a:solidFill>
+                  <a:srgbClr val="96969E"/>
+                </a:solidFill>
+                <a:latin typeface="Amazon Ember"/>
+                <a:ea typeface="メイリオ"/>
+                <a:cs typeface="メイリオ"/>
+              </a:rPr>
+              <a:t>opens the receiver's region</a:t>
+            </a:r>
+          </a:p>
+          <a:p>
+            <a:pPr algn="l">
+              <a:lnSpc>
+                <a:spcPct val="122000"/>
+              </a:lnSpc>
+            </a:pPr>
+            <a:r>
+              <a:rPr sz="1400" b="0">
+                <a:solidFill>
+                  <a:srgbClr val="96969E"/>
+                </a:solidFill>
+                <a:latin typeface="Amazon Ember"/>
+                <a:ea typeface="メイリオ"/>
+                <a:cs typeface="メイリオ"/>
+              </a:rPr>
+              <a:t>(shm_open + mmap)</a:t>
+            </a:r>
+          </a:p>
+        </p:txBody>
+      </p:sp>
+      <p:sp>
+        <p:nvSpPr>
+          <p:cNvPr id="18" name="TextBox 17"/>
+          <p:cNvSpPr txBox="1"/>
+          <p:nvPr/>
+        </p:nvSpPr>
+        <p:spPr>
+          <a:xfrm>
+            <a:off x="409575" y="5143500"/>
+            <a:ext cx="11372850" cy="285750"/>
+          </a:xfrm>
+          <a:prstGeom prst="rect">
+            <a:avLst/>
+          </a:prstGeom>
+          <a:noFill/>
+        </p:spPr>
+        <p:txBody>
+          <a:bodyPr wrap="square" lIns="0" rIns="0" tIns="0" bIns="0" anchor="ctr">
+            <a:spAutoFit/>
+          </a:bodyPr>
+          <a:lstStyle/>
+          <a:p>
+            <a:pPr algn="ctr">
+              <a:lnSpc>
+                <a:spcPct val="122000"/>
+              </a:lnSpc>
+            </a:pPr>
+            <a:r>
+              <a:rPr sz="1500" b="0">
+                <a:solidFill>
+                  <a:srgbClr val="96969E"/>
+                </a:solidFill>
+                <a:latin typeface="Amazon Ember"/>
+                <a:ea typeface="メイリオ"/>
+                <a:cs typeface="メイリオ"/>
+              </a:rPr>
+              <a:t>Each process creates its own region and maps its peers' regions</a:t>
+            </a:r>
+          </a:p>
+        </p:txBody>
+      </p:sp>
+    </p:spTree>
+  </p:cSld>
+  <p:clrMapOvr>
+    <a:masterClrMapping/>
+  </p:clrMapOvr>
+</p:sld>
+</file>
+
+<file path=ppt/slides/slide12.xml><?xml version="1.0" encoding="utf-8"?>
+<p:sld xmlns:a="http://schemas.openxmlformats.org/drawingml/2006/main" xmlns:p="http://schemas.openxmlformats.org/presentationml/2006/main" xmlns:r="http://schemas.openxmlformats.org/officeDocument/2006/relationships" showMasterSp="0">
+  <p:cSld>
+    <p:spTree>
+      <p:nvGrpSpPr>
+        <p:cNvPr id="1" name=""/>
+        <p:cNvGrpSpPr/>
+        <p:nvPr/>
+      </p:nvGrpSpPr>
+      <p:grpSpPr/>
+      <p:sp>
+        <p:nvSpPr>
+          <p:cNvPr id="2" name="TextBox 1"/>
+          <p:cNvSpPr txBox="1"/>
+          <p:nvPr/>
+        </p:nvSpPr>
+        <p:spPr>
+          <a:xfrm>
+            <a:off x="409575" y="247650"/>
+            <a:ext cx="11334750" cy="438150"/>
+          </a:xfrm>
+          <a:prstGeom prst="rect">
+            <a:avLst/>
+          </a:prstGeom>
+          <a:noFill/>
+        </p:spPr>
+        <p:txBody>
+          <a:bodyPr wrap="square" lIns="0" rIns="0" tIns="0" bIns="0" anchor="ctr">
+            <a:spAutoFit/>
+          </a:bodyPr>
+          <a:lstStyle/>
+          <a:p>
+            <a:pPr algn="l">
+              <a:lnSpc>
+                <a:spcPct val="122000"/>
+              </a:lnSpc>
+            </a:pPr>
+            <a:r>
+              <a:rPr sz="3000" b="1">
+                <a:solidFill>
+                  <a:srgbClr val="F5F5F8"/>
+                </a:solidFill>
+                <a:latin typeface="Amazon Ember"/>
+                <a:ea typeface="メイリオ"/>
+                <a:cs typeface="メイリオ"/>
+              </a:rPr>
+              <a:t>CUDA IPC</a:t>
+            </a:r>
+          </a:p>
+        </p:txBody>
+      </p:sp>
+      <p:sp>
+        <p:nvSpPr>
+          <p:cNvPr id="3" name="TextBox 2"/>
+          <p:cNvSpPr txBox="1"/>
+          <p:nvPr/>
+        </p:nvSpPr>
+        <p:spPr>
+          <a:xfrm>
+            <a:off x="409575" y="685800"/>
+            <a:ext cx="11334750" cy="247650"/>
+          </a:xfrm>
+          <a:prstGeom prst="rect">
+            <a:avLst/>
+          </a:prstGeom>
+          <a:noFill/>
+        </p:spPr>
+        <p:txBody>
+          <a:bodyPr wrap="square" lIns="0" rIns="0" tIns="0" bIns="0" anchor="ctr">
+            <a:spAutoFit/>
+          </a:bodyPr>
+          <a:lstStyle/>
+          <a:p>
+            <a:pPr algn="l">
+              <a:lnSpc>
+                <a:spcPct val="122000"/>
+              </a:lnSpc>
+            </a:pPr>
+            <a:r>
+              <a:rPr sz="1600" b="0">
+                <a:solidFill>
+                  <a:srgbClr val="96969E"/>
+                </a:solidFill>
+                <a:latin typeface="Amazon Ember"/>
+                <a:ea typeface="メイリオ"/>
+                <a:cs typeface="メイリオ"/>
+              </a:rPr>
+              <a:t>A send into a GPU buffer: the receiver copies with a handle from the sender</a:t>
+            </a:r>
+          </a:p>
+        </p:txBody>
+      </p:sp>
+      <p:sp>
+        <p:nvSpPr>
+          <p:cNvPr id="4" name="Rounded Rectangle 3"/>
+          <p:cNvSpPr/>
+          <p:nvPr/>
+        </p:nvSpPr>
+        <p:spPr>
+          <a:xfrm>
+            <a:off x="409575" y="1428750"/>
+            <a:ext cx="3143250" cy="1047750"/>
+          </a:xfrm>
+          <a:prstGeom prst="roundRect">
+            <a:avLst>
+              <a:gd name="adj" fmla="val 10000"/>
+            </a:avLst>
+          </a:prstGeom>
+          <a:solidFill>
+            <a:srgbClr val="124022"/>
+          </a:solidFill>
+          <a:ln w="15875">
+            <a:solidFill>
+              <a:srgbClr val="24A046"/>
+            </a:solidFill>
+          </a:ln>
+          <a:effectLst/>
+        </p:spPr>
+        <p:style>
+          <a:lnRef idx="1">
+            <a:schemeClr val="accent1"/>
+          </a:lnRef>
+          <a:fillRef idx="3">
+            <a:schemeClr val="accent1"/>
+          </a:fillRef>
+          <a:effectRef idx="2">
+            <a:schemeClr val="accent1"/>
+          </a:effectRef>
+          <a:fontRef idx="minor">
+            <a:schemeClr val="lt1"/>
+          </a:fontRef>
+        </p:style>
+        <p:txBody>
+          <a:bodyPr rtlCol="0" anchor="ctr" wrap="square" lIns="19050" rIns="19050" tIns="19050" bIns="19050"/>
+          <a:lstStyle/>
+          <a:p>
+            <a:pPr algn="ctr">
+              <a:lnSpc>
+                <a:spcPct val="122000"/>
+              </a:lnSpc>
+            </a:pPr>
+            <a:r>
+              <a:rPr sz="1600" b="1">
+                <a:solidFill>
+                  <a:srgbClr val="F5F5F8"/>
+                </a:solidFill>
+                <a:latin typeface="Amazon Ember"/>
+                <a:ea typeface="メイリオ"/>
+                <a:cs typeface="メイリオ"/>
+              </a:rPr>
+              <a:t>sender's GPU buffer</a:t>
+            </a:r>
+          </a:p>
+        </p:txBody>
+      </p:sp>
+      <p:sp>
+        <p:nvSpPr>
+          <p:cNvPr id="5" name="Rounded Rectangle 4"/>
+          <p:cNvSpPr/>
+          <p:nvPr/>
+        </p:nvSpPr>
+        <p:spPr>
+          <a:xfrm>
+            <a:off x="8639175" y="1428750"/>
+            <a:ext cx="3143250" cy="1047750"/>
+          </a:xfrm>
+          <a:prstGeom prst="roundRect">
+            <a:avLst>
+              <a:gd name="adj" fmla="val 10000"/>
+            </a:avLst>
+          </a:prstGeom>
+          <a:solidFill>
+            <a:srgbClr val="102C48"/>
+          </a:solidFill>
+          <a:ln w="15875">
+            <a:solidFill>
+              <a:srgbClr val="2896F0"/>
+            </a:solidFill>
+          </a:ln>
+          <a:effectLst/>
+        </p:spPr>
+        <p:style>
+          <a:lnRef idx="1">
+            <a:schemeClr val="accent1"/>
+          </a:lnRef>
+          <a:fillRef idx="3">
+            <a:schemeClr val="accent1"/>
+          </a:fillRef>
+          <a:effectRef idx="2">
+            <a:schemeClr val="accent1"/>
+          </a:effectRef>
+          <a:fontRef idx="minor">
+            <a:schemeClr val="lt1"/>
+          </a:fontRef>
+        </p:style>
+        <p:txBody>
+          <a:bodyPr rtlCol="0" anchor="ctr" wrap="square" lIns="19050" rIns="19050" tIns="19050" bIns="19050"/>
+          <a:lstStyle/>
+          <a:p>
+            <a:pPr algn="ctr">
+              <a:lnSpc>
+                <a:spcPct val="122000"/>
+              </a:lnSpc>
+            </a:pPr>
+            <a:r>
+              <a:rPr sz="1600" b="1">
+                <a:solidFill>
+                  <a:srgbClr val="F5F5F8"/>
+                </a:solidFill>
+                <a:latin typeface="Amazon Ember"/>
+                <a:ea typeface="メイリオ"/>
+                <a:cs typeface="メイリオ"/>
+              </a:rPr>
+              <a:t>receiver's GPU buffer</a:t>
+            </a:r>
+          </a:p>
+        </p:txBody>
+      </p:sp>
+      <p:sp>
+        <p:nvSpPr>
+          <p:cNvPr id="6" name="Rounded Rectangle 5"/>
+          <p:cNvSpPr/>
+          <p:nvPr/>
+        </p:nvSpPr>
+        <p:spPr>
+          <a:xfrm>
+            <a:off x="4505325" y="1047750"/>
+            <a:ext cx="3181350" cy="666750"/>
+          </a:xfrm>
+          <a:prstGeom prst="roundRect">
+            <a:avLst>
+              <a:gd name="adj" fmla="val 10000"/>
+            </a:avLst>
+          </a:prstGeom>
+          <a:solidFill>
+            <a:srgbClr val="50420E"/>
+          </a:solidFill>
+          <a:ln w="15875">
+            <a:solidFill>
+              <a:srgbClr val="FBD332"/>
+            </a:solidFill>
+          </a:ln>
+          <a:effectLst/>
+        </p:spPr>
+        <p:style>
+          <a:lnRef idx="1">
+            <a:schemeClr val="accent1"/>
+          </a:lnRef>
+          <a:fillRef idx="3">
+            <a:schemeClr val="accent1"/>
+          </a:fillRef>
+          <a:effectRef idx="2">
+            <a:schemeClr val="accent1"/>
+          </a:effectRef>
+          <a:fontRef idx="minor">
+            <a:schemeClr val="lt1"/>
+          </a:fontRef>
+        </p:style>
+        <p:txBody>
+          <a:bodyPr rtlCol="0" anchor="ctr" wrap="square" lIns="19050" rIns="19050" tIns="19050" bIns="19050"/>
+          <a:lstStyle/>
+          <a:p>
+            <a:pPr algn="ctr">
+              <a:lnSpc>
+                <a:spcPct val="122000"/>
+              </a:lnSpc>
+            </a:pPr>
+            <a:r>
+              <a:rPr sz="1500" b="1">
+                <a:solidFill>
+                  <a:srgbClr val="F5F5F8"/>
+                </a:solidFill>
+                <a:latin typeface="Amazon Ember"/>
+                <a:ea typeface="メイリオ"/>
+                <a:cs typeface="メイリオ"/>
+              </a:rPr>
+              <a:t>IPC handle</a:t>
+            </a:r>
+          </a:p>
+          <a:p>
+            <a:pPr algn="ctr">
+              <a:lnSpc>
+                <a:spcPct val="122000"/>
+              </a:lnSpc>
+            </a:pPr>
+            <a:r>
+              <a:rPr sz="1500" b="1">
+                <a:solidFill>
+                  <a:srgbClr val="F5F5F8"/>
+                </a:solidFill>
+                <a:latin typeface="Amazon Ember"/>
+                <a:ea typeface="メイリオ"/>
+                <a:cs typeface="メイリオ"/>
+              </a:rPr>
+              <a:t>(in a shm command)</a:t>
+            </a:r>
+          </a:p>
+        </p:txBody>
+      </p:sp>
+      <p:cxnSp>
+        <p:nvCxnSpPr>
+          <p:cNvPr id="7" name="Connector 6"/>
+          <p:cNvCxnSpPr/>
+          <p:nvPr/>
+        </p:nvCxnSpPr>
+        <p:spPr>
+          <a:xfrm flipV="1">
+            <a:off x="3552825" y="1381125"/>
+            <a:ext cx="952500" cy="238125"/>
+          </a:xfrm>
+          <a:prstGeom prst="line">
+            <a:avLst/>
+          </a:prstGeom>
+          <a:ln w="31750">
+            <a:solidFill>
+              <a:srgbClr val="FBD332"/>
+            </a:solidFill>
+            <a:tailEnd type="triangle" w="med" len="med"/>
+          </a:ln>
+          <a:effectLst/>
+        </p:spPr>
+        <p:style>
+          <a:lnRef idx="2">
+            <a:schemeClr val="accent1"/>
+          </a:lnRef>
+          <a:fillRef idx="0">
+            <a:schemeClr val="accent1"/>
+          </a:fillRef>
+          <a:effectRef idx="1">
+            <a:schemeClr val="accent1"/>
+          </a:effectRef>
+          <a:fontRef idx="minor">
+            <a:schemeClr val="tx1"/>
+          </a:fontRef>
+        </p:style>
+      </p:cxnSp>
+      <p:cxnSp>
+        <p:nvCxnSpPr>
+          <p:cNvPr id="8" name="Connector 7"/>
+          <p:cNvCxnSpPr/>
+          <p:nvPr/>
+        </p:nvCxnSpPr>
+        <p:spPr>
+          <a:xfrm>
+            <a:off x="7686675" y="1381125"/>
+            <a:ext cx="952500" cy="238125"/>
+          </a:xfrm>
+          <a:prstGeom prst="line">
+            <a:avLst/>
+          </a:prstGeom>
+          <a:ln w="31750">
+            <a:solidFill>
+              <a:srgbClr val="FBD332"/>
+            </a:solidFill>
+            <a:tailEnd type="triangle" w="med" len="med"/>
+          </a:ln>
+          <a:effectLst/>
+        </p:spPr>
+        <p:style>
+          <a:lnRef idx="2">
+            <a:schemeClr val="accent1"/>
+          </a:lnRef>
+          <a:fillRef idx="0">
+            <a:schemeClr val="accent1"/>
+          </a:fillRef>
+          <a:effectRef idx="1">
+            <a:schemeClr val="accent1"/>
+          </a:effectRef>
+          <a:fontRef idx="minor">
+            <a:schemeClr val="tx1"/>
+          </a:fontRef>
+        </p:style>
+      </p:cxnSp>
+      <p:cxnSp>
+        <p:nvCxnSpPr>
+          <p:cNvPr id="9" name="Connector 8"/>
+          <p:cNvCxnSpPr/>
+          <p:nvPr/>
+        </p:nvCxnSpPr>
+        <p:spPr>
+          <a:xfrm>
+            <a:off x="3552825" y="2238375"/>
+            <a:ext cx="5086350" cy="0"/>
+          </a:xfrm>
+          <a:prstGeom prst="line">
+            <a:avLst/>
+          </a:prstGeom>
+          <a:ln w="44450">
+            <a:solidFill>
+              <a:srgbClr val="3BD16F"/>
+            </a:solidFill>
+            <a:tailEnd type="triangle" w="med" len="med"/>
+          </a:ln>
+          <a:effectLst/>
+        </p:spPr>
+        <p:style>
+          <a:lnRef idx="2">
+            <a:schemeClr val="accent1"/>
+          </a:lnRef>
+          <a:fillRef idx="0">
+            <a:schemeClr val="accent1"/>
+          </a:fillRef>
+          <a:effectRef idx="1">
+            <a:schemeClr val="accent1"/>
+          </a:effectRef>
+          <a:fontRef idx="minor">
+            <a:schemeClr val="tx1"/>
+          </a:fontRef>
+        </p:style>
+      </p:cxnSp>
+      <p:sp>
+        <p:nvSpPr>
+          <p:cNvPr id="10" name="TextBox 9"/>
+          <p:cNvSpPr txBox="1"/>
+          <p:nvPr/>
+        </p:nvSpPr>
+        <p:spPr>
+          <a:xfrm>
+            <a:off x="4505325" y="2333625"/>
+            <a:ext cx="3181350" cy="285750"/>
+          </a:xfrm>
+          <a:prstGeom prst="rect">
+            <a:avLst/>
+          </a:prstGeom>
+          <a:noFill/>
+        </p:spPr>
+        <p:txBody>
+          <a:bodyPr wrap="square" lIns="0" rIns="0" tIns="0" bIns="0" anchor="ctr">
+            <a:spAutoFit/>
+          </a:bodyPr>
+          <a:lstStyle/>
+          <a:p>
+            <a:pPr algn="ctr">
+              <a:lnSpc>
+                <a:spcPct val="122000"/>
+              </a:lnSpc>
+            </a:pPr>
+            <a:r>
+              <a:rPr sz="1500" b="0">
+                <a:solidFill>
+                  <a:srgbClr val="3BD16F"/>
+                </a:solidFill>
+                <a:latin typeface="Amazon Ember"/>
+                <a:ea typeface="メイリオ"/>
+                <a:cs typeface="メイリオ"/>
+              </a:rPr>
+              <a:t>1 copy, done by the receiver</a:t>
+            </a:r>
+          </a:p>
+        </p:txBody>
+      </p:sp>
+      <p:sp>
+        <p:nvSpPr>
+          <p:cNvPr id="11" name="Rounded Rectangle 10"/>
+          <p:cNvSpPr/>
+          <p:nvPr/>
+        </p:nvSpPr>
+        <p:spPr>
+          <a:xfrm>
+            <a:off x="409575" y="3238500"/>
+            <a:ext cx="11372850" cy="1143000"/>
+          </a:xfrm>
+          <a:prstGeom prst="roundRect">
+            <a:avLst>
+              <a:gd name="adj" fmla="val 5000"/>
+            </a:avLst>
+          </a:prstGeom>
+          <a:solidFill>
+            <a:srgbClr val="161A1E"/>
+          </a:solidFill>
+          <a:ln w="15875">
+            <a:solidFill>
+              <a:srgbClr val="464A50"/>
+            </a:solidFill>
+          </a:ln>
+          <a:effectLst/>
+        </p:spPr>
+        <p:style>
+          <a:lnRef idx="1">
+            <a:schemeClr val="accent1"/>
+          </a:lnRef>
+          <a:fillRef idx="3">
+            <a:schemeClr val="accent1"/>
+          </a:fillRef>
+          <a:effectRef idx="2">
+            <a:schemeClr val="accent1"/>
+          </a:effectRef>
+          <a:fontRef idx="minor">
+            <a:schemeClr val="lt1"/>
+          </a:fontRef>
+        </p:style>
+        <p:txBody>
+          <a:bodyPr rtlCol="0" anchor="ctr"/>
+          <a:lstStyle/>
+          <a:p>
+            <a:pPr algn="ctr"/>
+          </a:p>
+        </p:txBody>
+      </p:sp>
+      <p:sp>
+        <p:nvSpPr>
+          <p:cNvPr id="12" name="TextBox 11"/>
+          <p:cNvSpPr txBox="1"/>
+          <p:nvPr/>
+        </p:nvSpPr>
+        <p:spPr>
+          <a:xfrm>
+            <a:off x="600075" y="3333750"/>
+            <a:ext cx="10991850" cy="285750"/>
+          </a:xfrm>
+          <a:prstGeom prst="rect">
+            <a:avLst/>
+          </a:prstGeom>
+          <a:noFill/>
+        </p:spPr>
+        <p:txBody>
+          <a:bodyPr wrap="square" lIns="0" rIns="0" tIns="0" bIns="0" anchor="ctr">
+            <a:spAutoFit/>
+          </a:bodyPr>
+          <a:lstStyle/>
+          <a:p>
+            <a:pPr algn="l">
+              <a:lnSpc>
+                <a:spcPct val="122000"/>
+              </a:lnSpc>
+            </a:pPr>
+            <a:r>
+              <a:rPr sz="1600" b="1">
+                <a:solidFill>
+                  <a:srgbClr val="FBD332"/>
+                </a:solidFill>
+                <a:latin typeface="Amazon Ember"/>
+                <a:ea typeface="メイリオ"/>
+                <a:cs typeface="メイリオ"/>
+              </a:rPr>
+              <a:t>precondition on the sender</a:t>
+            </a:r>
+          </a:p>
+        </p:txBody>
+      </p:sp>
+      <p:sp>
+        <p:nvSpPr>
+          <p:cNvPr id="13" name="TextBox 12"/>
+          <p:cNvSpPr txBox="1"/>
+          <p:nvPr/>
+        </p:nvSpPr>
+        <p:spPr>
+          <a:xfrm>
+            <a:off x="600075" y="3667125"/>
+            <a:ext cx="10991850" cy="571500"/>
+          </a:xfrm>
+          <a:prstGeom prst="rect">
+            <a:avLst/>
+          </a:prstGeom>
+          <a:noFill/>
+        </p:spPr>
+        <p:txBody>
+          <a:bodyPr wrap="square" lIns="0" rIns="0" tIns="0" bIns="0" anchor="ctr">
+            <a:spAutoFit/>
+          </a:bodyPr>
+          <a:lstStyle/>
+          <a:p>
+            <a:pPr algn="l">
+              <a:lnSpc>
+                <a:spcPct val="122000"/>
+              </a:lnSpc>
+            </a:pPr>
+            <a:r>
+              <a:rPr sz="1500" b="0">
+                <a:solidFill>
+                  <a:srgbClr val="F5F5F8"/>
+                </a:solidFill>
+                <a:latin typeface="Amazon Ember"/>
+                <a:ea typeface="メイリオ"/>
+                <a:cs typeface="メイリオ"/>
+              </a:rPr>
+              <a:t>cuMemGetAddressRange must find the buffer in the sending thread's</a:t>
+            </a:r>
+          </a:p>
+          <a:p>
+            <a:pPr algn="l">
+              <a:lnSpc>
+                <a:spcPct val="122000"/>
+              </a:lnSpc>
+            </a:pPr>
+            <a:r>
+              <a:rPr sz="1500" b="0">
+                <a:solidFill>
+                  <a:srgbClr val="F5F5F8"/>
+                </a:solidFill>
+                <a:latin typeface="Amazon Ember"/>
+                <a:ea typeface="メイリオ"/>
+                <a:cs typeface="メイリオ"/>
+              </a:rPr>
+              <a:t>current CUDA context, or no handle can be exported</a:t>
+            </a:r>
+          </a:p>
+        </p:txBody>
+      </p:sp>
+    </p:spTree>
+  </p:cSld>
+  <p:clrMapOvr>
+    <a:masterClrMapping/>
+  </p:clrMapOvr>
+</p:sld>
+</file>
+
+<file path=ppt/slides/slide13.xml><?xml version="1.0" encoding="utf-8"?>
+<p:sld xmlns:a="http://schemas.openxmlformats.org/drawingml/2006/main" xmlns:p="http://schemas.openxmlformats.org/presentationml/2006/main" xmlns:r="http://schemas.openxmlformats.org/officeDocument/2006/relationships" showMasterSp="0">
+  <p:cSld>
+    <p:spTree>
+      <p:nvGrpSpPr>
+        <p:cNvPr id="1" name=""/>
+        <p:cNvGrpSpPr/>
+        <p:nvPr/>
+      </p:nvGrpSpPr>
+      <p:grpSpPr/>
+      <p:sp>
+        <p:nvSpPr>
+          <p:cNvPr id="2" name="TextBox 1"/>
+          <p:cNvSpPr txBox="1"/>
+          <p:nvPr/>
+        </p:nvSpPr>
+        <p:spPr>
+          <a:xfrm>
+            <a:off x="409575" y="247650"/>
+            <a:ext cx="11334750" cy="438150"/>
+          </a:xfrm>
+          <a:prstGeom prst="rect">
+            <a:avLst/>
+          </a:prstGeom>
+          <a:noFill/>
+        </p:spPr>
+        <p:txBody>
+          <a:bodyPr wrap="square" lIns="0" rIns="0" tIns="0" bIns="0" anchor="ctr">
+            <a:spAutoFit/>
+          </a:bodyPr>
+          <a:lstStyle/>
+          <a:p>
+            <a:pPr algn="l">
+              <a:lnSpc>
+                <a:spcPct val="122000"/>
+              </a:lnSpc>
+            </a:pPr>
+            <a:r>
+              <a:rPr sz="3000" b="1">
+                <a:solidFill>
+                  <a:srgbClr val="F5F5F8"/>
+                </a:solidFill>
+                <a:latin typeface="Amazon Ember"/>
+                <a:ea typeface="メイリオ"/>
+                <a:cs typeface="メイリオ"/>
+              </a:rPr>
+              <a:t>SAR</a:t>
+            </a:r>
+          </a:p>
+        </p:txBody>
+      </p:sp>
+      <p:sp>
+        <p:nvSpPr>
+          <p:cNvPr id="3" name="TextBox 2"/>
+          <p:cNvSpPr txBox="1"/>
+          <p:nvPr/>
+        </p:nvSpPr>
+        <p:spPr>
+          <a:xfrm>
+            <a:off x="409575" y="685800"/>
+            <a:ext cx="11334750" cy="247650"/>
+          </a:xfrm>
+          <a:prstGeom prst="rect">
+            <a:avLst/>
+          </a:prstGeom>
+          <a:noFill/>
+        </p:spPr>
+        <p:txBody>
+          <a:bodyPr wrap="square" lIns="0" rIns="0" tIns="0" bIns="0" anchor="ctr">
+            <a:spAutoFit/>
+          </a:bodyPr>
+          <a:lstStyle/>
+          <a:p>
+            <a:pPr algn="l">
+              <a:lnSpc>
+                <a:spcPct val="122000"/>
+              </a:lnSpc>
+            </a:pPr>
+            <a:r>
+              <a:rPr sz="1600" b="0">
+                <a:solidFill>
+                  <a:srgbClr val="96969E"/>
+                </a:solidFill>
+                <a:latin typeface="Amazon Ember"/>
+                <a:ea typeface="メイリオ"/>
+                <a:cs typeface="メイリオ"/>
+              </a:rPr>
+              <a:t>Segmentation and reassembly through bounce buffers; here, after the IPC handle fails</a:t>
+            </a:r>
+          </a:p>
+        </p:txBody>
+      </p:sp>
+      <p:sp>
+        <p:nvSpPr>
+          <p:cNvPr id="4" name="Rounded Rectangle 3"/>
+          <p:cNvSpPr/>
+          <p:nvPr/>
+        </p:nvSpPr>
+        <p:spPr>
+          <a:xfrm>
+            <a:off x="409575" y="1428750"/>
+            <a:ext cx="2571750" cy="1047750"/>
+          </a:xfrm>
+          <a:prstGeom prst="roundRect">
+            <a:avLst>
+              <a:gd name="adj" fmla="val 10000"/>
+            </a:avLst>
+          </a:prstGeom>
+          <a:solidFill>
+            <a:srgbClr val="124022"/>
+          </a:solidFill>
+          <a:ln w="15875">
+            <a:solidFill>
+              <a:srgbClr val="24A046"/>
+            </a:solidFill>
+          </a:ln>
+          <a:effectLst/>
+        </p:spPr>
+        <p:style>
+          <a:lnRef idx="1">
+            <a:schemeClr val="accent1"/>
+          </a:lnRef>
+          <a:fillRef idx="3">
+            <a:schemeClr val="accent1"/>
+          </a:fillRef>
+          <a:effectRef idx="2">
+            <a:schemeClr val="accent1"/>
+          </a:effectRef>
+          <a:fontRef idx="minor">
+            <a:schemeClr val="lt1"/>
+          </a:fontRef>
+        </p:style>
+        <p:txBody>
+          <a:bodyPr rtlCol="0" anchor="ctr" wrap="square" lIns="19050" rIns="19050" tIns="19050" bIns="19050"/>
+          <a:lstStyle/>
+          <a:p>
+            <a:pPr algn="ctr">
+              <a:lnSpc>
+                <a:spcPct val="122000"/>
+              </a:lnSpc>
+            </a:pPr>
+            <a:r>
+              <a:rPr sz="1600" b="1">
+                <a:solidFill>
+                  <a:srgbClr val="F5F5F8"/>
+                </a:solidFill>
+                <a:latin typeface="Amazon Ember"/>
+                <a:ea typeface="メイリオ"/>
+                <a:cs typeface="メイリオ"/>
+              </a:rPr>
+              <a:t>sender's GPU buffer</a:t>
+            </a:r>
+          </a:p>
+        </p:txBody>
+      </p:sp>
+      <p:sp>
+        <p:nvSpPr>
+          <p:cNvPr id="5" name="Rounded Rectangle 4"/>
+          <p:cNvSpPr/>
+          <p:nvPr/>
+        </p:nvSpPr>
+        <p:spPr>
+          <a:xfrm>
+            <a:off x="9210675" y="1428750"/>
+            <a:ext cx="2571750" cy="1047750"/>
+          </a:xfrm>
+          <a:prstGeom prst="roundRect">
+            <a:avLst>
+              <a:gd name="adj" fmla="val 10000"/>
+            </a:avLst>
+          </a:prstGeom>
+          <a:solidFill>
+            <a:srgbClr val="102C48"/>
+          </a:solidFill>
+          <a:ln w="15875">
+            <a:solidFill>
+              <a:srgbClr val="2896F0"/>
+            </a:solidFill>
+          </a:ln>
+          <a:effectLst/>
+        </p:spPr>
+        <p:style>
+          <a:lnRef idx="1">
+            <a:schemeClr val="accent1"/>
+          </a:lnRef>
+          <a:fillRef idx="3">
+            <a:schemeClr val="accent1"/>
+          </a:fillRef>
+          <a:effectRef idx="2">
+            <a:schemeClr val="accent1"/>
+          </a:effectRef>
+          <a:fontRef idx="minor">
+            <a:schemeClr val="lt1"/>
+          </a:fontRef>
+        </p:style>
+        <p:txBody>
+          <a:bodyPr rtlCol="0" anchor="ctr" wrap="square" lIns="19050" rIns="19050" tIns="19050" bIns="19050"/>
+          <a:lstStyle/>
+          <a:p>
+            <a:pPr algn="ctr">
+              <a:lnSpc>
+                <a:spcPct val="122000"/>
+              </a:lnSpc>
+            </a:pPr>
+            <a:r>
+              <a:rPr sz="1600" b="1">
+                <a:solidFill>
+                  <a:srgbClr val="F5F5F8"/>
+                </a:solidFill>
+                <a:latin typeface="Amazon Ember"/>
+                <a:ea typeface="メイリオ"/>
+                <a:cs typeface="メイリオ"/>
+              </a:rPr>
+              <a:t>receiver's GPU buffer</a:t>
+            </a:r>
+          </a:p>
+        </p:txBody>
+      </p:sp>
+      <p:sp>
+        <p:nvSpPr>
+          <p:cNvPr id="6" name="Rounded Rectangle 5"/>
+          <p:cNvSpPr/>
+          <p:nvPr/>
+        </p:nvSpPr>
+        <p:spPr>
+          <a:xfrm>
+            <a:off x="4124325" y="1333500"/>
+            <a:ext cx="3943350" cy="1238250"/>
+          </a:xfrm>
+          <a:prstGeom prst="roundRect">
+            <a:avLst>
+              <a:gd name="adj" fmla="val 5000"/>
+            </a:avLst>
+          </a:prstGeom>
+          <a:solidFill>
+            <a:srgbClr val="161A1E"/>
+          </a:solidFill>
+          <a:ln w="15875">
+            <a:solidFill>
+              <a:srgbClr val="FBD332"/>
+            </a:solidFill>
+          </a:ln>
+          <a:effectLst/>
+        </p:spPr>
+        <p:style>
+          <a:lnRef idx="1">
+            <a:schemeClr val="accent1"/>
+          </a:lnRef>
+          <a:fillRef idx="3">
+            <a:schemeClr val="accent1"/>
+          </a:fillRef>
+          <a:effectRef idx="2">
+            <a:schemeClr val="accent1"/>
+          </a:effectRef>
+          <a:fontRef idx="minor">
+            <a:schemeClr val="lt1"/>
+          </a:fontRef>
+        </p:style>
+        <p:txBody>
+          <a:bodyPr rtlCol="0" anchor="ctr"/>
+          <a:lstStyle/>
+          <a:p>
+            <a:pPr algn="ctr"/>
+          </a:p>
+        </p:txBody>
+      </p:sp>
+      <p:sp>
+        <p:nvSpPr>
+          <p:cNvPr id="7" name="TextBox 6"/>
+          <p:cNvSpPr txBox="1"/>
+          <p:nvPr/>
+        </p:nvSpPr>
+        <p:spPr>
+          <a:xfrm>
+            <a:off x="4219575" y="1390650"/>
+            <a:ext cx="3752850" cy="247650"/>
+          </a:xfrm>
+          <a:prstGeom prst="rect">
+            <a:avLst/>
+          </a:prstGeom>
+          <a:noFill/>
+        </p:spPr>
+        <p:txBody>
+          <a:bodyPr wrap="square" lIns="0" rIns="0" tIns="0" bIns="0" anchor="ctr">
+            <a:spAutoFit/>
+          </a:bodyPr>
+          <a:lstStyle/>
+          <a:p>
+            <a:pPr algn="ctr">
+              <a:lnSpc>
+                <a:spcPct val="122000"/>
+              </a:lnSpc>
+            </a:pPr>
+            <a:r>
+              <a:rPr sz="1400" b="0">
+                <a:solidFill>
+                  <a:srgbClr val="FBD332"/>
+                </a:solidFill>
+                <a:latin typeface="Amazon Ember"/>
+                <a:ea typeface="メイリオ"/>
+                <a:cs typeface="メイリオ"/>
+              </a:rPr>
+              <a:t>receiver's shared memory</a:t>
+            </a:r>
+          </a:p>
+        </p:txBody>
+      </p:sp>
+      <p:sp>
+        <p:nvSpPr>
+          <p:cNvPr id="8" name="Rounded Rectangle 7"/>
+          <p:cNvSpPr/>
+          <p:nvPr/>
+        </p:nvSpPr>
+        <p:spPr>
+          <a:xfrm>
+            <a:off x="4410075" y="1762125"/>
+            <a:ext cx="723900" cy="533400"/>
+          </a:xfrm>
+          <a:prstGeom prst="roundRect">
+            <a:avLst>
+              <a:gd name="adj" fmla="val 10000"/>
+            </a:avLst>
+          </a:prstGeom>
+          <a:solidFill>
+            <a:srgbClr val="343840"/>
+          </a:solidFill>
+          <a:ln w="15875">
+            <a:solidFill>
+              <a:srgbClr val="464A50"/>
+            </a:solidFill>
+          </a:ln>
+          <a:effectLst/>
+        </p:spPr>
+        <p:style>
+          <a:lnRef idx="1">
+            <a:schemeClr val="accent1"/>
+          </a:lnRef>
+          <a:fillRef idx="3">
+            <a:schemeClr val="accent1"/>
+          </a:fillRef>
+          <a:effectRef idx="2">
+            <a:schemeClr val="accent1"/>
+          </a:effectRef>
+          <a:fontRef idx="minor">
+            <a:schemeClr val="lt1"/>
+          </a:fontRef>
+        </p:style>
+        <p:txBody>
+          <a:bodyPr rtlCol="0" anchor="ctr" wrap="square" lIns="19050" rIns="19050" tIns="19050" bIns="19050"/>
+          <a:lstStyle/>
+          <a:p>
+            <a:pPr algn="ctr">
+              <a:lnSpc>
+                <a:spcPct val="122000"/>
+              </a:lnSpc>
+            </a:pPr>
+            <a:r>
+              <a:rPr sz="1300" b="1">
+                <a:solidFill>
+                  <a:srgbClr val="F5F5F8"/>
+                </a:solidFill>
+                <a:latin typeface="Amazon Ember"/>
+                <a:ea typeface="メイリオ"/>
+                <a:cs typeface="メイリオ"/>
+              </a:rPr>
+              <a:t>32 KiB</a:t>
+            </a:r>
+          </a:p>
+        </p:txBody>
+      </p:sp>
+      <p:sp>
+        <p:nvSpPr>
+          <p:cNvPr id="9" name="Rounded Rectangle 8"/>
+          <p:cNvSpPr/>
+          <p:nvPr/>
+        </p:nvSpPr>
+        <p:spPr>
+          <a:xfrm>
+            <a:off x="5286375" y="1762125"/>
+            <a:ext cx="723900" cy="533400"/>
+          </a:xfrm>
+          <a:prstGeom prst="roundRect">
+            <a:avLst>
+              <a:gd name="adj" fmla="val 10000"/>
+            </a:avLst>
+          </a:prstGeom>
+          <a:solidFill>
+            <a:srgbClr val="343840"/>
+          </a:solidFill>
+          <a:ln w="15875">
+            <a:solidFill>
+              <a:srgbClr val="464A50"/>
+            </a:solidFill>
+          </a:ln>
+          <a:effectLst/>
+        </p:spPr>
+        <p:style>
+          <a:lnRef idx="1">
+            <a:schemeClr val="accent1"/>
+          </a:lnRef>
+          <a:fillRef idx="3">
+            <a:schemeClr val="accent1"/>
+          </a:fillRef>
+          <a:effectRef idx="2">
+            <a:schemeClr val="accent1"/>
+          </a:effectRef>
+          <a:fontRef idx="minor">
+            <a:schemeClr val="lt1"/>
+          </a:fontRef>
+        </p:style>
+        <p:txBody>
+          <a:bodyPr rtlCol="0" anchor="ctr" wrap="square" lIns="19050" rIns="19050" tIns="19050" bIns="19050"/>
+          <a:lstStyle/>
+          <a:p>
+            <a:pPr algn="ctr">
+              <a:lnSpc>
+                <a:spcPct val="122000"/>
+              </a:lnSpc>
+            </a:pPr>
+            <a:r>
+              <a:rPr sz="1300" b="1">
+                <a:solidFill>
+                  <a:srgbClr val="F5F5F8"/>
+                </a:solidFill>
+                <a:latin typeface="Amazon Ember"/>
+                <a:ea typeface="メイリオ"/>
+                <a:cs typeface="メイリオ"/>
+              </a:rPr>
+              <a:t>32 KiB</a:t>
+            </a:r>
+          </a:p>
+        </p:txBody>
+      </p:sp>
+      <p:sp>
+        <p:nvSpPr>
+          <p:cNvPr id="10" name="Rounded Rectangle 9"/>
+          <p:cNvSpPr/>
+          <p:nvPr/>
+        </p:nvSpPr>
+        <p:spPr>
+          <a:xfrm>
+            <a:off x="6162675" y="1762125"/>
+            <a:ext cx="723900" cy="533400"/>
+          </a:xfrm>
+          <a:prstGeom prst="roundRect">
+            <a:avLst>
+              <a:gd name="adj" fmla="val 10000"/>
+            </a:avLst>
+          </a:prstGeom>
+          <a:solidFill>
+            <a:srgbClr val="343840"/>
+          </a:solidFill>
+          <a:ln w="15875">
+            <a:solidFill>
+              <a:srgbClr val="464A50"/>
+            </a:solidFill>
+          </a:ln>
+          <a:effectLst/>
+        </p:spPr>
+        <p:style>
+          <a:lnRef idx="1">
+            <a:schemeClr val="accent1"/>
+          </a:lnRef>
+          <a:fillRef idx="3">
+            <a:schemeClr val="accent1"/>
+          </a:fillRef>
+          <a:effectRef idx="2">
+            <a:schemeClr val="accent1"/>
+          </a:effectRef>
+          <a:fontRef idx="minor">
+            <a:schemeClr val="lt1"/>
+          </a:fontRef>
+        </p:style>
+        <p:txBody>
+          <a:bodyPr rtlCol="0" anchor="ctr" wrap="square" lIns="19050" rIns="19050" tIns="19050" bIns="19050"/>
+          <a:lstStyle/>
+          <a:p>
+            <a:pPr algn="ctr">
+              <a:lnSpc>
+                <a:spcPct val="122000"/>
+              </a:lnSpc>
+            </a:pPr>
+            <a:r>
+              <a:rPr sz="1300" b="1">
+                <a:solidFill>
+                  <a:srgbClr val="F5F5F8"/>
+                </a:solidFill>
+                <a:latin typeface="Amazon Ember"/>
+                <a:ea typeface="メイリオ"/>
+                <a:cs typeface="メイリオ"/>
+              </a:rPr>
+              <a:t>32 KiB</a:t>
+            </a:r>
+          </a:p>
+        </p:txBody>
+      </p:sp>
+      <p:sp>
+        <p:nvSpPr>
+          <p:cNvPr id="11" name="Rounded Rectangle 10"/>
+          <p:cNvSpPr/>
+          <p:nvPr/>
+        </p:nvSpPr>
+        <p:spPr>
+          <a:xfrm>
+            <a:off x="7038975" y="1762125"/>
+            <a:ext cx="723900" cy="533400"/>
+          </a:xfrm>
+          <a:prstGeom prst="roundRect">
+            <a:avLst>
+              <a:gd name="adj" fmla="val 10000"/>
+            </a:avLst>
+          </a:prstGeom>
+          <a:solidFill>
+            <a:srgbClr val="343840"/>
+          </a:solidFill>
+          <a:ln w="15875">
+            <a:solidFill>
+              <a:srgbClr val="464A50"/>
+            </a:solidFill>
+          </a:ln>
+          <a:effectLst/>
+        </p:spPr>
+        <p:style>
+          <a:lnRef idx="1">
+            <a:schemeClr val="accent1"/>
+          </a:lnRef>
+          <a:fillRef idx="3">
+            <a:schemeClr val="accent1"/>
+          </a:fillRef>
+          <a:effectRef idx="2">
+            <a:schemeClr val="accent1"/>
+          </a:effectRef>
+          <a:fontRef idx="minor">
+            <a:schemeClr val="lt1"/>
+          </a:fontRef>
+        </p:style>
+        <p:txBody>
+          <a:bodyPr rtlCol="0" anchor="ctr" wrap="square" lIns="19050" rIns="19050" tIns="19050" bIns="19050"/>
+          <a:lstStyle/>
+          <a:p>
+            <a:pPr algn="ctr">
+              <a:lnSpc>
+                <a:spcPct val="122000"/>
+              </a:lnSpc>
+            </a:pPr>
+            <a:r>
+              <a:rPr sz="1300" b="1">
+                <a:solidFill>
+                  <a:srgbClr val="F5F5F8"/>
+                </a:solidFill>
+                <a:latin typeface="Amazon Ember"/>
+                <a:ea typeface="メイリオ"/>
+                <a:cs typeface="メイリオ"/>
+              </a:rPr>
+              <a:t>32 KiB</a:t>
+            </a:r>
+          </a:p>
+        </p:txBody>
+      </p:sp>
+      <p:cxnSp>
+        <p:nvCxnSpPr>
+          <p:cNvPr id="12" name="Connector 11"/>
+          <p:cNvCxnSpPr/>
+          <p:nvPr/>
+        </p:nvCxnSpPr>
+        <p:spPr>
+          <a:xfrm>
+            <a:off x="2981325" y="1952625"/>
+            <a:ext cx="1143000" cy="0"/>
+          </a:xfrm>
+          <a:prstGeom prst="line">
+            <a:avLst/>
+          </a:prstGeom>
+          <a:ln w="31750">
+            <a:solidFill>
+              <a:srgbClr val="FBD332"/>
+            </a:solidFill>
+            <a:tailEnd type="triangle" w="med" len="med"/>
+          </a:ln>
+          <a:effectLst/>
+        </p:spPr>
+        <p:style>
+          <a:lnRef idx="2">
+            <a:schemeClr val="accent1"/>
+          </a:lnRef>
+          <a:fillRef idx="0">
+            <a:schemeClr val="accent1"/>
+          </a:fillRef>
+          <a:effectRef idx="1">
+            <a:schemeClr val="accent1"/>
+          </a:effectRef>
+          <a:fontRef idx="minor">
+            <a:schemeClr val="tx1"/>
+          </a:fontRef>
+        </p:style>
+      </p:cxnSp>
+      <p:cxnSp>
+        <p:nvCxnSpPr>
+          <p:cNvPr id="13" name="Connector 12"/>
+          <p:cNvCxnSpPr/>
+          <p:nvPr/>
+        </p:nvCxnSpPr>
+        <p:spPr>
+          <a:xfrm>
+            <a:off x="8067675" y="1952625"/>
+            <a:ext cx="1143000" cy="0"/>
+          </a:xfrm>
+          <a:prstGeom prst="line">
+            <a:avLst/>
+          </a:prstGeom>
+          <a:ln w="31750">
+            <a:solidFill>
+              <a:srgbClr val="FBD332"/>
+            </a:solidFill>
+            <a:tailEnd type="triangle" w="med" len="med"/>
+          </a:ln>
+          <a:effectLst/>
+        </p:spPr>
+        <p:style>
+          <a:lnRef idx="2">
+            <a:schemeClr val="accent1"/>
+          </a:lnRef>
+          <a:fillRef idx="0">
+            <a:schemeClr val="accent1"/>
+          </a:fillRef>
+          <a:effectRef idx="1">
+            <a:schemeClr val="accent1"/>
+          </a:effectRef>
+          <a:fontRef idx="minor">
+            <a:schemeClr val="tx1"/>
+          </a:fontRef>
+        </p:style>
+      </p:cxnSp>
+      <p:sp>
+        <p:nvSpPr>
+          <p:cNvPr id="14" name="TextBox 13"/>
+          <p:cNvSpPr txBox="1"/>
+          <p:nvPr/>
+        </p:nvSpPr>
+        <p:spPr>
+          <a:xfrm>
+            <a:off x="2981325" y="2047875"/>
+            <a:ext cx="1143000" cy="476250"/>
+          </a:xfrm>
+          <a:prstGeom prst="rect">
+            <a:avLst/>
+          </a:prstGeom>
+          <a:noFill/>
+        </p:spPr>
+        <p:txBody>
+          <a:bodyPr wrap="square" lIns="0" rIns="0" tIns="0" bIns="0" anchor="ctr">
+            <a:spAutoFit/>
+          </a:bodyPr>
+          <a:lstStyle/>
+          <a:p>
+            <a:pPr algn="ctr">
+              <a:lnSpc>
+                <a:spcPct val="122000"/>
+              </a:lnSpc>
+            </a:pPr>
+            <a:r>
+              <a:rPr sz="1400" b="0">
+                <a:solidFill>
+                  <a:srgbClr val="FBD332"/>
+                </a:solidFill>
+                <a:latin typeface="Amazon Ember"/>
+                <a:ea typeface="メイリオ"/>
+                <a:cs typeface="メイリオ"/>
+              </a:rPr>
+              <a:t>copy 1</a:t>
+            </a:r>
+          </a:p>
+          <a:p>
+            <a:pPr algn="ctr">
+              <a:lnSpc>
+                <a:spcPct val="122000"/>
+              </a:lnSpc>
+            </a:pPr>
+            <a:r>
+              <a:rPr sz="1400" b="0">
+                <a:solidFill>
+                  <a:srgbClr val="FBD332"/>
+                </a:solidFill>
+                <a:latin typeface="Amazon Ember"/>
+                <a:ea typeface="メイリオ"/>
+                <a:cs typeface="メイリオ"/>
+              </a:rPr>
+              <a:t>(sender)</a:t>
+            </a:r>
+          </a:p>
+        </p:txBody>
+      </p:sp>
+      <p:sp>
+        <p:nvSpPr>
+          <p:cNvPr id="15" name="TextBox 14"/>
+          <p:cNvSpPr txBox="1"/>
+          <p:nvPr/>
+        </p:nvSpPr>
+        <p:spPr>
+          <a:xfrm>
+            <a:off x="8067675" y="2047875"/>
+            <a:ext cx="1143000" cy="476250"/>
+          </a:xfrm>
+          <a:prstGeom prst="rect">
+            <a:avLst/>
+          </a:prstGeom>
+          <a:noFill/>
+        </p:spPr>
+        <p:txBody>
+          <a:bodyPr wrap="square" lIns="0" rIns="0" tIns="0" bIns="0" anchor="ctr">
+            <a:spAutoFit/>
+          </a:bodyPr>
+          <a:lstStyle/>
+          <a:p>
+            <a:pPr algn="ctr">
+              <a:lnSpc>
+                <a:spcPct val="122000"/>
+              </a:lnSpc>
+            </a:pPr>
+            <a:r>
+              <a:rPr sz="1400" b="0">
+                <a:solidFill>
+                  <a:srgbClr val="FBD332"/>
+                </a:solidFill>
+                <a:latin typeface="Amazon Ember"/>
+                <a:ea typeface="メイリオ"/>
+                <a:cs typeface="メイリオ"/>
+              </a:rPr>
+              <a:t>copy 2</a:t>
+            </a:r>
+          </a:p>
+          <a:p>
+            <a:pPr algn="ctr">
+              <a:lnSpc>
+                <a:spcPct val="122000"/>
+              </a:lnSpc>
+            </a:pPr>
+            <a:r>
+              <a:rPr sz="1400" b="0">
+                <a:solidFill>
+                  <a:srgbClr val="FBD332"/>
+                </a:solidFill>
+                <a:latin typeface="Amazon Ember"/>
+                <a:ea typeface="メイリオ"/>
+                <a:cs typeface="メイリオ"/>
+              </a:rPr>
+              <a:t>(receiver)</a:t>
+            </a:r>
+          </a:p>
+        </p:txBody>
+      </p:sp>
+      <p:sp>
+        <p:nvSpPr>
+          <p:cNvPr id="16" name="Rounded Rectangle 15"/>
+          <p:cNvSpPr/>
+          <p:nvPr/>
+        </p:nvSpPr>
+        <p:spPr>
+          <a:xfrm>
+            <a:off x="409575" y="3143250"/>
+            <a:ext cx="11372850" cy="1238250"/>
+          </a:xfrm>
+          <a:prstGeom prst="roundRect">
+            <a:avLst>
+              <a:gd name="adj" fmla="val 5000"/>
+            </a:avLst>
+          </a:prstGeom>
+          <a:solidFill>
+            <a:srgbClr val="161A1E"/>
+          </a:solidFill>
+          <a:ln w="15875">
+            <a:solidFill>
+              <a:srgbClr val="464A50"/>
+            </a:solidFill>
+          </a:ln>
+          <a:effectLst/>
+        </p:spPr>
+        <p:style>
+          <a:lnRef idx="1">
+            <a:schemeClr val="accent1"/>
+          </a:lnRef>
+          <a:fillRef idx="3">
+            <a:schemeClr val="accent1"/>
+          </a:fillRef>
+          <a:effectRef idx="2">
+            <a:schemeClr val="accent1"/>
+          </a:effectRef>
+          <a:fontRef idx="minor">
+            <a:schemeClr val="lt1"/>
+          </a:fontRef>
+        </p:style>
+        <p:txBody>
+          <a:bodyPr rtlCol="0" anchor="ctr"/>
+          <a:lstStyle/>
+          <a:p>
+            <a:pPr algn="ctr"/>
+          </a:p>
+        </p:txBody>
+      </p:sp>
+      <p:sp>
+        <p:nvSpPr>
+          <p:cNvPr id="17" name="TextBox 16"/>
+          <p:cNvSpPr txBox="1"/>
+          <p:nvPr/>
+        </p:nvSpPr>
+        <p:spPr>
+          <a:xfrm>
+            <a:off x="600075" y="3286125"/>
+            <a:ext cx="10991850" cy="285750"/>
+          </a:xfrm>
+          <a:prstGeom prst="rect">
+            <a:avLst/>
+          </a:prstGeom>
+          <a:noFill/>
+        </p:spPr>
+        <p:txBody>
+          <a:bodyPr wrap="square" lIns="0" rIns="0" tIns="0" bIns="0" anchor="ctr">
+            <a:spAutoFit/>
+          </a:bodyPr>
+          <a:lstStyle/>
+          <a:p>
+            <a:pPr algn="l">
+              <a:lnSpc>
+                <a:spcPct val="122000"/>
+              </a:lnSpc>
+            </a:pPr>
+            <a:r>
+              <a:rPr sz="1600" b="0">
+                <a:solidFill>
+                  <a:srgbClr val="F5F5F8"/>
+                </a:solidFill>
+                <a:latin typeface="Amazon Ember"/>
+                <a:ea typeface="メイリオ"/>
+                <a:cs typeface="メイリオ"/>
+              </a:rPr>
+              <a:t>per piece: sender copies in, receiver copies out, buffer reused</a:t>
+            </a:r>
+          </a:p>
+        </p:txBody>
+      </p:sp>
+      <p:sp>
+        <p:nvSpPr>
+          <p:cNvPr id="18" name="TextBox 17"/>
+          <p:cNvSpPr txBox="1"/>
+          <p:nvPr/>
+        </p:nvSpPr>
+        <p:spPr>
+          <a:xfrm>
+            <a:off x="600075" y="3714750"/>
+            <a:ext cx="10991850" cy="571500"/>
+          </a:xfrm>
+          <a:prstGeom prst="rect">
+            <a:avLst/>
+          </a:prstGeom>
+          <a:noFill/>
+        </p:spPr>
+        <p:txBody>
+          <a:bodyPr wrap="square" lIns="0" rIns="0" tIns="0" bIns="0" anchor="ctr">
+            <a:spAutoFit/>
+          </a:bodyPr>
+          <a:lstStyle/>
+          <a:p>
+            <a:pPr algn="l">
+              <a:lnSpc>
+                <a:spcPct val="122000"/>
+              </a:lnSpc>
+            </a:pPr>
+            <a:r>
+              <a:rPr sz="1500" b="0">
+                <a:solidFill>
+                  <a:srgbClr val="96969E"/>
+                </a:solidFill>
+                <a:latin typeface="Amazon Ember"/>
+                <a:ea typeface="メイリオ"/>
+                <a:cs typeface="メイリオ"/>
+              </a:rPr>
+              <a:t>repeated until the whole message is across</a:t>
+            </a:r>
+          </a:p>
+          <a:p>
+            <a:pPr algn="l">
+              <a:lnSpc>
+                <a:spcPct val="122000"/>
+              </a:lnSpc>
+            </a:pPr>
+            <a:r>
+              <a:rPr sz="1500" b="0">
+                <a:solidFill>
+                  <a:srgbClr val="96969E"/>
+                </a:solidFill>
+                <a:latin typeface="Amazon Ember"/>
+                <a:ea typeface="メイリオ"/>
+                <a:cs typeface="メイリオ"/>
+              </a:rPr>
+              <a:t>(2 copies per piece, versus 1 copy with CUDA IPC)</a:t>
             </a:r>
           </a:p>
         </p:txBody>

</xml_diff>

<commit_message>
741e79cf2e9bf2: redraw efa-shm as owner lanes (SGLang, NIXL, libfabric efa, libfabric shm)
</commit_message>
<xml_diff>
--- a/zenn/articles/741e79cf2e9bf2/source/figs.pptx
+++ b/zenn/articles/741e79cf2e9bf2/source/figs.pptx
@@ -7570,7 +7570,7 @@
                 <a:ea typeface="メイリオ"/>
                 <a:cs typeface="メイリオ"/>
               </a:rPr>
-              <a:t>The efa provider hands a same-node peer to shm</a:t>
+              <a:t>Who does what when NIXL writes to a same-node peer</a:t>
             </a:r>
           </a:p>
         </p:txBody>
@@ -7611,7 +7611,7 @@
                 <a:ea typeface="メイリオ"/>
                 <a:cs typeface="メイリオ"/>
               </a:rPr>
-              <a:t>FI_EFA_ENABLE_SHM_TRANSFER decides whether the shm path exists</a:t>
+              <a:t>FI_REMOTE_CQ_DATA is a libfabric flag; NIXL sets it, the libfabric providers act on it</a:t>
             </a:r>
           </a:p>
         </p:txBody>
@@ -7624,8 +7624,56 @@
         </p:nvSpPr>
         <p:spPr>
           <a:xfrm>
-            <a:off x="409575" y="1238250"/>
-            <a:ext cx="3429000" cy="666750"/>
+            <a:off x="409575" y="1123950"/>
+            <a:ext cx="11372850" cy="971550"/>
+          </a:xfrm>
+          <a:prstGeom prst="roundRect">
+            <a:avLst>
+              <a:gd name="adj" fmla="val 4000"/>
+            </a:avLst>
+          </a:prstGeom>
+          <a:solidFill>
+            <a:srgbClr val="161A1E"/>
+          </a:solidFill>
+          <a:ln w="15875">
+            <a:solidFill>
+              <a:srgbClr val="464A50"/>
+            </a:solidFill>
+          </a:ln>
+          <a:effectLst/>
+        </p:spPr>
+        <p:style>
+          <a:lnRef idx="1">
+            <a:schemeClr val="accent1"/>
+          </a:lnRef>
+          <a:fillRef idx="3">
+            <a:schemeClr val="accent1"/>
+          </a:fillRef>
+          <a:effectRef idx="2">
+            <a:schemeClr val="accent1"/>
+          </a:effectRef>
+          <a:fontRef idx="minor">
+            <a:schemeClr val="lt1"/>
+          </a:fontRef>
+        </p:style>
+        <p:txBody>
+          <a:bodyPr rtlCol="0" anchor="ctr"/>
+          <a:lstStyle/>
+          <a:p>
+            <a:pPr algn="ctr"/>
+          </a:p>
+        </p:txBody>
+      </p:sp>
+      <p:sp>
+        <p:nvSpPr>
+          <p:cNvPr id="5" name="Rounded Rectangle 4"/>
+          <p:cNvSpPr/>
+          <p:nvPr/>
+        </p:nvSpPr>
+        <p:spPr>
+          <a:xfrm>
+            <a:off x="523875" y="1238250"/>
+            <a:ext cx="1905000" cy="742950"/>
           </a:xfrm>
           <a:prstGeom prst="roundRect">
             <a:avLst>
@@ -7633,11 +7681,11 @@
             </a:avLst>
           </a:prstGeom>
           <a:solidFill>
-            <a:srgbClr val="102C48"/>
+            <a:srgbClr val="124022"/>
           </a:solidFill>
           <a:ln w="15875">
             <a:solidFill>
-              <a:srgbClr val="2896F0"/>
+              <a:srgbClr val="24A046"/>
             </a:solidFill>
           </a:ln>
           <a:effectLst/>
@@ -7666,7 +7714,7 @@
               </a:lnSpc>
             </a:pPr>
             <a:r>
-              <a:rPr sz="1600" b="1">
+              <a:rPr sz="1500" b="1">
                 <a:solidFill>
                   <a:srgbClr val="F5F5F8"/>
                 </a:solidFill>
@@ -7674,39 +7722,69 @@
                 <a:ea typeface="メイリオ"/>
                 <a:cs typeface="メイリオ"/>
               </a:rPr>
-              <a:t>write from NIXL</a:t>
-            </a:r>
-          </a:p>
-          <a:p>
-            <a:pPr algn="ctr">
-              <a:lnSpc>
-                <a:spcPct val="122000"/>
-              </a:lnSpc>
-            </a:pPr>
-            <a:r>
-              <a:rPr sz="1600" b="1">
-                <a:solidFill>
-                  <a:srgbClr val="F5F5F8"/>
-                </a:solidFill>
-                <a:latin typeface="Amazon Ember"/>
-                <a:ea typeface="メイリオ"/>
-                <a:cs typeface="メイリオ"/>
-              </a:rPr>
-              <a:t>(FI_REMOTE_CQ_DATA)</a:t>
-            </a:r>
-          </a:p>
-        </p:txBody>
-      </p:sp>
-      <p:sp>
-        <p:nvSpPr>
-          <p:cNvPr id="5" name="Rounded Rectangle 4"/>
+              <a:t>SGLang</a:t>
+            </a:r>
+          </a:p>
+        </p:txBody>
+      </p:sp>
+      <p:sp>
+        <p:nvSpPr>
+          <p:cNvPr id="6" name="Rounded Rectangle 5"/>
           <p:cNvSpPr/>
           <p:nvPr/>
         </p:nvSpPr>
         <p:spPr>
           <a:xfrm>
-            <a:off x="4381500" y="1238250"/>
-            <a:ext cx="3429000" cy="666750"/>
+            <a:off x="409575" y="2190750"/>
+            <a:ext cx="11372850" cy="971550"/>
+          </a:xfrm>
+          <a:prstGeom prst="roundRect">
+            <a:avLst>
+              <a:gd name="adj" fmla="val 4000"/>
+            </a:avLst>
+          </a:prstGeom>
+          <a:solidFill>
+            <a:srgbClr val="161A1E"/>
+          </a:solidFill>
+          <a:ln w="15875">
+            <a:solidFill>
+              <a:srgbClr val="464A50"/>
+            </a:solidFill>
+          </a:ln>
+          <a:effectLst/>
+        </p:spPr>
+        <p:style>
+          <a:lnRef idx="1">
+            <a:schemeClr val="accent1"/>
+          </a:lnRef>
+          <a:fillRef idx="3">
+            <a:schemeClr val="accent1"/>
+          </a:fillRef>
+          <a:effectRef idx="2">
+            <a:schemeClr val="accent1"/>
+          </a:effectRef>
+          <a:fontRef idx="minor">
+            <a:schemeClr val="lt1"/>
+          </a:fontRef>
+        </p:style>
+        <p:txBody>
+          <a:bodyPr rtlCol="0" anchor="ctr"/>
+          <a:lstStyle/>
+          <a:p>
+            <a:pPr algn="ctr"/>
+          </a:p>
+        </p:txBody>
+      </p:sp>
+      <p:sp>
+        <p:nvSpPr>
+          <p:cNvPr id="7" name="Rounded Rectangle 6"/>
+          <p:cNvSpPr/>
+          <p:nvPr/>
+        </p:nvSpPr>
+        <p:spPr>
+          <a:xfrm>
+            <a:off x="523875" y="2305050"/>
+            <a:ext cx="1905000" cy="742950"/>
           </a:xfrm>
           <a:prstGeom prst="roundRect">
             <a:avLst>
@@ -7747,7 +7825,7 @@
               </a:lnSpc>
             </a:pPr>
             <a:r>
-              <a:rPr sz="1600" b="1">
+              <a:rPr sz="1500" b="1">
                 <a:solidFill>
                   <a:srgbClr val="F5F5F8"/>
                 </a:solidFill>
@@ -7755,17 +7833,17 @@
                 <a:ea typeface="メイリオ"/>
                 <a:cs typeface="メイリオ"/>
               </a:rPr>
-              <a:t>efa provider</a:t>
-            </a:r>
-          </a:p>
-          <a:p>
-            <a:pPr algn="ctr">
-              <a:lnSpc>
-                <a:spcPct val="122000"/>
-              </a:lnSpc>
-            </a:pPr>
-            <a:r>
-              <a:rPr sz="1600" b="1">
+              <a:t>NIXL</a:t>
+            </a:r>
+          </a:p>
+          <a:p>
+            <a:pPr algn="ctr">
+              <a:lnSpc>
+                <a:spcPct val="122000"/>
+              </a:lnSpc>
+            </a:pPr>
+            <a:r>
+              <a:rPr sz="1500" b="1">
                 <a:solidFill>
                   <a:srgbClr val="F5F5F8"/>
                 </a:solidFill>
@@ -7773,58 +7851,69 @@
                 <a:ea typeface="メイリオ"/>
                 <a:cs typeface="メイリオ"/>
               </a:rPr>
-              <a:t>is the peer local?</a:t>
-            </a:r>
-          </a:p>
-        </p:txBody>
-      </p:sp>
-      <p:cxnSp>
-        <p:nvCxnSpPr>
-          <p:cNvPr id="6" name="Connector 5"/>
-          <p:cNvCxnSpPr/>
-          <p:nvPr/>
-        </p:nvCxnSpPr>
-        <p:spPr>
-          <a:xfrm>
-            <a:off x="3838575" y="1571625"/>
-            <a:ext cx="542925" cy="0"/>
-          </a:xfrm>
-          <a:prstGeom prst="line">
-            <a:avLst/>
-          </a:prstGeom>
-          <a:ln w="25400">
-            <a:solidFill>
-              <a:srgbClr val="F5F5F8"/>
-            </a:solidFill>
-            <a:tailEnd type="triangle" w="med" len="med"/>
-          </a:ln>
-          <a:effectLst/>
-        </p:spPr>
-        <p:style>
-          <a:lnRef idx="2">
-            <a:schemeClr val="accent1"/>
-          </a:lnRef>
-          <a:fillRef idx="0">
-            <a:schemeClr val="accent1"/>
-          </a:fillRef>
-          <a:effectRef idx="1">
-            <a:schemeClr val="accent1"/>
-          </a:effectRef>
-          <a:fontRef idx="minor">
-            <a:schemeClr val="tx1"/>
-          </a:fontRef>
-        </p:style>
-      </p:cxnSp>
-      <p:sp>
-        <p:nvSpPr>
-          <p:cNvPr id="7" name="Rounded Rectangle 6"/>
+              <a:t>LIBFABRIC backend</a:t>
+            </a:r>
+          </a:p>
+        </p:txBody>
+      </p:sp>
+      <p:sp>
+        <p:nvSpPr>
+          <p:cNvPr id="8" name="Rounded Rectangle 7"/>
           <p:cNvSpPr/>
           <p:nvPr/>
         </p:nvSpPr>
         <p:spPr>
           <a:xfrm>
-            <a:off x="8353425" y="1143000"/>
-            <a:ext cx="3429000" cy="857250"/>
+            <a:off x="409575" y="3257550"/>
+            <a:ext cx="11372850" cy="971550"/>
+          </a:xfrm>
+          <a:prstGeom prst="roundRect">
+            <a:avLst>
+              <a:gd name="adj" fmla="val 4000"/>
+            </a:avLst>
+          </a:prstGeom>
+          <a:solidFill>
+            <a:srgbClr val="161A1E"/>
+          </a:solidFill>
+          <a:ln w="15875">
+            <a:solidFill>
+              <a:srgbClr val="464A50"/>
+            </a:solidFill>
+          </a:ln>
+          <a:effectLst/>
+        </p:spPr>
+        <p:style>
+          <a:lnRef idx="1">
+            <a:schemeClr val="accent1"/>
+          </a:lnRef>
+          <a:fillRef idx="3">
+            <a:schemeClr val="accent1"/>
+          </a:fillRef>
+          <a:effectRef idx="2">
+            <a:schemeClr val="accent1"/>
+          </a:effectRef>
+          <a:fontRef idx="minor">
+            <a:schemeClr val="lt1"/>
+          </a:fontRef>
+        </p:style>
+        <p:txBody>
+          <a:bodyPr rtlCol="0" anchor="ctr"/>
+          <a:lstStyle/>
+          <a:p>
+            <a:pPr algn="ctr"/>
+          </a:p>
+        </p:txBody>
+      </p:sp>
+      <p:sp>
+        <p:nvSpPr>
+          <p:cNvPr id="9" name="Rounded Rectangle 8"/>
+          <p:cNvSpPr/>
+          <p:nvPr/>
+        </p:nvSpPr>
+        <p:spPr>
+          <a:xfrm>
+            <a:off x="523875" y="3371850"/>
+            <a:ext cx="1905000" cy="742950"/>
           </a:xfrm>
           <a:prstGeom prst="roundRect">
             <a:avLst>
@@ -7865,7 +7954,7 @@
               </a:lnSpc>
             </a:pPr>
             <a:r>
-              <a:rPr sz="1600" b="1">
+              <a:rPr sz="1500" b="1">
                 <a:solidFill>
                   <a:srgbClr val="F5F5F8"/>
                 </a:solidFill>
@@ -7873,17 +7962,17 @@
                 <a:ea typeface="メイリオ"/>
                 <a:cs typeface="メイリオ"/>
               </a:rPr>
-              <a:t>default (=1)</a:t>
-            </a:r>
-          </a:p>
-          <a:p>
-            <a:pPr algn="ctr">
-              <a:lnSpc>
-                <a:spcPct val="122000"/>
-              </a:lnSpc>
-            </a:pPr>
-            <a:r>
-              <a:rPr sz="1600" b="1">
+              <a:t>libfabric</a:t>
+            </a:r>
+          </a:p>
+          <a:p>
+            <a:pPr algn="ctr">
+              <a:lnSpc>
+                <a:spcPct val="122000"/>
+              </a:lnSpc>
+            </a:pPr>
+            <a:r>
+              <a:rPr sz="1500" b="1">
                 <a:solidFill>
                   <a:srgbClr val="F5F5F8"/>
                 </a:solidFill>
@@ -7891,21 +7980,69 @@
                 <a:ea typeface="メイリオ"/>
                 <a:cs typeface="メイリオ"/>
               </a:rPr>
-              <a:t>shm provider</a:t>
-            </a:r>
-          </a:p>
-        </p:txBody>
-      </p:sp>
-      <p:sp>
-        <p:nvSpPr>
-          <p:cNvPr id="8" name="Rounded Rectangle 7"/>
+              <a:t>efa provider</a:t>
+            </a:r>
+          </a:p>
+        </p:txBody>
+      </p:sp>
+      <p:sp>
+        <p:nvSpPr>
+          <p:cNvPr id="10" name="Rounded Rectangle 9"/>
           <p:cNvSpPr/>
           <p:nvPr/>
         </p:nvSpPr>
         <p:spPr>
           <a:xfrm>
-            <a:off x="8353425" y="2381250"/>
-            <a:ext cx="3429000" cy="857250"/>
+            <a:off x="409575" y="4324350"/>
+            <a:ext cx="11372850" cy="971550"/>
+          </a:xfrm>
+          <a:prstGeom prst="roundRect">
+            <a:avLst>
+              <a:gd name="adj" fmla="val 4000"/>
+            </a:avLst>
+          </a:prstGeom>
+          <a:solidFill>
+            <a:srgbClr val="161A1E"/>
+          </a:solidFill>
+          <a:ln w="15875">
+            <a:solidFill>
+              <a:srgbClr val="464A50"/>
+            </a:solidFill>
+          </a:ln>
+          <a:effectLst/>
+        </p:spPr>
+        <p:style>
+          <a:lnRef idx="1">
+            <a:schemeClr val="accent1"/>
+          </a:lnRef>
+          <a:fillRef idx="3">
+            <a:schemeClr val="accent1"/>
+          </a:fillRef>
+          <a:effectRef idx="2">
+            <a:schemeClr val="accent1"/>
+          </a:effectRef>
+          <a:fontRef idx="minor">
+            <a:schemeClr val="lt1"/>
+          </a:fontRef>
+        </p:style>
+        <p:txBody>
+          <a:bodyPr rtlCol="0" anchor="ctr"/>
+          <a:lstStyle/>
+          <a:p>
+            <a:pPr algn="ctr"/>
+          </a:p>
+        </p:txBody>
+      </p:sp>
+      <p:sp>
+        <p:nvSpPr>
+          <p:cNvPr id="11" name="Rounded Rectangle 10"/>
+          <p:cNvSpPr/>
+          <p:nvPr/>
+        </p:nvSpPr>
+        <p:spPr>
+          <a:xfrm>
+            <a:off x="523875" y="4438650"/>
+            <a:ext cx="1905000" cy="742950"/>
           </a:xfrm>
           <a:prstGeom prst="roundRect">
             <a:avLst>
@@ -7913,11 +8050,92 @@
             </a:avLst>
           </a:prstGeom>
           <a:solidFill>
+            <a:srgbClr val="50420E"/>
+          </a:solidFill>
+          <a:ln w="15875">
+            <a:solidFill>
+              <a:srgbClr val="FBD332"/>
+            </a:solidFill>
+          </a:ln>
+          <a:effectLst/>
+        </p:spPr>
+        <p:style>
+          <a:lnRef idx="1">
+            <a:schemeClr val="accent1"/>
+          </a:lnRef>
+          <a:fillRef idx="3">
+            <a:schemeClr val="accent1"/>
+          </a:fillRef>
+          <a:effectRef idx="2">
+            <a:schemeClr val="accent1"/>
+          </a:effectRef>
+          <a:fontRef idx="minor">
+            <a:schemeClr val="lt1"/>
+          </a:fontRef>
+        </p:style>
+        <p:txBody>
+          <a:bodyPr rtlCol="0" anchor="ctr" wrap="square" lIns="19050" rIns="19050" tIns="19050" bIns="19050"/>
+          <a:lstStyle/>
+          <a:p>
+            <a:pPr algn="ctr">
+              <a:lnSpc>
+                <a:spcPct val="122000"/>
+              </a:lnSpc>
+            </a:pPr>
+            <a:r>
+              <a:rPr sz="1500" b="1">
+                <a:solidFill>
+                  <a:srgbClr val="F5F5F8"/>
+                </a:solidFill>
+                <a:latin typeface="Amazon Ember"/>
+                <a:ea typeface="メイリオ"/>
+                <a:cs typeface="メイリオ"/>
+              </a:rPr>
+              <a:t>libfabric</a:t>
+            </a:r>
+          </a:p>
+          <a:p>
+            <a:pPr algn="ctr">
+              <a:lnSpc>
+                <a:spcPct val="122000"/>
+              </a:lnSpc>
+            </a:pPr>
+            <a:r>
+              <a:rPr sz="1500" b="1">
+                <a:solidFill>
+                  <a:srgbClr val="F5F5F8"/>
+                </a:solidFill>
+                <a:latin typeface="Amazon Ember"/>
+                <a:ea typeface="メイリオ"/>
+                <a:cs typeface="メイリオ"/>
+              </a:rPr>
+              <a:t>shm provider</a:t>
+            </a:r>
+          </a:p>
+        </p:txBody>
+      </p:sp>
+      <p:sp>
+        <p:nvSpPr>
+          <p:cNvPr id="12" name="Rounded Rectangle 11"/>
+          <p:cNvSpPr/>
+          <p:nvPr/>
+        </p:nvSpPr>
+        <p:spPr>
+          <a:xfrm>
+            <a:off x="2762250" y="1323975"/>
+            <a:ext cx="3048000" cy="571500"/>
+          </a:xfrm>
+          <a:prstGeom prst="roundRect">
+            <a:avLst>
+              <a:gd name="adj" fmla="val 10000"/>
+            </a:avLst>
+          </a:prstGeom>
+          <a:solidFill>
             <a:srgbClr val="124022"/>
           </a:solidFill>
           <a:ln w="15875">
             <a:solidFill>
-              <a:srgbClr val="3BD16F"/>
+              <a:srgbClr val="24A046"/>
             </a:solidFill>
           </a:ln>
           <a:effectLst/>
@@ -7954,17 +8172,62 @@
                 <a:ea typeface="メイリオ"/>
                 <a:cs typeface="メイリオ"/>
               </a:rPr>
-              <a:t>FI_EFA_ENABLE_SHM_TRANSFER=0</a:t>
-            </a:r>
-          </a:p>
-          <a:p>
-            <a:pPr algn="ctr">
-              <a:lnSpc>
-                <a:spcPct val="122000"/>
-              </a:lnSpc>
-            </a:pPr>
-            <a:r>
-              <a:rPr sz="1500" b="1">
+              <a:t>send the KV cache</a:t>
+            </a:r>
+          </a:p>
+        </p:txBody>
+      </p:sp>
+      <p:sp>
+        <p:nvSpPr>
+          <p:cNvPr id="13" name="Rounded Rectangle 12"/>
+          <p:cNvSpPr/>
+          <p:nvPr/>
+        </p:nvSpPr>
+        <p:spPr>
+          <a:xfrm>
+            <a:off x="2762250" y="2390775"/>
+            <a:ext cx="3048000" cy="571500"/>
+          </a:xfrm>
+          <a:prstGeom prst="roundRect">
+            <a:avLst>
+              <a:gd name="adj" fmla="val 10000"/>
+            </a:avLst>
+          </a:prstGeom>
+          <a:solidFill>
+            <a:srgbClr val="102C48"/>
+          </a:solidFill>
+          <a:ln w="15875">
+            <a:solidFill>
+              <a:srgbClr val="2896F0"/>
+            </a:solidFill>
+          </a:ln>
+          <a:effectLst/>
+        </p:spPr>
+        <p:style>
+          <a:lnRef idx="1">
+            <a:schemeClr val="accent1"/>
+          </a:lnRef>
+          <a:fillRef idx="3">
+            <a:schemeClr val="accent1"/>
+          </a:fillRef>
+          <a:effectRef idx="2">
+            <a:schemeClr val="accent1"/>
+          </a:effectRef>
+          <a:fontRef idx="minor">
+            <a:schemeClr val="lt1"/>
+          </a:fontRef>
+        </p:style>
+        <p:txBody>
+          <a:bodyPr rtlCol="0" anchor="ctr" wrap="square" lIns="19050" rIns="19050" tIns="19050" bIns="19050"/>
+          <a:lstStyle/>
+          <a:p>
+            <a:pPr algn="ctr">
+              <a:lnSpc>
+                <a:spcPct val="122000"/>
+              </a:lnSpc>
+            </a:pPr>
+            <a:r>
+              <a:rPr sz="1300" b="1">
                 <a:solidFill>
                   <a:srgbClr val="F5F5F8"/>
                 </a:solidFill>
@@ -7972,26 +8235,743 @@
                 <a:ea typeface="メイリオ"/>
                 <a:cs typeface="メイリオ"/>
               </a:rPr>
-              <a:t>EFA device, RDMA write</a:t>
+              <a:t>post an RDMA write</a:t>
+            </a:r>
+          </a:p>
+          <a:p>
+            <a:pPr algn="ctr">
+              <a:lnSpc>
+                <a:spcPct val="122000"/>
+              </a:lnSpc>
+            </a:pPr>
+            <a:r>
+              <a:rPr sz="1300" b="1">
+                <a:solidFill>
+                  <a:srgbClr val="F5F5F8"/>
+                </a:solidFill>
+                <a:latin typeface="Amazon Ember"/>
+                <a:ea typeface="メイリオ"/>
+                <a:cs typeface="メイリオ"/>
+              </a:rPr>
+              <a:t>1.1.0 fi_writedata / 1.4.0 fi_writemsg</a:t>
             </a:r>
           </a:p>
         </p:txBody>
       </p:sp>
       <p:cxnSp>
         <p:nvCxnSpPr>
-          <p:cNvPr id="9" name="Connector 8"/>
+          <p:cNvPr id="14" name="Connector 13"/>
           <p:cNvCxnSpPr/>
           <p:nvPr/>
         </p:nvCxnSpPr>
         <p:spPr>
           <a:xfrm>
-            <a:off x="7810500" y="1524000"/>
-            <a:ext cx="542925" cy="0"/>
+            <a:off x="4286250" y="1895475"/>
+            <a:ext cx="0" cy="495300"/>
           </a:xfrm>
           <a:prstGeom prst="line">
             <a:avLst/>
           </a:prstGeom>
+          <a:ln w="25400">
+            <a:solidFill>
+              <a:srgbClr val="F5F5F8"/>
+            </a:solidFill>
+            <a:tailEnd type="triangle" w="med" len="med"/>
+          </a:ln>
+          <a:effectLst/>
+        </p:spPr>
+        <p:style>
+          <a:lnRef idx="2">
+            <a:schemeClr val="accent1"/>
+          </a:lnRef>
+          <a:fillRef idx="0">
+            <a:schemeClr val="accent1"/>
+          </a:fillRef>
+          <a:effectRef idx="1">
+            <a:schemeClr val="accent1"/>
+          </a:effectRef>
+          <a:fontRef idx="minor">
+            <a:schemeClr val="tx1"/>
+          </a:fontRef>
+        </p:style>
+      </p:cxnSp>
+      <p:sp>
+        <p:nvSpPr>
+          <p:cNvPr id="15" name="Rounded Rectangle 14"/>
+          <p:cNvSpPr/>
+          <p:nvPr/>
+        </p:nvSpPr>
+        <p:spPr>
+          <a:xfrm>
+            <a:off x="6286500" y="2505075"/>
+            <a:ext cx="2381250" cy="342900"/>
+          </a:xfrm>
+          <a:prstGeom prst="roundRect">
+            <a:avLst>
+              <a:gd name="adj" fmla="val 30000"/>
+            </a:avLst>
+          </a:prstGeom>
+          <a:solidFill>
+            <a:srgbClr val="50420E"/>
+          </a:solidFill>
+          <a:ln w="15875">
+            <a:solidFill>
+              <a:srgbClr val="FBD332"/>
+            </a:solidFill>
+          </a:ln>
+          <a:effectLst/>
+        </p:spPr>
+        <p:style>
+          <a:lnRef idx="1">
+            <a:schemeClr val="accent1"/>
+          </a:lnRef>
+          <a:fillRef idx="3">
+            <a:schemeClr val="accent1"/>
+          </a:fillRef>
+          <a:effectRef idx="2">
+            <a:schemeClr val="accent1"/>
+          </a:effectRef>
+          <a:fontRef idx="minor">
+            <a:schemeClr val="lt1"/>
+          </a:fontRef>
+        </p:style>
+        <p:txBody>
+          <a:bodyPr rtlCol="0" anchor="ctr" wrap="square" lIns="19050" rIns="19050" tIns="19050" bIns="19050"/>
+          <a:lstStyle/>
+          <a:p>
+            <a:pPr algn="ctr">
+              <a:lnSpc>
+                <a:spcPct val="122000"/>
+              </a:lnSpc>
+            </a:pPr>
+            <a:r>
+              <a:rPr sz="1400" b="1">
+                <a:solidFill>
+                  <a:srgbClr val="F5F5F8"/>
+                </a:solidFill>
+                <a:latin typeface="Amazon Ember"/>
+                <a:ea typeface="メイリオ"/>
+                <a:cs typeface="メイリオ"/>
+              </a:rPr>
+              <a:t>+ FI_REMOTE_CQ_DATA</a:t>
+            </a:r>
+          </a:p>
+        </p:txBody>
+      </p:sp>
+      <p:cxnSp>
+        <p:nvCxnSpPr>
+          <p:cNvPr id="16" name="Connector 15"/>
+          <p:cNvCxnSpPr/>
+          <p:nvPr/>
+        </p:nvCxnSpPr>
+        <p:spPr>
+          <a:xfrm>
+            <a:off x="5810250" y="2676525"/>
+            <a:ext cx="476250" cy="0"/>
+          </a:xfrm>
+          <a:prstGeom prst="line">
+            <a:avLst/>
+          </a:prstGeom>
+          <a:ln w="25400">
+            <a:solidFill>
+              <a:srgbClr val="FBD332"/>
+            </a:solidFill>
+            <a:tailEnd type="triangle" w="med" len="med"/>
+          </a:ln>
+          <a:effectLst/>
+        </p:spPr>
+        <p:style>
+          <a:lnRef idx="2">
+            <a:schemeClr val="accent1"/>
+          </a:lnRef>
+          <a:fillRef idx="0">
+            <a:schemeClr val="accent1"/>
+          </a:fillRef>
+          <a:effectRef idx="1">
+            <a:schemeClr val="accent1"/>
+          </a:effectRef>
+          <a:fontRef idx="minor">
+            <a:schemeClr val="tx1"/>
+          </a:fontRef>
+        </p:style>
+      </p:cxnSp>
+      <p:sp>
+        <p:nvSpPr>
+          <p:cNvPr id="17" name="Rounded Rectangle 16"/>
+          <p:cNvSpPr/>
+          <p:nvPr/>
+        </p:nvSpPr>
+        <p:spPr>
+          <a:xfrm>
+            <a:off x="6286500" y="3457575"/>
+            <a:ext cx="2381250" cy="571500"/>
+          </a:xfrm>
+          <a:prstGeom prst="roundRect">
+            <a:avLst>
+              <a:gd name="adj" fmla="val 10000"/>
+            </a:avLst>
+          </a:prstGeom>
+          <a:solidFill>
+            <a:srgbClr val="50420E"/>
+          </a:solidFill>
+          <a:ln w="15875">
+            <a:solidFill>
+              <a:srgbClr val="FBD332"/>
+            </a:solidFill>
+          </a:ln>
+          <a:effectLst/>
+        </p:spPr>
+        <p:style>
+          <a:lnRef idx="1">
+            <a:schemeClr val="accent1"/>
+          </a:lnRef>
+          <a:fillRef idx="3">
+            <a:schemeClr val="accent1"/>
+          </a:fillRef>
+          <a:effectRef idx="2">
+            <a:schemeClr val="accent1"/>
+          </a:effectRef>
+          <a:fontRef idx="minor">
+            <a:schemeClr val="lt1"/>
+          </a:fontRef>
+        </p:style>
+        <p:txBody>
+          <a:bodyPr rtlCol="0" anchor="ctr" wrap="square" lIns="19050" rIns="19050" tIns="19050" bIns="19050"/>
+          <a:lstStyle/>
+          <a:p>
+            <a:pPr algn="ctr">
+              <a:lnSpc>
+                <a:spcPct val="122000"/>
+              </a:lnSpc>
+            </a:pPr>
+            <a:r>
+              <a:rPr sz="1500" b="1">
+                <a:solidFill>
+                  <a:srgbClr val="F5F5F8"/>
+                </a:solidFill>
+                <a:latin typeface="Amazon Ember"/>
+                <a:ea typeface="メイリオ"/>
+                <a:cs typeface="メイリオ"/>
+              </a:rPr>
+              <a:t>peer on this node?</a:t>
+            </a:r>
+          </a:p>
+        </p:txBody>
+      </p:sp>
+      <p:cxnSp>
+        <p:nvCxnSpPr>
+          <p:cNvPr id="18" name="Connector 17"/>
+          <p:cNvCxnSpPr/>
+          <p:nvPr/>
+        </p:nvCxnSpPr>
+        <p:spPr>
+          <a:xfrm>
+            <a:off x="7477125" y="2847975"/>
+            <a:ext cx="0" cy="609600"/>
+          </a:xfrm>
+          <a:prstGeom prst="line">
+            <a:avLst/>
+          </a:prstGeom>
+          <a:ln w="25400">
+            <a:solidFill>
+              <a:srgbClr val="FBD332"/>
+            </a:solidFill>
+            <a:tailEnd type="triangle" w="med" len="med"/>
+          </a:ln>
+          <a:effectLst/>
+        </p:spPr>
+        <p:style>
+          <a:lnRef idx="2">
+            <a:schemeClr val="accent1"/>
+          </a:lnRef>
+          <a:fillRef idx="0">
+            <a:schemeClr val="accent1"/>
+          </a:fillRef>
+          <a:effectRef idx="1">
+            <a:schemeClr val="accent1"/>
+          </a:effectRef>
+          <a:fontRef idx="minor">
+            <a:schemeClr val="tx1"/>
+          </a:fontRef>
+        </p:style>
+      </p:cxnSp>
+      <p:sp>
+        <p:nvSpPr>
+          <p:cNvPr id="19" name="Rounded Rectangle 18"/>
+          <p:cNvSpPr/>
+          <p:nvPr/>
+        </p:nvSpPr>
+        <p:spPr>
+          <a:xfrm>
+            <a:off x="9286875" y="3457575"/>
+            <a:ext cx="2381250" cy="571500"/>
+          </a:xfrm>
+          <a:prstGeom prst="roundRect">
+            <a:avLst>
+              <a:gd name="adj" fmla="val 10000"/>
+            </a:avLst>
+          </a:prstGeom>
+          <a:solidFill>
+            <a:srgbClr val="343840"/>
+          </a:solidFill>
+          <a:ln w="15875">
+            <a:solidFill>
+              <a:srgbClr val="3BD16F"/>
+            </a:solidFill>
+          </a:ln>
+          <a:effectLst/>
+        </p:spPr>
+        <p:style>
+          <a:lnRef idx="1">
+            <a:schemeClr val="accent1"/>
+          </a:lnRef>
+          <a:fillRef idx="3">
+            <a:schemeClr val="accent1"/>
+          </a:fillRef>
+          <a:effectRef idx="2">
+            <a:schemeClr val="accent1"/>
+          </a:effectRef>
+          <a:fontRef idx="minor">
+            <a:schemeClr val="lt1"/>
+          </a:fontRef>
+        </p:style>
+        <p:txBody>
+          <a:bodyPr rtlCol="0" anchor="ctr" wrap="square" lIns="19050" rIns="19050" tIns="19050" bIns="19050"/>
+          <a:lstStyle/>
+          <a:p>
+            <a:pPr algn="ctr">
+              <a:lnSpc>
+                <a:spcPct val="122000"/>
+              </a:lnSpc>
+            </a:pPr>
+            <a:r>
+              <a:rPr sz="1400" b="1">
+                <a:solidFill>
+                  <a:srgbClr val="F5F5F8"/>
+                </a:solidFill>
+                <a:latin typeface="Amazon Ember"/>
+                <a:ea typeface="メイリオ"/>
+                <a:cs typeface="メイリオ"/>
+              </a:rPr>
+              <a:t>EFA device</a:t>
+            </a:r>
+          </a:p>
+          <a:p>
+            <a:pPr algn="ctr">
+              <a:lnSpc>
+                <a:spcPct val="122000"/>
+              </a:lnSpc>
+            </a:pPr>
+            <a:r>
+              <a:rPr sz="1400" b="1">
+                <a:solidFill>
+                  <a:srgbClr val="F5F5F8"/>
+                </a:solidFill>
+                <a:latin typeface="Amazon Ember"/>
+                <a:ea typeface="メイリオ"/>
+                <a:cs typeface="メイリオ"/>
+              </a:rPr>
+              <a:t>RDMA write</a:t>
+            </a:r>
+          </a:p>
+        </p:txBody>
+      </p:sp>
+      <p:cxnSp>
+        <p:nvCxnSpPr>
+          <p:cNvPr id="20" name="Connector 19"/>
+          <p:cNvCxnSpPr/>
+          <p:nvPr/>
+        </p:nvCxnSpPr>
+        <p:spPr>
+          <a:xfrm>
+            <a:off x="8667750" y="3743325"/>
+            <a:ext cx="619125" cy="0"/>
+          </a:xfrm>
+          <a:prstGeom prst="line">
+            <a:avLst/>
+          </a:prstGeom>
           <a:ln w="31750">
+            <a:solidFill>
+              <a:srgbClr val="3BD16F"/>
+            </a:solidFill>
+            <a:tailEnd type="triangle" w="med" len="med"/>
+          </a:ln>
+          <a:effectLst/>
+        </p:spPr>
+        <p:style>
+          <a:lnRef idx="2">
+            <a:schemeClr val="accent1"/>
+          </a:lnRef>
+          <a:fillRef idx="0">
+            <a:schemeClr val="accent1"/>
+          </a:fillRef>
+          <a:effectRef idx="1">
+            <a:schemeClr val="accent1"/>
+          </a:effectRef>
+          <a:fontRef idx="minor">
+            <a:schemeClr val="tx1"/>
+          </a:fontRef>
+        </p:style>
+      </p:cxnSp>
+      <p:sp>
+        <p:nvSpPr>
+          <p:cNvPr id="21" name="TextBox 20"/>
+          <p:cNvSpPr txBox="1"/>
+          <p:nvPr/>
+        </p:nvSpPr>
+        <p:spPr>
+          <a:xfrm>
+            <a:off x="8648700" y="3352800"/>
+            <a:ext cx="666750" cy="342900"/>
+          </a:xfrm>
+          <a:prstGeom prst="rect">
+            <a:avLst/>
+          </a:prstGeom>
+          <a:noFill/>
+        </p:spPr>
+        <p:txBody>
+          <a:bodyPr wrap="square" lIns="0" rIns="0" tIns="0" bIns="0" anchor="ctr">
+            <a:spAutoFit/>
+          </a:bodyPr>
+          <a:lstStyle/>
+          <a:p>
+            <a:pPr algn="ctr">
+              <a:lnSpc>
+                <a:spcPct val="122000"/>
+              </a:lnSpc>
+            </a:pPr>
+            <a:r>
+              <a:rPr sz="1100" b="0">
+                <a:solidFill>
+                  <a:srgbClr val="3BD16F"/>
+                </a:solidFill>
+                <a:latin typeface="Amazon Ember"/>
+                <a:ea typeface="メイリオ"/>
+                <a:cs typeface="メイリオ"/>
+              </a:rPr>
+              <a:t>no, or</a:t>
+            </a:r>
+          </a:p>
+          <a:p>
+            <a:pPr algn="ctr">
+              <a:lnSpc>
+                <a:spcPct val="122000"/>
+              </a:lnSpc>
+            </a:pPr>
+            <a:r>
+              <a:rPr sz="1100" b="0">
+                <a:solidFill>
+                  <a:srgbClr val="3BD16F"/>
+                </a:solidFill>
+                <a:latin typeface="Amazon Ember"/>
+                <a:ea typeface="メイリオ"/>
+                <a:cs typeface="メイリオ"/>
+              </a:rPr>
+              <a:t>shm off</a:t>
+            </a:r>
+          </a:p>
+        </p:txBody>
+      </p:sp>
+      <p:sp>
+        <p:nvSpPr>
+          <p:cNvPr id="22" name="Rounded Rectangle 21"/>
+          <p:cNvSpPr/>
+          <p:nvPr/>
+        </p:nvSpPr>
+        <p:spPr>
+          <a:xfrm>
+            <a:off x="6286500" y="4524375"/>
+            <a:ext cx="2381250" cy="571500"/>
+          </a:xfrm>
+          <a:prstGeom prst="roundRect">
+            <a:avLst>
+              <a:gd name="adj" fmla="val 10000"/>
+            </a:avLst>
+          </a:prstGeom>
+          <a:solidFill>
+            <a:srgbClr val="50420E"/>
+          </a:solidFill>
+          <a:ln w="15875">
+            <a:solidFill>
+              <a:srgbClr val="FBD332"/>
+            </a:solidFill>
+          </a:ln>
+          <a:effectLst/>
+        </p:spPr>
+        <p:style>
+          <a:lnRef idx="1">
+            <a:schemeClr val="accent1"/>
+          </a:lnRef>
+          <a:fillRef idx="3">
+            <a:schemeClr val="accent1"/>
+          </a:fillRef>
+          <a:effectRef idx="2">
+            <a:schemeClr val="accent1"/>
+          </a:effectRef>
+          <a:fontRef idx="minor">
+            <a:schemeClr val="lt1"/>
+          </a:fontRef>
+        </p:style>
+        <p:txBody>
+          <a:bodyPr rtlCol="0" anchor="ctr" wrap="square" lIns="19050" rIns="19050" tIns="19050" bIns="19050"/>
+          <a:lstStyle/>
+          <a:p>
+            <a:pPr algn="ctr">
+              <a:lnSpc>
+                <a:spcPct val="122000"/>
+              </a:lnSpc>
+            </a:pPr>
+            <a:r>
+              <a:rPr sz="1400" b="1">
+                <a:solidFill>
+                  <a:srgbClr val="F5F5F8"/>
+                </a:solidFill>
+                <a:latin typeface="Amazon Ember"/>
+                <a:ea typeface="メイリオ"/>
+                <a:cs typeface="メイリオ"/>
+              </a:rPr>
+              <a:t>flag set:</a:t>
+            </a:r>
+          </a:p>
+          <a:p>
+            <a:pPr algn="ctr">
+              <a:lnSpc>
+                <a:spcPct val="122000"/>
+              </a:lnSpc>
+            </a:pPr>
+            <a:r>
+              <a:rPr sz="1400" b="1">
+                <a:solidFill>
+                  <a:srgbClr val="F5F5F8"/>
+                </a:solidFill>
+                <a:latin typeface="Amazon Ember"/>
+                <a:ea typeface="メイリオ"/>
+                <a:cs typeface="メイリオ"/>
+              </a:rPr>
+              <a:t>skip the CMA fast path</a:t>
+            </a:r>
+          </a:p>
+        </p:txBody>
+      </p:sp>
+      <p:cxnSp>
+        <p:nvCxnSpPr>
+          <p:cNvPr id="23" name="Connector 22"/>
+          <p:cNvCxnSpPr/>
+          <p:nvPr/>
+        </p:nvCxnSpPr>
+        <p:spPr>
+          <a:xfrm>
+            <a:off x="7477125" y="4029075"/>
+            <a:ext cx="0" cy="495300"/>
+          </a:xfrm>
+          <a:prstGeom prst="line">
+            <a:avLst/>
+          </a:prstGeom>
+          <a:ln w="31750">
+            <a:solidFill>
+              <a:srgbClr val="FBD332"/>
+            </a:solidFill>
+            <a:tailEnd type="triangle" w="med" len="med"/>
+          </a:ln>
+          <a:effectLst/>
+        </p:spPr>
+        <p:style>
+          <a:lnRef idx="2">
+            <a:schemeClr val="accent1"/>
+          </a:lnRef>
+          <a:fillRef idx="0">
+            <a:schemeClr val="accent1"/>
+          </a:fillRef>
+          <a:effectRef idx="1">
+            <a:schemeClr val="accent1"/>
+          </a:effectRef>
+          <a:fontRef idx="minor">
+            <a:schemeClr val="tx1"/>
+          </a:fontRef>
+        </p:style>
+      </p:cxnSp>
+      <p:sp>
+        <p:nvSpPr>
+          <p:cNvPr id="24" name="TextBox 23"/>
+          <p:cNvSpPr txBox="1"/>
+          <p:nvPr/>
+        </p:nvSpPr>
+        <p:spPr>
+          <a:xfrm>
+            <a:off x="7572375" y="4114800"/>
+            <a:ext cx="1524000" cy="342900"/>
+          </a:xfrm>
+          <a:prstGeom prst="rect">
+            <a:avLst/>
+          </a:prstGeom>
+          <a:noFill/>
+        </p:spPr>
+        <p:txBody>
+          <a:bodyPr wrap="square" lIns="0" rIns="0" tIns="0" bIns="0" anchor="ctr">
+            <a:spAutoFit/>
+          </a:bodyPr>
+          <a:lstStyle/>
+          <a:p>
+            <a:pPr algn="l">
+              <a:lnSpc>
+                <a:spcPct val="122000"/>
+              </a:lnSpc>
+            </a:pPr>
+            <a:r>
+              <a:rPr sz="1200" b="0">
+                <a:solidFill>
+                  <a:srgbClr val="FBD332"/>
+                </a:solidFill>
+                <a:latin typeface="Amazon Ember"/>
+                <a:ea typeface="メイリオ"/>
+                <a:cs typeface="メイリオ"/>
+              </a:rPr>
+              <a:t>yes, default (=1)</a:t>
+            </a:r>
+          </a:p>
+        </p:txBody>
+      </p:sp>
+      <p:sp>
+        <p:nvSpPr>
+          <p:cNvPr id="25" name="Rounded Rectangle 24"/>
+          <p:cNvSpPr/>
+          <p:nvPr/>
+        </p:nvSpPr>
+        <p:spPr>
+          <a:xfrm>
+            <a:off x="9286875" y="4410075"/>
+            <a:ext cx="2381250" cy="361950"/>
+          </a:xfrm>
+          <a:prstGeom prst="roundRect">
+            <a:avLst>
+              <a:gd name="adj" fmla="val 10000"/>
+            </a:avLst>
+          </a:prstGeom>
+          <a:solidFill>
+            <a:srgbClr val="102C48"/>
+          </a:solidFill>
+          <a:ln w="15875">
+            <a:solidFill>
+              <a:srgbClr val="2896F0"/>
+            </a:solidFill>
+          </a:ln>
+          <a:effectLst/>
+        </p:spPr>
+        <p:style>
+          <a:lnRef idx="1">
+            <a:schemeClr val="accent1"/>
+          </a:lnRef>
+          <a:fillRef idx="3">
+            <a:schemeClr val="accent1"/>
+          </a:fillRef>
+          <a:effectRef idx="2">
+            <a:schemeClr val="accent1"/>
+          </a:effectRef>
+          <a:fontRef idx="minor">
+            <a:schemeClr val="lt1"/>
+          </a:fontRef>
+        </p:style>
+        <p:txBody>
+          <a:bodyPr rtlCol="0" anchor="ctr" wrap="square" lIns="19050" rIns="19050" tIns="19050" bIns="19050"/>
+          <a:lstStyle/>
+          <a:p>
+            <a:pPr algn="ctr">
+              <a:lnSpc>
+                <a:spcPct val="122000"/>
+              </a:lnSpc>
+            </a:pPr>
+            <a:r>
+              <a:rPr sz="1300" b="1">
+                <a:solidFill>
+                  <a:srgbClr val="F5F5F8"/>
+                </a:solidFill>
+                <a:latin typeface="Amazon Ember"/>
+                <a:ea typeface="メイリオ"/>
+                <a:cs typeface="メイリオ"/>
+              </a:rPr>
+              <a:t>GPU memory: CUDA IPC</a:t>
+            </a:r>
+          </a:p>
+        </p:txBody>
+      </p:sp>
+      <p:sp>
+        <p:nvSpPr>
+          <p:cNvPr id="26" name="Rounded Rectangle 25"/>
+          <p:cNvSpPr/>
+          <p:nvPr/>
+        </p:nvSpPr>
+        <p:spPr>
+          <a:xfrm>
+            <a:off x="9286875" y="4848225"/>
+            <a:ext cx="2381250" cy="361950"/>
+          </a:xfrm>
+          <a:prstGeom prst="roundRect">
+            <a:avLst>
+              <a:gd name="adj" fmla="val 10000"/>
+            </a:avLst>
+          </a:prstGeom>
+          <a:solidFill>
+            <a:srgbClr val="501816"/>
+          </a:solidFill>
+          <a:ln w="15875">
+            <a:solidFill>
+              <a:srgbClr val="E65046"/>
+            </a:solidFill>
+          </a:ln>
+          <a:effectLst/>
+        </p:spPr>
+        <p:style>
+          <a:lnRef idx="1">
+            <a:schemeClr val="accent1"/>
+          </a:lnRef>
+          <a:fillRef idx="3">
+            <a:schemeClr val="accent1"/>
+          </a:fillRef>
+          <a:effectRef idx="2">
+            <a:schemeClr val="accent1"/>
+          </a:effectRef>
+          <a:fontRef idx="minor">
+            <a:schemeClr val="lt1"/>
+          </a:fontRef>
+        </p:style>
+        <p:txBody>
+          <a:bodyPr rtlCol="0" anchor="ctr" wrap="square" lIns="19050" rIns="19050" tIns="19050" bIns="19050"/>
+          <a:lstStyle/>
+          <a:p>
+            <a:pPr algn="ctr">
+              <a:lnSpc>
+                <a:spcPct val="122000"/>
+              </a:lnSpc>
+            </a:pPr>
+            <a:r>
+              <a:rPr sz="1300" b="1">
+                <a:solidFill>
+                  <a:srgbClr val="F5F5F8"/>
+                </a:solidFill>
+                <a:latin typeface="Amazon Ember"/>
+                <a:ea typeface="メイリオ"/>
+                <a:cs typeface="メイリオ"/>
+              </a:rPr>
+              <a:t>IPC setup fails: SAR</a:t>
+            </a:r>
+          </a:p>
+        </p:txBody>
+      </p:sp>
+      <p:cxnSp>
+        <p:nvCxnSpPr>
+          <p:cNvPr id="27" name="Connector 26"/>
+          <p:cNvCxnSpPr/>
+          <p:nvPr/>
+        </p:nvCxnSpPr>
+        <p:spPr>
+          <a:xfrm flipV="1">
+            <a:off x="8667750" y="4591050"/>
+            <a:ext cx="619125" cy="123825"/>
+          </a:xfrm>
+          <a:prstGeom prst="line">
+            <a:avLst/>
+          </a:prstGeom>
+          <a:ln w="25400">
             <a:solidFill>
               <a:srgbClr val="FBD332"/>
             </a:solidFill>
@@ -8016,21 +8996,21 @@
       </p:cxnSp>
       <p:cxnSp>
         <p:nvCxnSpPr>
-          <p:cNvPr id="10" name="Connector 9"/>
+          <p:cNvPr id="28" name="Connector 27"/>
           <p:cNvCxnSpPr/>
           <p:nvPr/>
         </p:nvCxnSpPr>
         <p:spPr>
           <a:xfrm>
-            <a:off x="7810500" y="1714500"/>
-            <a:ext cx="542925" cy="952500"/>
+            <a:off x="8667750" y="4905375"/>
+            <a:ext cx="619125" cy="123825"/>
           </a:xfrm>
           <a:prstGeom prst="line">
             <a:avLst/>
           </a:prstGeom>
-          <a:ln w="31750">
-            <a:solidFill>
-              <a:srgbClr val="3BD16F"/>
+          <a:ln w="25400">
+            <a:solidFill>
+              <a:srgbClr val="FBD332"/>
             </a:solidFill>
             <a:tailEnd type="triangle" w="med" len="med"/>
           </a:ln>
@@ -8053,26 +9033,26 @@
       </p:cxnSp>
       <p:sp>
         <p:nvSpPr>
-          <p:cNvPr id="11" name="Rounded Rectangle 10"/>
+          <p:cNvPr id="29" name="Rounded Rectangle 28"/>
           <p:cNvSpPr/>
           <p:nvPr/>
         </p:nvSpPr>
         <p:spPr>
           <a:xfrm>
-            <a:off x="409575" y="3810000"/>
-            <a:ext cx="11372850" cy="1428750"/>
+            <a:off x="409575" y="5524500"/>
+            <a:ext cx="247650" cy="190500"/>
           </a:xfrm>
           <a:prstGeom prst="roundRect">
             <a:avLst>
-              <a:gd name="adj" fmla="val 4000"/>
+              <a:gd name="adj" fmla="val 20000"/>
             </a:avLst>
           </a:prstGeom>
           <a:solidFill>
-            <a:srgbClr val="161A1E"/>
+            <a:srgbClr val="124022"/>
           </a:solidFill>
           <a:ln w="15875">
             <a:solidFill>
-              <a:srgbClr val="464A50"/>
+              <a:srgbClr val="24A046"/>
             </a:solidFill>
           </a:ln>
           <a:effectLst/>
@@ -8101,14 +9081,14 @@
       </p:sp>
       <p:sp>
         <p:nvSpPr>
-          <p:cNvPr id="12" name="TextBox 11"/>
+          <p:cNvPr id="30" name="TextBox 29"/>
           <p:cNvSpPr txBox="1"/>
           <p:nvPr/>
         </p:nvSpPr>
         <p:spPr>
           <a:xfrm>
-            <a:off x="600075" y="3905250"/>
-            <a:ext cx="10991850" cy="285750"/>
+            <a:off x="714375" y="5486400"/>
+            <a:ext cx="1238250" cy="266700"/>
           </a:xfrm>
           <a:prstGeom prst="rect">
             <a:avLst/>
@@ -8127,29 +9107,77 @@
               </a:lnSpc>
             </a:pPr>
             <a:r>
-              <a:rPr sz="1700" b="1">
-                <a:solidFill>
-                  <a:srgbClr val="FBD332"/>
-                </a:solidFill>
-                <a:latin typeface="Amazon Ember"/>
-                <a:ea typeface="メイリオ"/>
-                <a:cs typeface="メイリオ"/>
-              </a:rPr>
-              <a:t>shm path</a:t>
-            </a:r>
-          </a:p>
-        </p:txBody>
-      </p:sp>
-      <p:sp>
-        <p:nvSpPr>
-          <p:cNvPr id="13" name="TextBox 12"/>
+              <a:rPr sz="1300" b="0">
+                <a:solidFill>
+                  <a:srgbClr val="F5F5F8"/>
+                </a:solidFill>
+                <a:latin typeface="Amazon Ember"/>
+                <a:ea typeface="メイリオ"/>
+                <a:cs typeface="メイリオ"/>
+              </a:rPr>
+              <a:t>SGLang</a:t>
+            </a:r>
+          </a:p>
+        </p:txBody>
+      </p:sp>
+      <p:sp>
+        <p:nvSpPr>
+          <p:cNvPr id="31" name="Rounded Rectangle 30"/>
+          <p:cNvSpPr/>
+          <p:nvPr/>
+        </p:nvSpPr>
+        <p:spPr>
+          <a:xfrm>
+            <a:off x="2028825" y="5524500"/>
+            <a:ext cx="247650" cy="190500"/>
+          </a:xfrm>
+          <a:prstGeom prst="roundRect">
+            <a:avLst>
+              <a:gd name="adj" fmla="val 20000"/>
+            </a:avLst>
+          </a:prstGeom>
+          <a:solidFill>
+            <a:srgbClr val="102C48"/>
+          </a:solidFill>
+          <a:ln w="15875">
+            <a:solidFill>
+              <a:srgbClr val="2896F0"/>
+            </a:solidFill>
+          </a:ln>
+          <a:effectLst/>
+        </p:spPr>
+        <p:style>
+          <a:lnRef idx="1">
+            <a:schemeClr val="accent1"/>
+          </a:lnRef>
+          <a:fillRef idx="3">
+            <a:schemeClr val="accent1"/>
+          </a:fillRef>
+          <a:effectRef idx="2">
+            <a:schemeClr val="accent1"/>
+          </a:effectRef>
+          <a:fontRef idx="minor">
+            <a:schemeClr val="lt1"/>
+          </a:fontRef>
+        </p:style>
+        <p:txBody>
+          <a:bodyPr rtlCol="0" anchor="ctr"/>
+          <a:lstStyle/>
+          <a:p>
+            <a:pPr algn="ctr"/>
+          </a:p>
+        </p:txBody>
+      </p:sp>
+      <p:sp>
+        <p:nvSpPr>
+          <p:cNvPr id="32" name="TextBox 31"/>
           <p:cNvSpPr txBox="1"/>
           <p:nvPr/>
         </p:nvSpPr>
         <p:spPr>
           <a:xfrm>
-            <a:off x="600075" y="4238625"/>
-            <a:ext cx="10991850" cy="285750"/>
+            <a:off x="2333625" y="5486400"/>
+            <a:ext cx="1238250" cy="266700"/>
           </a:xfrm>
           <a:prstGeom prst="rect">
             <a:avLst/>
@@ -8168,7 +9196,7 @@
               </a:lnSpc>
             </a:pPr>
             <a:r>
-              <a:rPr sz="1500" b="0">
+              <a:rPr sz="1300" b="0">
                 <a:solidFill>
                   <a:srgbClr val="F5F5F8"/>
                 </a:solidFill>
@@ -8176,21 +9204,69 @@
                 <a:ea typeface="メイリオ"/>
                 <a:cs typeface="メイリオ"/>
               </a:rPr>
-              <a:t>GPU memory is handed over with CUDA IPC; the receiving process copies the bytes</a:t>
-            </a:r>
-          </a:p>
-        </p:txBody>
-      </p:sp>
-      <p:sp>
-        <p:nvSpPr>
-          <p:cNvPr id="14" name="TextBox 13"/>
+              <a:t>NIXL</a:t>
+            </a:r>
+          </a:p>
+        </p:txBody>
+      </p:sp>
+      <p:sp>
+        <p:nvSpPr>
+          <p:cNvPr id="33" name="Rounded Rectangle 32"/>
+          <p:cNvSpPr/>
+          <p:nvPr/>
+        </p:nvSpPr>
+        <p:spPr>
+          <a:xfrm>
+            <a:off x="3648075" y="5524500"/>
+            <a:ext cx="247650" cy="190500"/>
+          </a:xfrm>
+          <a:prstGeom prst="roundRect">
+            <a:avLst>
+              <a:gd name="adj" fmla="val 20000"/>
+            </a:avLst>
+          </a:prstGeom>
+          <a:solidFill>
+            <a:srgbClr val="50420E"/>
+          </a:solidFill>
+          <a:ln w="15875">
+            <a:solidFill>
+              <a:srgbClr val="FBD332"/>
+            </a:solidFill>
+          </a:ln>
+          <a:effectLst/>
+        </p:spPr>
+        <p:style>
+          <a:lnRef idx="1">
+            <a:schemeClr val="accent1"/>
+          </a:lnRef>
+          <a:fillRef idx="3">
+            <a:schemeClr val="accent1"/>
+          </a:fillRef>
+          <a:effectRef idx="2">
+            <a:schemeClr val="accent1"/>
+          </a:effectRef>
+          <a:fontRef idx="minor">
+            <a:schemeClr val="lt1"/>
+          </a:fontRef>
+        </p:style>
+        <p:txBody>
+          <a:bodyPr rtlCol="0" anchor="ctr"/>
+          <a:lstStyle/>
+          <a:p>
+            <a:pPr algn="ctr"/>
+          </a:p>
+        </p:txBody>
+      </p:sp>
+      <p:sp>
+        <p:nvSpPr>
+          <p:cNvPr id="34" name="TextBox 33"/>
           <p:cNvSpPr txBox="1"/>
           <p:nvPr/>
         </p:nvSpPr>
         <p:spPr>
           <a:xfrm>
-            <a:off x="600075" y="4714875"/>
-            <a:ext cx="10991850" cy="285750"/>
+            <a:off x="3952875" y="5486400"/>
+            <a:ext cx="1238250" cy="266700"/>
           </a:xfrm>
           <a:prstGeom prst="rect">
             <a:avLst/>
@@ -8209,15 +9285,15 @@
               </a:lnSpc>
             </a:pPr>
             <a:r>
-              <a:rPr sz="1500" b="0">
-                <a:solidFill>
-                  <a:srgbClr val="3BD16F"/>
-                </a:solidFill>
-                <a:latin typeface="Amazon Ember"/>
-                <a:ea typeface="メイリオ"/>
-                <a:cs typeface="メイリオ"/>
-              </a:rPr>
-              <a:t>EFA device path: RDMA write through the EFA device to the same-node peer</a:t>
+              <a:rPr sz="1300" b="0">
+                <a:solidFill>
+                  <a:srgbClr val="F5F5F8"/>
+                </a:solidFill>
+                <a:latin typeface="Amazon Ember"/>
+                <a:ea typeface="メイリオ"/>
+                <a:cs typeface="メイリオ"/>
+              </a:rPr>
+              <a:t>libfabric</a:t>
             </a:r>
           </a:p>
         </p:txBody>

</xml_diff>

<commit_message>
741e79cf2e9bf2: add efa-counter (what rdma_write_bytes counts and where it was read)
</commit_message>
<xml_diff>
--- a/zenn/articles/741e79cf2e9bf2/source/figs.pptx
+++ b/zenn/articles/741e79cf2e9bf2/source/figs.pptx
@@ -24,6 +24,7 @@
     <p:sldId id="266" r:id="rId2"/>
     <p:sldId id="267" r:id="rId20"/>
     <p:sldId id="268" r:id="rId21"/>
+    <p:sldId id="269" r:id="rId22"/>
   </p:sldIdLst>
   <p:sldSz cx="12192000" cy="6858000"/>
   <p:notesSz cx="6858000" cy="9144000"/>
@@ -7524,6 +7525,1755 @@
 </p:sld>
 </file>
 
+<file path=ppt/slides/slide14.xml><?xml version="1.0" encoding="utf-8"?>
+<p:sld xmlns:a="http://schemas.openxmlformats.org/drawingml/2006/main" xmlns:p="http://schemas.openxmlformats.org/presentationml/2006/main" xmlns:r="http://schemas.openxmlformats.org/officeDocument/2006/relationships" showMasterSp="0">
+  <p:cSld>
+    <p:spTree>
+      <p:nvGrpSpPr>
+        <p:cNvPr id="1" name=""/>
+        <p:cNvGrpSpPr/>
+        <p:nvPr/>
+      </p:nvGrpSpPr>
+      <p:grpSpPr/>
+      <p:sp>
+        <p:nvSpPr>
+          <p:cNvPr id="2" name="TextBox 1"/>
+          <p:cNvSpPr txBox="1"/>
+          <p:nvPr/>
+        </p:nvSpPr>
+        <p:spPr>
+          <a:xfrm>
+            <a:off x="409575" y="247650"/>
+            <a:ext cx="11334750" cy="438150"/>
+          </a:xfrm>
+          <a:prstGeom prst="rect">
+            <a:avLst/>
+          </a:prstGeom>
+          <a:noFill/>
+        </p:spPr>
+        <p:txBody>
+          <a:bodyPr wrap="square" lIns="0" rIns="0" tIns="0" bIns="0" anchor="ctr">
+            <a:spAutoFit/>
+          </a:bodyPr>
+          <a:lstStyle/>
+          <a:p>
+            <a:pPr algn="l">
+              <a:lnSpc>
+                <a:spcPct val="122000"/>
+              </a:lnSpc>
+            </a:pPr>
+            <a:r>
+              <a:rPr sz="3000" b="1">
+                <a:solidFill>
+                  <a:srgbClr val="F5F5F8"/>
+                </a:solidFill>
+                <a:latin typeface="Amazon Ember"/>
+                <a:ea typeface="メイリオ"/>
+                <a:cs typeface="メイリオ"/>
+              </a:rPr>
+              <a:t>What was measured, and where</a:t>
+            </a:r>
+          </a:p>
+        </p:txBody>
+      </p:sp>
+      <p:sp>
+        <p:nvSpPr>
+          <p:cNvPr id="3" name="TextBox 2"/>
+          <p:cNvSpPr txBox="1"/>
+          <p:nvPr/>
+        </p:nvSpPr>
+        <p:spPr>
+          <a:xfrm>
+            <a:off x="409575" y="685800"/>
+            <a:ext cx="11334750" cy="247650"/>
+          </a:xfrm>
+          <a:prstGeom prst="rect">
+            <a:avLst/>
+          </a:prstGeom>
+          <a:noFill/>
+        </p:spPr>
+        <p:txBody>
+          <a:bodyPr wrap="square" lIns="0" rIns="0" tIns="0" bIns="0" anchor="ctr">
+            <a:spAutoFit/>
+          </a:bodyPr>
+          <a:lstStyle/>
+          <a:p>
+            <a:pPr algn="l">
+              <a:lnSpc>
+                <a:spcPct val="122000"/>
+              </a:lnSpc>
+            </a:pPr>
+            <a:r>
+              <a:rPr sz="1600" b="0">
+                <a:solidFill>
+                  <a:srgbClr val="96969E"/>
+                </a:solidFill>
+                <a:latin typeface="Amazon Ember"/>
+                <a:ea typeface="メイリオ"/>
+                <a:cs typeface="メイリオ"/>
+              </a:rPr>
+              <a:t>A hardware counter of the EFA device, read through sysfs from a probe Pod on the same node</a:t>
+            </a:r>
+          </a:p>
+        </p:txBody>
+      </p:sp>
+      <p:sp>
+        <p:nvSpPr>
+          <p:cNvPr id="4" name="Rounded Rectangle 3"/>
+          <p:cNvSpPr/>
+          <p:nvPr/>
+        </p:nvSpPr>
+        <p:spPr>
+          <a:xfrm>
+            <a:off x="409575" y="1047750"/>
+            <a:ext cx="7810500" cy="4476750"/>
+          </a:xfrm>
+          <a:prstGeom prst="roundRect">
+            <a:avLst>
+              <a:gd name="adj" fmla="val 3000"/>
+            </a:avLst>
+          </a:prstGeom>
+          <a:solidFill>
+            <a:srgbClr val="161A1E"/>
+          </a:solidFill>
+          <a:ln w="15875">
+            <a:solidFill>
+              <a:srgbClr val="464A50"/>
+            </a:solidFill>
+          </a:ln>
+          <a:effectLst/>
+        </p:spPr>
+        <p:style>
+          <a:lnRef idx="1">
+            <a:schemeClr val="accent1"/>
+          </a:lnRef>
+          <a:fillRef idx="3">
+            <a:schemeClr val="accent1"/>
+          </a:fillRef>
+          <a:effectRef idx="2">
+            <a:schemeClr val="accent1"/>
+          </a:effectRef>
+          <a:fontRef idx="minor">
+            <a:schemeClr val="lt1"/>
+          </a:fontRef>
+        </p:style>
+        <p:txBody>
+          <a:bodyPr rtlCol="0" anchor="ctr"/>
+          <a:lstStyle/>
+          <a:p>
+            <a:pPr algn="ctr"/>
+          </a:p>
+        </p:txBody>
+      </p:sp>
+      <p:sp>
+        <p:nvSpPr>
+          <p:cNvPr id="5" name="TextBox 4"/>
+          <p:cNvSpPr txBox="1"/>
+          <p:nvPr/>
+        </p:nvSpPr>
+        <p:spPr>
+          <a:xfrm>
+            <a:off x="552450" y="1104900"/>
+            <a:ext cx="3810000" cy="247650"/>
+          </a:xfrm>
+          <a:prstGeom prst="rect">
+            <a:avLst/>
+          </a:prstGeom>
+          <a:noFill/>
+        </p:spPr>
+        <p:txBody>
+          <a:bodyPr wrap="square" lIns="0" rIns="0" tIns="0" bIns="0" anchor="ctr">
+            <a:spAutoFit/>
+          </a:bodyPr>
+          <a:lstStyle/>
+          <a:p>
+            <a:pPr algn="l">
+              <a:lnSpc>
+                <a:spcPct val="122000"/>
+              </a:lnSpc>
+            </a:pPr>
+            <a:r>
+              <a:rPr sz="1400" b="0">
+                <a:solidFill>
+                  <a:srgbClr val="96969E"/>
+                </a:solidFill>
+                <a:latin typeface="Amazon Ember"/>
+                <a:ea typeface="メイリオ"/>
+                <a:cs typeface="メイリオ"/>
+              </a:rPr>
+              <a:t>one node</a:t>
+            </a:r>
+          </a:p>
+        </p:txBody>
+      </p:sp>
+      <p:sp>
+        <p:nvSpPr>
+          <p:cNvPr id="6" name="Rounded Rectangle 5"/>
+          <p:cNvSpPr/>
+          <p:nvPr/>
+        </p:nvSpPr>
+        <p:spPr>
+          <a:xfrm>
+            <a:off x="600075" y="1428750"/>
+            <a:ext cx="3619500" cy="1714500"/>
+          </a:xfrm>
+          <a:prstGeom prst="roundRect">
+            <a:avLst>
+              <a:gd name="adj" fmla="val 6000"/>
+            </a:avLst>
+          </a:prstGeom>
+          <a:solidFill>
+            <a:srgbClr val="124022"/>
+          </a:solidFill>
+          <a:ln w="15875">
+            <a:solidFill>
+              <a:srgbClr val="24A046"/>
+            </a:solidFill>
+          </a:ln>
+          <a:effectLst/>
+        </p:spPr>
+        <p:style>
+          <a:lnRef idx="1">
+            <a:schemeClr val="accent1"/>
+          </a:lnRef>
+          <a:fillRef idx="3">
+            <a:schemeClr val="accent1"/>
+          </a:fillRef>
+          <a:effectRef idx="2">
+            <a:schemeClr val="accent1"/>
+          </a:effectRef>
+          <a:fontRef idx="minor">
+            <a:schemeClr val="lt1"/>
+          </a:fontRef>
+        </p:style>
+        <p:txBody>
+          <a:bodyPr rtlCol="0" anchor="ctr"/>
+          <a:lstStyle/>
+          <a:p>
+            <a:pPr algn="ctr"/>
+          </a:p>
+        </p:txBody>
+      </p:sp>
+      <p:sp>
+        <p:nvSpPr>
+          <p:cNvPr id="7" name="TextBox 6"/>
+          <p:cNvSpPr txBox="1"/>
+          <p:nvPr/>
+        </p:nvSpPr>
+        <p:spPr>
+          <a:xfrm>
+            <a:off x="695325" y="1485900"/>
+            <a:ext cx="3429000" cy="247650"/>
+          </a:xfrm>
+          <a:prstGeom prst="rect">
+            <a:avLst/>
+          </a:prstGeom>
+          <a:noFill/>
+        </p:spPr>
+        <p:txBody>
+          <a:bodyPr wrap="square" lIns="0" rIns="0" tIns="0" bIns="0" anchor="ctr">
+            <a:spAutoFit/>
+          </a:bodyPr>
+          <a:lstStyle/>
+          <a:p>
+            <a:pPr algn="ctr">
+              <a:lnSpc>
+                <a:spcPct val="122000"/>
+              </a:lnSpc>
+            </a:pPr>
+            <a:r>
+              <a:rPr sz="1500" b="1">
+                <a:solidFill>
+                  <a:srgbClr val="F5F5F8"/>
+                </a:solidFill>
+                <a:latin typeface="Amazon Ember"/>
+                <a:ea typeface="メイリオ"/>
+                <a:cs typeface="メイリオ"/>
+              </a:rPr>
+              <a:t>engine Pod (no hostNetwork)</a:t>
+            </a:r>
+          </a:p>
+        </p:txBody>
+      </p:sp>
+      <p:sp>
+        <p:nvSpPr>
+          <p:cNvPr id="8" name="Rounded Rectangle 7"/>
+          <p:cNvSpPr/>
+          <p:nvPr/>
+        </p:nvSpPr>
+        <p:spPr>
+          <a:xfrm>
+            <a:off x="790575" y="1828800"/>
+            <a:ext cx="1524000" cy="609600"/>
+          </a:xfrm>
+          <a:prstGeom prst="roundRect">
+            <a:avLst>
+              <a:gd name="adj" fmla="val 10000"/>
+            </a:avLst>
+          </a:prstGeom>
+          <a:solidFill>
+            <a:srgbClr val="343840"/>
+          </a:solidFill>
+          <a:ln w="15875">
+            <a:solidFill>
+              <a:srgbClr val="464A50"/>
+            </a:solidFill>
+          </a:ln>
+          <a:effectLst/>
+        </p:spPr>
+        <p:style>
+          <a:lnRef idx="1">
+            <a:schemeClr val="accent1"/>
+          </a:lnRef>
+          <a:fillRef idx="3">
+            <a:schemeClr val="accent1"/>
+          </a:fillRef>
+          <a:effectRef idx="2">
+            <a:schemeClr val="accent1"/>
+          </a:effectRef>
+          <a:fontRef idx="minor">
+            <a:schemeClr val="lt1"/>
+          </a:fontRef>
+        </p:style>
+        <p:txBody>
+          <a:bodyPr rtlCol="0" anchor="ctr" wrap="square" lIns="19050" rIns="19050" tIns="19050" bIns="19050"/>
+          <a:lstStyle/>
+          <a:p>
+            <a:pPr algn="ctr">
+              <a:lnSpc>
+                <a:spcPct val="122000"/>
+              </a:lnSpc>
+            </a:pPr>
+            <a:r>
+              <a:rPr sz="1500" b="1">
+                <a:solidFill>
+                  <a:srgbClr val="F5F5F8"/>
+                </a:solidFill>
+                <a:latin typeface="Amazon Ember"/>
+                <a:ea typeface="メイリオ"/>
+                <a:cs typeface="メイリオ"/>
+              </a:rPr>
+              <a:t>prefill</a:t>
+            </a:r>
+          </a:p>
+          <a:p>
+            <a:pPr algn="ctr">
+              <a:lnSpc>
+                <a:spcPct val="122000"/>
+              </a:lnSpc>
+            </a:pPr>
+            <a:r>
+              <a:rPr sz="1500" b="1">
+                <a:solidFill>
+                  <a:srgbClr val="F5F5F8"/>
+                </a:solidFill>
+                <a:latin typeface="Amazon Ember"/>
+                <a:ea typeface="メイリオ"/>
+                <a:cs typeface="メイリオ"/>
+              </a:rPr>
+              <a:t>TP0  TP1</a:t>
+            </a:r>
+          </a:p>
+        </p:txBody>
+      </p:sp>
+      <p:sp>
+        <p:nvSpPr>
+          <p:cNvPr id="9" name="Rounded Rectangle 8"/>
+          <p:cNvSpPr/>
+          <p:nvPr/>
+        </p:nvSpPr>
+        <p:spPr>
+          <a:xfrm>
+            <a:off x="2505075" y="1828800"/>
+            <a:ext cx="1524000" cy="609600"/>
+          </a:xfrm>
+          <a:prstGeom prst="roundRect">
+            <a:avLst>
+              <a:gd name="adj" fmla="val 10000"/>
+            </a:avLst>
+          </a:prstGeom>
+          <a:solidFill>
+            <a:srgbClr val="343840"/>
+          </a:solidFill>
+          <a:ln w="15875">
+            <a:solidFill>
+              <a:srgbClr val="464A50"/>
+            </a:solidFill>
+          </a:ln>
+          <a:effectLst/>
+        </p:spPr>
+        <p:style>
+          <a:lnRef idx="1">
+            <a:schemeClr val="accent1"/>
+          </a:lnRef>
+          <a:fillRef idx="3">
+            <a:schemeClr val="accent1"/>
+          </a:fillRef>
+          <a:effectRef idx="2">
+            <a:schemeClr val="accent1"/>
+          </a:effectRef>
+          <a:fontRef idx="minor">
+            <a:schemeClr val="lt1"/>
+          </a:fontRef>
+        </p:style>
+        <p:txBody>
+          <a:bodyPr rtlCol="0" anchor="ctr" wrap="square" lIns="19050" rIns="19050" tIns="19050" bIns="19050"/>
+          <a:lstStyle/>
+          <a:p>
+            <a:pPr algn="ctr">
+              <a:lnSpc>
+                <a:spcPct val="122000"/>
+              </a:lnSpc>
+            </a:pPr>
+            <a:r>
+              <a:rPr sz="1500" b="1">
+                <a:solidFill>
+                  <a:srgbClr val="F5F5F8"/>
+                </a:solidFill>
+                <a:latin typeface="Amazon Ember"/>
+                <a:ea typeface="メイリオ"/>
+                <a:cs typeface="メイリオ"/>
+              </a:rPr>
+              <a:t>decode</a:t>
+            </a:r>
+          </a:p>
+          <a:p>
+            <a:pPr algn="ctr">
+              <a:lnSpc>
+                <a:spcPct val="122000"/>
+              </a:lnSpc>
+            </a:pPr>
+            <a:r>
+              <a:rPr sz="1500" b="1">
+                <a:solidFill>
+                  <a:srgbClr val="F5F5F8"/>
+                </a:solidFill>
+                <a:latin typeface="Amazon Ember"/>
+                <a:ea typeface="メイリオ"/>
+                <a:cs typeface="メイリオ"/>
+              </a:rPr>
+              <a:t>TP0  TP1</a:t>
+            </a:r>
+          </a:p>
+        </p:txBody>
+      </p:sp>
+      <p:sp>
+        <p:nvSpPr>
+          <p:cNvPr id="10" name="TextBox 9"/>
+          <p:cNvSpPr txBox="1"/>
+          <p:nvPr/>
+        </p:nvSpPr>
+        <p:spPr>
+          <a:xfrm>
+            <a:off x="695325" y="2590800"/>
+            <a:ext cx="3429000" cy="438150"/>
+          </a:xfrm>
+          <a:prstGeom prst="rect">
+            <a:avLst/>
+          </a:prstGeom>
+          <a:noFill/>
+        </p:spPr>
+        <p:txBody>
+          <a:bodyPr wrap="square" lIns="0" rIns="0" tIns="0" bIns="0" anchor="ctr">
+            <a:spAutoFit/>
+          </a:bodyPr>
+          <a:lstStyle/>
+          <a:p>
+            <a:pPr algn="ctr">
+              <a:lnSpc>
+                <a:spcPct val="122000"/>
+              </a:lnSpc>
+            </a:pPr>
+            <a:r>
+              <a:rPr sz="1400" b="0">
+                <a:solidFill>
+                  <a:srgbClr val="E65046"/>
+                </a:solidFill>
+                <a:latin typeface="Amazon Ember"/>
+                <a:ea typeface="メイリオ"/>
+                <a:cs typeface="メイリオ"/>
+              </a:rPr>
+              <a:t>hw_counters</a:t>
+            </a:r>
+          </a:p>
+          <a:p>
+            <a:pPr algn="ctr">
+              <a:lnSpc>
+                <a:spcPct val="122000"/>
+              </a:lnSpc>
+            </a:pPr>
+            <a:r>
+              <a:rPr sz="1400" b="0">
+                <a:solidFill>
+                  <a:srgbClr val="E65046"/>
+                </a:solidFill>
+                <a:latin typeface="Amazon Ember"/>
+                <a:ea typeface="メイリオ"/>
+                <a:cs typeface="メイリオ"/>
+              </a:rPr>
+              <a:t>not visible here</a:t>
+            </a:r>
+          </a:p>
+        </p:txBody>
+      </p:sp>
+      <p:sp>
+        <p:nvSpPr>
+          <p:cNvPr id="11" name="Rounded Rectangle 10"/>
+          <p:cNvSpPr/>
+          <p:nvPr/>
+        </p:nvSpPr>
+        <p:spPr>
+          <a:xfrm>
+            <a:off x="600075" y="4286250"/>
+            <a:ext cx="3619500" cy="1047750"/>
+          </a:xfrm>
+          <a:prstGeom prst="roundRect">
+            <a:avLst>
+              <a:gd name="adj" fmla="val 6000"/>
+            </a:avLst>
+          </a:prstGeom>
+          <a:solidFill>
+            <a:srgbClr val="50420E"/>
+          </a:solidFill>
+          <a:ln w="15875">
+            <a:solidFill>
+              <a:srgbClr val="FBD332"/>
+            </a:solidFill>
+          </a:ln>
+          <a:effectLst/>
+        </p:spPr>
+        <p:style>
+          <a:lnRef idx="1">
+            <a:schemeClr val="accent1"/>
+          </a:lnRef>
+          <a:fillRef idx="3">
+            <a:schemeClr val="accent1"/>
+          </a:fillRef>
+          <a:effectRef idx="2">
+            <a:schemeClr val="accent1"/>
+          </a:effectRef>
+          <a:fontRef idx="minor">
+            <a:schemeClr val="lt1"/>
+          </a:fontRef>
+        </p:style>
+        <p:txBody>
+          <a:bodyPr rtlCol="0" anchor="ctr"/>
+          <a:lstStyle/>
+          <a:p>
+            <a:pPr algn="ctr"/>
+          </a:p>
+        </p:txBody>
+      </p:sp>
+      <p:sp>
+        <p:nvSpPr>
+          <p:cNvPr id="12" name="TextBox 11"/>
+          <p:cNvSpPr txBox="1"/>
+          <p:nvPr/>
+        </p:nvSpPr>
+        <p:spPr>
+          <a:xfrm>
+            <a:off x="695325" y="4343400"/>
+            <a:ext cx="3429000" cy="247650"/>
+          </a:xfrm>
+          <a:prstGeom prst="rect">
+            <a:avLst/>
+          </a:prstGeom>
+          <a:noFill/>
+        </p:spPr>
+        <p:txBody>
+          <a:bodyPr wrap="square" lIns="0" rIns="0" tIns="0" bIns="0" anchor="ctr">
+            <a:spAutoFit/>
+          </a:bodyPr>
+          <a:lstStyle/>
+          <a:p>
+            <a:pPr algn="ctr">
+              <a:lnSpc>
+                <a:spcPct val="122000"/>
+              </a:lnSpc>
+            </a:pPr>
+            <a:r>
+              <a:rPr sz="1600" b="1">
+                <a:solidFill>
+                  <a:srgbClr val="FBD332"/>
+                </a:solidFill>
+                <a:latin typeface="Amazon Ember"/>
+                <a:ea typeface="メイリオ"/>
+                <a:cs typeface="メイリオ"/>
+              </a:rPr>
+              <a:t>EFA device</a:t>
+            </a:r>
+          </a:p>
+        </p:txBody>
+      </p:sp>
+      <p:sp>
+        <p:nvSpPr>
+          <p:cNvPr id="13" name="Rounded Rectangle 12"/>
+          <p:cNvSpPr/>
+          <p:nvPr/>
+        </p:nvSpPr>
+        <p:spPr>
+          <a:xfrm>
+            <a:off x="885825" y="4705350"/>
+            <a:ext cx="3048000" cy="457200"/>
+          </a:xfrm>
+          <a:prstGeom prst="roundRect">
+            <a:avLst>
+              <a:gd name="adj" fmla="val 10000"/>
+            </a:avLst>
+          </a:prstGeom>
+          <a:solidFill>
+            <a:srgbClr val="161A1E"/>
+          </a:solidFill>
+          <a:ln w="15875">
+            <a:solidFill>
+              <a:srgbClr val="FBD332"/>
+            </a:solidFill>
+          </a:ln>
+          <a:effectLst/>
+        </p:spPr>
+        <p:style>
+          <a:lnRef idx="1">
+            <a:schemeClr val="accent1"/>
+          </a:lnRef>
+          <a:fillRef idx="3">
+            <a:schemeClr val="accent1"/>
+          </a:fillRef>
+          <a:effectRef idx="2">
+            <a:schemeClr val="accent1"/>
+          </a:effectRef>
+          <a:fontRef idx="minor">
+            <a:schemeClr val="lt1"/>
+          </a:fontRef>
+        </p:style>
+        <p:txBody>
+          <a:bodyPr rtlCol="0" anchor="ctr" wrap="square" lIns="19050" rIns="19050" tIns="19050" bIns="19050"/>
+          <a:lstStyle/>
+          <a:p>
+            <a:pPr algn="ctr">
+              <a:lnSpc>
+                <a:spcPct val="122000"/>
+              </a:lnSpc>
+            </a:pPr>
+            <a:r>
+              <a:rPr sz="1500" b="1">
+                <a:solidFill>
+                  <a:srgbClr val="F5F5F8"/>
+                </a:solidFill>
+                <a:latin typeface="Amazon Ember"/>
+                <a:ea typeface="メイリオ"/>
+                <a:cs typeface="メイリオ"/>
+              </a:rPr>
+              <a:t>counter rdma_write_bytes</a:t>
+            </a:r>
+          </a:p>
+        </p:txBody>
+      </p:sp>
+      <p:cxnSp>
+        <p:nvCxnSpPr>
+          <p:cNvPr id="14" name="Connector 13"/>
+          <p:cNvCxnSpPr/>
+          <p:nvPr/>
+        </p:nvCxnSpPr>
+        <p:spPr>
+          <a:xfrm>
+            <a:off x="1552575" y="2438400"/>
+            <a:ext cx="0" cy="1847850"/>
+          </a:xfrm>
+          <a:prstGeom prst="line">
+            <a:avLst/>
+          </a:prstGeom>
+          <a:ln w="38100">
+            <a:solidFill>
+              <a:srgbClr val="2896F0"/>
+            </a:solidFill>
+            <a:tailEnd type="triangle" w="med" len="med"/>
+          </a:ln>
+          <a:effectLst/>
+        </p:spPr>
+        <p:style>
+          <a:lnRef idx="2">
+            <a:schemeClr val="accent1"/>
+          </a:lnRef>
+          <a:fillRef idx="0">
+            <a:schemeClr val="accent1"/>
+          </a:fillRef>
+          <a:effectRef idx="1">
+            <a:schemeClr val="accent1"/>
+          </a:effectRef>
+          <a:fontRef idx="minor">
+            <a:schemeClr val="tx1"/>
+          </a:fontRef>
+        </p:style>
+      </p:cxnSp>
+      <p:cxnSp>
+        <p:nvCxnSpPr>
+          <p:cNvPr id="15" name="Connector 14"/>
+          <p:cNvCxnSpPr/>
+          <p:nvPr/>
+        </p:nvCxnSpPr>
+        <p:spPr>
+          <a:xfrm flipV="1">
+            <a:off x="3267075" y="2438400"/>
+            <a:ext cx="0" cy="1847850"/>
+          </a:xfrm>
+          <a:prstGeom prst="line">
+            <a:avLst/>
+          </a:prstGeom>
+          <a:ln w="38100">
+            <a:solidFill>
+              <a:srgbClr val="2896F0"/>
+            </a:solidFill>
+            <a:tailEnd type="triangle" w="med" len="med"/>
+          </a:ln>
+          <a:effectLst/>
+        </p:spPr>
+        <p:style>
+          <a:lnRef idx="2">
+            <a:schemeClr val="accent1"/>
+          </a:lnRef>
+          <a:fillRef idx="0">
+            <a:schemeClr val="accent1"/>
+          </a:fillRef>
+          <a:effectRef idx="1">
+            <a:schemeClr val="accent1"/>
+          </a:effectRef>
+          <a:fontRef idx="minor">
+            <a:schemeClr val="tx1"/>
+          </a:fontRef>
+        </p:style>
+      </p:cxnSp>
+      <p:sp>
+        <p:nvSpPr>
+          <p:cNvPr id="16" name="TextBox 15"/>
+          <p:cNvSpPr txBox="1"/>
+          <p:nvPr/>
+        </p:nvSpPr>
+        <p:spPr>
+          <a:xfrm>
+            <a:off x="1600200" y="3238500"/>
+            <a:ext cx="1619250" cy="476250"/>
+          </a:xfrm>
+          <a:prstGeom prst="rect">
+            <a:avLst/>
+          </a:prstGeom>
+          <a:noFill/>
+        </p:spPr>
+        <p:txBody>
+          <a:bodyPr wrap="square" lIns="0" rIns="0" tIns="0" bIns="0" anchor="ctr">
+            <a:spAutoFit/>
+          </a:bodyPr>
+          <a:lstStyle/>
+          <a:p>
+            <a:pPr algn="l">
+              <a:lnSpc>
+                <a:spcPct val="122000"/>
+              </a:lnSpc>
+            </a:pPr>
+            <a:r>
+              <a:rPr sz="1300" b="0">
+                <a:solidFill>
+                  <a:srgbClr val="2896F0"/>
+                </a:solidFill>
+                <a:latin typeface="Amazon Ember"/>
+                <a:ea typeface="メイリオ"/>
+                <a:cs typeface="メイリオ"/>
+              </a:rPr>
+              <a:t>KV as RDMA</a:t>
+            </a:r>
+          </a:p>
+          <a:p>
+            <a:pPr algn="l">
+              <a:lnSpc>
+                <a:spcPct val="122000"/>
+              </a:lnSpc>
+            </a:pPr>
+            <a:r>
+              <a:rPr sz="1300" b="0">
+                <a:solidFill>
+                  <a:srgbClr val="2896F0"/>
+                </a:solidFill>
+                <a:latin typeface="Amazon Ember"/>
+                <a:ea typeface="メイリオ"/>
+                <a:cs typeface="メイリオ"/>
+              </a:rPr>
+              <a:t>writes (shm off)</a:t>
+            </a:r>
+          </a:p>
+        </p:txBody>
+      </p:sp>
+      <p:sp>
+        <p:nvSpPr>
+          <p:cNvPr id="17" name="Rounded Rectangle 16"/>
+          <p:cNvSpPr/>
+          <p:nvPr/>
+        </p:nvSpPr>
+        <p:spPr>
+          <a:xfrm>
+            <a:off x="4600575" y="4476750"/>
+            <a:ext cx="3429000" cy="857250"/>
+          </a:xfrm>
+          <a:prstGeom prst="roundRect">
+            <a:avLst>
+              <a:gd name="adj" fmla="val 10000"/>
+            </a:avLst>
+          </a:prstGeom>
+          <a:solidFill>
+            <a:srgbClr val="102C48"/>
+          </a:solidFill>
+          <a:ln w="15875">
+            <a:solidFill>
+              <a:srgbClr val="2896F0"/>
+            </a:solidFill>
+          </a:ln>
+          <a:effectLst/>
+        </p:spPr>
+        <p:style>
+          <a:lnRef idx="1">
+            <a:schemeClr val="accent1"/>
+          </a:lnRef>
+          <a:fillRef idx="3">
+            <a:schemeClr val="accent1"/>
+          </a:fillRef>
+          <a:effectRef idx="2">
+            <a:schemeClr val="accent1"/>
+          </a:effectRef>
+          <a:fontRef idx="minor">
+            <a:schemeClr val="lt1"/>
+          </a:fontRef>
+        </p:style>
+        <p:txBody>
+          <a:bodyPr rtlCol="0" anchor="ctr" wrap="square" lIns="19050" rIns="19050" tIns="19050" bIns="19050"/>
+          <a:lstStyle/>
+          <a:p>
+            <a:pPr algn="ctr">
+              <a:lnSpc>
+                <a:spcPct val="122000"/>
+              </a:lnSpc>
+            </a:pPr>
+            <a:r>
+              <a:rPr sz="1400" b="1">
+                <a:solidFill>
+                  <a:srgbClr val="F5F5F8"/>
+                </a:solidFill>
+                <a:latin typeface="Amazon Ember"/>
+                <a:ea typeface="メイリオ"/>
+                <a:cs typeface="メイリオ"/>
+              </a:rPr>
+              <a:t>kernel: efa driver registers hw_stats</a:t>
+            </a:r>
+          </a:p>
+          <a:p>
+            <a:pPr algn="ctr">
+              <a:lnSpc>
+                <a:spcPct val="122000"/>
+              </a:lnSpc>
+            </a:pPr>
+            <a:r>
+              <a:rPr sz="1400" b="1">
+                <a:solidFill>
+                  <a:srgbClr val="F5F5F8"/>
+                </a:solidFill>
+                <a:latin typeface="Amazon Ember"/>
+                <a:ea typeface="メイリオ"/>
+                <a:cs typeface="メイリオ"/>
+              </a:rPr>
+              <a:t>RDMA core exposes hw_counters</a:t>
+            </a:r>
+          </a:p>
+        </p:txBody>
+      </p:sp>
+      <p:cxnSp>
+        <p:nvCxnSpPr>
+          <p:cNvPr id="18" name="Connector 17"/>
+          <p:cNvCxnSpPr/>
+          <p:nvPr/>
+        </p:nvCxnSpPr>
+        <p:spPr>
+          <a:xfrm>
+            <a:off x="4219575" y="4905375"/>
+            <a:ext cx="381000" cy="0"/>
+          </a:xfrm>
+          <a:prstGeom prst="line">
+            <a:avLst/>
+          </a:prstGeom>
+          <a:ln w="25400">
+            <a:solidFill>
+              <a:srgbClr val="F5F5F8"/>
+            </a:solidFill>
+            <a:tailEnd type="triangle" w="med" len="med"/>
+          </a:ln>
+          <a:effectLst/>
+        </p:spPr>
+        <p:style>
+          <a:lnRef idx="2">
+            <a:schemeClr val="accent1"/>
+          </a:lnRef>
+          <a:fillRef idx="0">
+            <a:schemeClr val="accent1"/>
+          </a:fillRef>
+          <a:effectRef idx="1">
+            <a:schemeClr val="accent1"/>
+          </a:effectRef>
+          <a:fontRef idx="minor">
+            <a:schemeClr val="tx1"/>
+          </a:fontRef>
+        </p:style>
+      </p:cxnSp>
+      <p:sp>
+        <p:nvSpPr>
+          <p:cNvPr id="19" name="Rounded Rectangle 18"/>
+          <p:cNvSpPr/>
+          <p:nvPr/>
+        </p:nvSpPr>
+        <p:spPr>
+          <a:xfrm>
+            <a:off x="4600575" y="3238500"/>
+            <a:ext cx="3429000" cy="857250"/>
+          </a:xfrm>
+          <a:prstGeom prst="roundRect">
+            <a:avLst>
+              <a:gd name="adj" fmla="val 10000"/>
+            </a:avLst>
+          </a:prstGeom>
+          <a:solidFill>
+            <a:srgbClr val="343840"/>
+          </a:solidFill>
+          <a:ln w="15875">
+            <a:solidFill>
+              <a:srgbClr val="464A50"/>
+            </a:solidFill>
+          </a:ln>
+          <a:effectLst/>
+        </p:spPr>
+        <p:style>
+          <a:lnRef idx="1">
+            <a:schemeClr val="accent1"/>
+          </a:lnRef>
+          <a:fillRef idx="3">
+            <a:schemeClr val="accent1"/>
+          </a:fillRef>
+          <a:effectRef idx="2">
+            <a:schemeClr val="accent1"/>
+          </a:effectRef>
+          <a:fontRef idx="minor">
+            <a:schemeClr val="lt1"/>
+          </a:fontRef>
+        </p:style>
+        <p:txBody>
+          <a:bodyPr rtlCol="0" anchor="ctr" wrap="square" lIns="19050" rIns="19050" tIns="19050" bIns="19050"/>
+          <a:lstStyle/>
+          <a:p>
+            <a:pPr algn="ctr">
+              <a:lnSpc>
+                <a:spcPct val="122000"/>
+              </a:lnSpc>
+            </a:pPr>
+            <a:r>
+              <a:rPr sz="1300" b="1">
+                <a:solidFill>
+                  <a:srgbClr val="F5F5F8"/>
+                </a:solidFill>
+                <a:latin typeface="Amazon Ember"/>
+                <a:ea typeface="メイリオ"/>
+                <a:cs typeface="メイリオ"/>
+              </a:rPr>
+              <a:t>sysfs file</a:t>
+            </a:r>
+          </a:p>
+          <a:p>
+            <a:pPr algn="ctr">
+              <a:lnSpc>
+                <a:spcPct val="122000"/>
+              </a:lnSpc>
+            </a:pPr>
+            <a:r>
+              <a:rPr sz="1300" b="1">
+                <a:solidFill>
+                  <a:srgbClr val="F5F5F8"/>
+                </a:solidFill>
+                <a:latin typeface="Amazon Ember"/>
+                <a:ea typeface="メイリオ"/>
+                <a:cs typeface="メイリオ"/>
+              </a:rPr>
+              <a:t>.../ports/1/hw_counters/rdma_write_bytes</a:t>
+            </a:r>
+          </a:p>
+        </p:txBody>
+      </p:sp>
+      <p:cxnSp>
+        <p:nvCxnSpPr>
+          <p:cNvPr id="20" name="Connector 19"/>
+          <p:cNvCxnSpPr/>
+          <p:nvPr/>
+        </p:nvCxnSpPr>
+        <p:spPr>
+          <a:xfrm flipV="1">
+            <a:off x="6315075" y="4095750"/>
+            <a:ext cx="0" cy="381000"/>
+          </a:xfrm>
+          <a:prstGeom prst="line">
+            <a:avLst/>
+          </a:prstGeom>
+          <a:ln w="25400">
+            <a:solidFill>
+              <a:srgbClr val="F5F5F8"/>
+            </a:solidFill>
+            <a:tailEnd type="triangle" w="med" len="med"/>
+          </a:ln>
+          <a:effectLst/>
+        </p:spPr>
+        <p:style>
+          <a:lnRef idx="2">
+            <a:schemeClr val="accent1"/>
+          </a:lnRef>
+          <a:fillRef idx="0">
+            <a:schemeClr val="accent1"/>
+          </a:fillRef>
+          <a:effectRef idx="1">
+            <a:schemeClr val="accent1"/>
+          </a:effectRef>
+          <a:fontRef idx="minor">
+            <a:schemeClr val="tx1"/>
+          </a:fontRef>
+        </p:style>
+      </p:cxnSp>
+      <p:sp>
+        <p:nvSpPr>
+          <p:cNvPr id="21" name="Rounded Rectangle 20"/>
+          <p:cNvSpPr/>
+          <p:nvPr/>
+        </p:nvSpPr>
+        <p:spPr>
+          <a:xfrm>
+            <a:off x="4600575" y="1428750"/>
+            <a:ext cx="3429000" cy="1428750"/>
+          </a:xfrm>
+          <a:prstGeom prst="roundRect">
+            <a:avLst>
+              <a:gd name="adj" fmla="val 6000"/>
+            </a:avLst>
+          </a:prstGeom>
+          <a:solidFill>
+            <a:srgbClr val="161A1E"/>
+          </a:solidFill>
+          <a:ln w="15875">
+            <a:solidFill>
+              <a:srgbClr val="F5F5F8"/>
+            </a:solidFill>
+          </a:ln>
+          <a:effectLst/>
+        </p:spPr>
+        <p:style>
+          <a:lnRef idx="1">
+            <a:schemeClr val="accent1"/>
+          </a:lnRef>
+          <a:fillRef idx="3">
+            <a:schemeClr val="accent1"/>
+          </a:fillRef>
+          <a:effectRef idx="2">
+            <a:schemeClr val="accent1"/>
+          </a:effectRef>
+          <a:fontRef idx="minor">
+            <a:schemeClr val="lt1"/>
+          </a:fontRef>
+        </p:style>
+        <p:txBody>
+          <a:bodyPr rtlCol="0" anchor="ctr"/>
+          <a:lstStyle/>
+          <a:p>
+            <a:pPr algn="ctr"/>
+          </a:p>
+        </p:txBody>
+      </p:sp>
+      <p:sp>
+        <p:nvSpPr>
+          <p:cNvPr id="22" name="TextBox 21"/>
+          <p:cNvSpPr txBox="1"/>
+          <p:nvPr/>
+        </p:nvSpPr>
+        <p:spPr>
+          <a:xfrm>
+            <a:off x="4695825" y="1504950"/>
+            <a:ext cx="3238500" cy="247650"/>
+          </a:xfrm>
+          <a:prstGeom prst="rect">
+            <a:avLst/>
+          </a:prstGeom>
+          <a:noFill/>
+        </p:spPr>
+        <p:txBody>
+          <a:bodyPr wrap="square" lIns="0" rIns="0" tIns="0" bIns="0" anchor="ctr">
+            <a:spAutoFit/>
+          </a:bodyPr>
+          <a:lstStyle/>
+          <a:p>
+            <a:pPr algn="ctr">
+              <a:lnSpc>
+                <a:spcPct val="122000"/>
+              </a:lnSpc>
+            </a:pPr>
+            <a:r>
+              <a:rPr sz="1500" b="1">
+                <a:solidFill>
+                  <a:srgbClr val="F5F5F8"/>
+                </a:solidFill>
+                <a:latin typeface="Amazon Ember"/>
+                <a:ea typeface="メイリオ"/>
+                <a:cs typeface="メイリオ"/>
+              </a:rPr>
+              <a:t>probe Pod (hostNetwork)</a:t>
+            </a:r>
+          </a:p>
+        </p:txBody>
+      </p:sp>
+      <p:sp>
+        <p:nvSpPr>
+          <p:cNvPr id="23" name="TextBox 22"/>
+          <p:cNvSpPr txBox="1"/>
+          <p:nvPr/>
+        </p:nvSpPr>
+        <p:spPr>
+          <a:xfrm>
+            <a:off x="4695825" y="1828800"/>
+            <a:ext cx="3238500" cy="876300"/>
+          </a:xfrm>
+          <a:prstGeom prst="rect">
+            <a:avLst/>
+          </a:prstGeom>
+          <a:noFill/>
+        </p:spPr>
+        <p:txBody>
+          <a:bodyPr wrap="square" lIns="0" rIns="0" tIns="0" bIns="0" anchor="ctr">
+            <a:spAutoFit/>
+          </a:bodyPr>
+          <a:lstStyle/>
+          <a:p>
+            <a:pPr algn="ctr">
+              <a:lnSpc>
+                <a:spcPct val="122000"/>
+              </a:lnSpc>
+            </a:pPr>
+            <a:r>
+              <a:rPr sz="1400" b="0">
+                <a:solidFill>
+                  <a:srgbClr val="96969E"/>
+                </a:solidFill>
+                <a:latin typeface="Amazon Ember"/>
+                <a:ea typeface="メイリオ"/>
+                <a:cs typeface="メイリオ"/>
+              </a:rPr>
+              <a:t>same node</a:t>
+            </a:r>
+          </a:p>
+          <a:p>
+            <a:pPr algn="ctr">
+              <a:lnSpc>
+                <a:spcPct val="122000"/>
+              </a:lnSpc>
+            </a:pPr>
+            <a:r>
+              <a:rPr sz="1400" b="0">
+                <a:solidFill>
+                  <a:srgbClr val="96969E"/>
+                </a:solidFill>
+                <a:latin typeface="Amazon Ember"/>
+                <a:ea typeface="メイリオ"/>
+                <a:cs typeface="メイリオ"/>
+              </a:rPr>
+              <a:t>reads every counter</a:t>
+            </a:r>
+          </a:p>
+          <a:p>
+            <a:pPr algn="ctr">
+              <a:lnSpc>
+                <a:spcPct val="122000"/>
+              </a:lnSpc>
+            </a:pPr>
+            <a:r>
+              <a:rPr sz="1400" b="0">
+                <a:solidFill>
+                  <a:srgbClr val="96969E"/>
+                </a:solidFill>
+                <a:latin typeface="Amazon Ember"/>
+                <a:ea typeface="メイリオ"/>
+                <a:cs typeface="メイリオ"/>
+              </a:rPr>
+              <a:t>before and after the run</a:t>
+            </a:r>
+          </a:p>
+        </p:txBody>
+      </p:sp>
+      <p:cxnSp>
+        <p:nvCxnSpPr>
+          <p:cNvPr id="24" name="Connector 23"/>
+          <p:cNvCxnSpPr/>
+          <p:nvPr/>
+        </p:nvCxnSpPr>
+        <p:spPr>
+          <a:xfrm flipV="1">
+            <a:off x="6315075" y="2857500"/>
+            <a:ext cx="0" cy="381000"/>
+          </a:xfrm>
+          <a:prstGeom prst="line">
+            <a:avLst/>
+          </a:prstGeom>
+          <a:ln w="25400">
+            <a:solidFill>
+              <a:srgbClr val="F5F5F8"/>
+            </a:solidFill>
+            <a:tailEnd type="triangle" w="med" len="med"/>
+          </a:ln>
+          <a:effectLst/>
+        </p:spPr>
+        <p:style>
+          <a:lnRef idx="2">
+            <a:schemeClr val="accent1"/>
+          </a:lnRef>
+          <a:fillRef idx="0">
+            <a:schemeClr val="accent1"/>
+          </a:fillRef>
+          <a:effectRef idx="1">
+            <a:schemeClr val="accent1"/>
+          </a:effectRef>
+          <a:fontRef idx="minor">
+            <a:schemeClr val="tx1"/>
+          </a:fontRef>
+        </p:style>
+      </p:cxnSp>
+      <p:sp>
+        <p:nvSpPr>
+          <p:cNvPr id="25" name="Rounded Rectangle 24"/>
+          <p:cNvSpPr/>
+          <p:nvPr/>
+        </p:nvSpPr>
+        <p:spPr>
+          <a:xfrm>
+            <a:off x="8505825" y="1047750"/>
+            <a:ext cx="3276600" cy="4476750"/>
+          </a:xfrm>
+          <a:prstGeom prst="roundRect">
+            <a:avLst>
+              <a:gd name="adj" fmla="val 3000"/>
+            </a:avLst>
+          </a:prstGeom>
+          <a:solidFill>
+            <a:srgbClr val="161A1E"/>
+          </a:solidFill>
+          <a:ln w="15875">
+            <a:solidFill>
+              <a:srgbClr val="464A50"/>
+            </a:solidFill>
+          </a:ln>
+          <a:effectLst/>
+        </p:spPr>
+        <p:style>
+          <a:lnRef idx="1">
+            <a:schemeClr val="accent1"/>
+          </a:lnRef>
+          <a:fillRef idx="3">
+            <a:schemeClr val="accent1"/>
+          </a:fillRef>
+          <a:effectRef idx="2">
+            <a:schemeClr val="accent1"/>
+          </a:effectRef>
+          <a:fontRef idx="minor">
+            <a:schemeClr val="lt1"/>
+          </a:fontRef>
+        </p:style>
+        <p:txBody>
+          <a:bodyPr rtlCol="0" anchor="ctr"/>
+          <a:lstStyle/>
+          <a:p>
+            <a:pPr algn="ctr"/>
+          </a:p>
+        </p:txBody>
+      </p:sp>
+      <p:sp>
+        <p:nvSpPr>
+          <p:cNvPr id="26" name="TextBox 25"/>
+          <p:cNvSpPr txBox="1"/>
+          <p:nvPr/>
+        </p:nvSpPr>
+        <p:spPr>
+          <a:xfrm>
+            <a:off x="8601075" y="1123950"/>
+            <a:ext cx="3086100" cy="247650"/>
+          </a:xfrm>
+          <a:prstGeom prst="rect">
+            <a:avLst/>
+          </a:prstGeom>
+          <a:noFill/>
+        </p:spPr>
+        <p:txBody>
+          <a:bodyPr wrap="square" lIns="0" rIns="0" tIns="0" bIns="0" anchor="ctr">
+            <a:spAutoFit/>
+          </a:bodyPr>
+          <a:lstStyle/>
+          <a:p>
+            <a:pPr algn="ctr">
+              <a:lnSpc>
+                <a:spcPct val="122000"/>
+              </a:lnSpc>
+            </a:pPr>
+            <a:r>
+              <a:rPr sz="1500" b="1">
+                <a:solidFill>
+                  <a:srgbClr val="F5F5F8"/>
+                </a:solidFill>
+                <a:latin typeface="Amazon Ember"/>
+                <a:ea typeface="メイリオ"/>
+                <a:cs typeface="メイリオ"/>
+              </a:rPr>
+              <a:t>rdma_write_bytes, 17 requests</a:t>
+            </a:r>
+          </a:p>
+        </p:txBody>
+      </p:sp>
+      <p:sp>
+        <p:nvSpPr>
+          <p:cNvPr id="27" name="Rounded Rectangle 26"/>
+          <p:cNvSpPr/>
+          <p:nvPr/>
+        </p:nvSpPr>
+        <p:spPr>
+          <a:xfrm>
+            <a:off x="8696325" y="1524000"/>
+            <a:ext cx="2895600" cy="857250"/>
+          </a:xfrm>
+          <a:prstGeom prst="roundRect">
+            <a:avLst>
+              <a:gd name="adj" fmla="val 6000"/>
+            </a:avLst>
+          </a:prstGeom>
+          <a:solidFill>
+            <a:srgbClr val="343840"/>
+          </a:solidFill>
+          <a:ln w="15875">
+            <a:solidFill>
+              <a:srgbClr val="464A50"/>
+            </a:solidFill>
+          </a:ln>
+          <a:effectLst/>
+        </p:spPr>
+        <p:style>
+          <a:lnRef idx="1">
+            <a:schemeClr val="accent1"/>
+          </a:lnRef>
+          <a:fillRef idx="3">
+            <a:schemeClr val="accent1"/>
+          </a:fillRef>
+          <a:effectRef idx="2">
+            <a:schemeClr val="accent1"/>
+          </a:effectRef>
+          <a:fontRef idx="minor">
+            <a:schemeClr val="lt1"/>
+          </a:fontRef>
+        </p:style>
+        <p:txBody>
+          <a:bodyPr rtlCol="0" anchor="ctr"/>
+          <a:lstStyle/>
+          <a:p>
+            <a:pPr algn="ctr"/>
+          </a:p>
+        </p:txBody>
+      </p:sp>
+      <p:sp>
+        <p:nvSpPr>
+          <p:cNvPr id="28" name="TextBox 27"/>
+          <p:cNvSpPr txBox="1"/>
+          <p:nvPr/>
+        </p:nvSpPr>
+        <p:spPr>
+          <a:xfrm>
+            <a:off x="8791575" y="1581150"/>
+            <a:ext cx="2705100" cy="247650"/>
+          </a:xfrm>
+          <a:prstGeom prst="rect">
+            <a:avLst/>
+          </a:prstGeom>
+          <a:noFill/>
+        </p:spPr>
+        <p:txBody>
+          <a:bodyPr wrap="square" lIns="0" rIns="0" tIns="0" bIns="0" anchor="ctr">
+            <a:spAutoFit/>
+          </a:bodyPr>
+          <a:lstStyle/>
+          <a:p>
+            <a:pPr algn="ctr">
+              <a:lnSpc>
+                <a:spcPct val="122000"/>
+              </a:lnSpc>
+            </a:pPr>
+            <a:r>
+              <a:rPr sz="1400" b="0">
+                <a:solidFill>
+                  <a:srgbClr val="96969E"/>
+                </a:solidFill>
+                <a:latin typeface="Amazon Ember"/>
+                <a:ea typeface="メイリオ"/>
+                <a:cs typeface="メイリオ"/>
+              </a:rPr>
+              <a:t>shm on (default)</a:t>
+            </a:r>
+          </a:p>
+        </p:txBody>
+      </p:sp>
+      <p:sp>
+        <p:nvSpPr>
+          <p:cNvPr id="29" name="TextBox 28"/>
+          <p:cNvSpPr txBox="1"/>
+          <p:nvPr/>
+        </p:nvSpPr>
+        <p:spPr>
+          <a:xfrm>
+            <a:off x="8791575" y="1866900"/>
+            <a:ext cx="2705100" cy="381000"/>
+          </a:xfrm>
+          <a:prstGeom prst="rect">
+            <a:avLst/>
+          </a:prstGeom>
+          <a:noFill/>
+        </p:spPr>
+        <p:txBody>
+          <a:bodyPr wrap="square" lIns="0" rIns="0" tIns="0" bIns="0" anchor="ctr">
+            <a:spAutoFit/>
+          </a:bodyPr>
+          <a:lstStyle/>
+          <a:p>
+            <a:pPr algn="ctr">
+              <a:lnSpc>
+                <a:spcPct val="122000"/>
+              </a:lnSpc>
+            </a:pPr>
+            <a:r>
+              <a:rPr sz="1800" b="1">
+                <a:solidFill>
+                  <a:srgbClr val="F5F5F8"/>
+                </a:solidFill>
+                <a:latin typeface="Amazon Ember"/>
+                <a:ea typeface="メイリオ"/>
+                <a:cs typeface="メイリオ"/>
+              </a:rPr>
+              <a:t>measured: 0</a:t>
+            </a:r>
+          </a:p>
+        </p:txBody>
+      </p:sp>
+      <p:sp>
+        <p:nvSpPr>
+          <p:cNvPr id="30" name="Rounded Rectangle 29"/>
+          <p:cNvSpPr/>
+          <p:nvPr/>
+        </p:nvSpPr>
+        <p:spPr>
+          <a:xfrm>
+            <a:off x="8696325" y="2571750"/>
+            <a:ext cx="2895600" cy="2095500"/>
+          </a:xfrm>
+          <a:prstGeom prst="roundRect">
+            <a:avLst>
+              <a:gd name="adj" fmla="val 6000"/>
+            </a:avLst>
+          </a:prstGeom>
+          <a:solidFill>
+            <a:srgbClr val="343840"/>
+          </a:solidFill>
+          <a:ln w="15875">
+            <a:solidFill>
+              <a:srgbClr val="FBD332"/>
+            </a:solidFill>
+          </a:ln>
+          <a:effectLst/>
+        </p:spPr>
+        <p:style>
+          <a:lnRef idx="1">
+            <a:schemeClr val="accent1"/>
+          </a:lnRef>
+          <a:fillRef idx="3">
+            <a:schemeClr val="accent1"/>
+          </a:fillRef>
+          <a:effectRef idx="2">
+            <a:schemeClr val="accent1"/>
+          </a:effectRef>
+          <a:fontRef idx="minor">
+            <a:schemeClr val="lt1"/>
+          </a:fontRef>
+        </p:style>
+        <p:txBody>
+          <a:bodyPr rtlCol="0" anchor="ctr"/>
+          <a:lstStyle/>
+          <a:p>
+            <a:pPr algn="ctr"/>
+          </a:p>
+        </p:txBody>
+      </p:sp>
+      <p:sp>
+        <p:nvSpPr>
+          <p:cNvPr id="31" name="TextBox 30"/>
+          <p:cNvSpPr txBox="1"/>
+          <p:nvPr/>
+        </p:nvSpPr>
+        <p:spPr>
+          <a:xfrm>
+            <a:off x="8791575" y="2628900"/>
+            <a:ext cx="2705100" cy="247650"/>
+          </a:xfrm>
+          <a:prstGeom prst="rect">
+            <a:avLst/>
+          </a:prstGeom>
+          <a:noFill/>
+        </p:spPr>
+        <p:txBody>
+          <a:bodyPr wrap="square" lIns="0" rIns="0" tIns="0" bIns="0" anchor="ctr">
+            <a:spAutoFit/>
+          </a:bodyPr>
+          <a:lstStyle/>
+          <a:p>
+            <a:pPr algn="ctr">
+              <a:lnSpc>
+                <a:spcPct val="122000"/>
+              </a:lnSpc>
+            </a:pPr>
+            <a:r>
+              <a:rPr sz="1400" b="0">
+                <a:solidFill>
+                  <a:srgbClr val="FBD332"/>
+                </a:solidFill>
+                <a:latin typeface="Amazon Ember"/>
+                <a:ea typeface="メイリオ"/>
+                <a:cs typeface="メイリオ"/>
+              </a:rPr>
+              <a:t>shm off</a:t>
+            </a:r>
+          </a:p>
+        </p:txBody>
+      </p:sp>
+      <p:sp>
+        <p:nvSpPr>
+          <p:cNvPr id="32" name="TextBox 31"/>
+          <p:cNvSpPr txBox="1"/>
+          <p:nvPr/>
+        </p:nvSpPr>
+        <p:spPr>
+          <a:xfrm>
+            <a:off x="8791575" y="2914650"/>
+            <a:ext cx="2705100" cy="476250"/>
+          </a:xfrm>
+          <a:prstGeom prst="rect">
+            <a:avLst/>
+          </a:prstGeom>
+          <a:noFill/>
+        </p:spPr>
+        <p:txBody>
+          <a:bodyPr wrap="square" lIns="0" rIns="0" tIns="0" bIns="0" anchor="ctr">
+            <a:spAutoFit/>
+          </a:bodyPr>
+          <a:lstStyle/>
+          <a:p>
+            <a:pPr algn="ctr">
+              <a:lnSpc>
+                <a:spcPct val="122000"/>
+              </a:lnSpc>
+            </a:pPr>
+            <a:r>
+              <a:rPr sz="1700" b="1">
+                <a:solidFill>
+                  <a:srgbClr val="F5F5F8"/>
+                </a:solidFill>
+                <a:latin typeface="Amazon Ember"/>
+                <a:ea typeface="メイリオ"/>
+                <a:cs typeface="メイリオ"/>
+              </a:rPr>
+              <a:t>measured</a:t>
+            </a:r>
+          </a:p>
+          <a:p>
+            <a:pPr algn="ctr">
+              <a:lnSpc>
+                <a:spcPct val="122000"/>
+              </a:lnSpc>
+            </a:pPr>
+            <a:r>
+              <a:rPr sz="1700" b="1">
+                <a:solidFill>
+                  <a:srgbClr val="F5F5F8"/>
+                </a:solidFill>
+                <a:latin typeface="Amazon Ember"/>
+                <a:ea typeface="メイリオ"/>
+                <a:cs typeface="メイリオ"/>
+              </a:rPr>
+              <a:t>8,663,389,312</a:t>
+            </a:r>
+          </a:p>
+        </p:txBody>
+      </p:sp>
+      <p:sp>
+        <p:nvSpPr>
+          <p:cNvPr id="33" name="TextBox 32"/>
+          <p:cNvSpPr txBox="1"/>
+          <p:nvPr/>
+        </p:nvSpPr>
+        <p:spPr>
+          <a:xfrm>
+            <a:off x="8791575" y="3486150"/>
+            <a:ext cx="2705100" cy="476250"/>
+          </a:xfrm>
+          <a:prstGeom prst="rect">
+            <a:avLst/>
+          </a:prstGeom>
+          <a:noFill/>
+        </p:spPr>
+        <p:txBody>
+          <a:bodyPr wrap="square" lIns="0" rIns="0" tIns="0" bIns="0" anchor="ctr">
+            <a:spAutoFit/>
+          </a:bodyPr>
+          <a:lstStyle/>
+          <a:p>
+            <a:pPr algn="ctr">
+              <a:lnSpc>
+                <a:spcPct val="122000"/>
+              </a:lnSpc>
+            </a:pPr>
+            <a:r>
+              <a:rPr sz="1500" b="0">
+                <a:solidFill>
+                  <a:srgbClr val="96969E"/>
+                </a:solidFill>
+                <a:latin typeface="Amazon Ember"/>
+                <a:ea typeface="メイリオ"/>
+                <a:cs typeface="メイリオ"/>
+              </a:rPr>
+              <a:t>computed KV volume</a:t>
+            </a:r>
+          </a:p>
+          <a:p>
+            <a:pPr algn="ctr">
+              <a:lnSpc>
+                <a:spcPct val="122000"/>
+              </a:lnSpc>
+            </a:pPr>
+            <a:r>
+              <a:rPr sz="1500" b="0">
+                <a:solidFill>
+                  <a:srgbClr val="96969E"/>
+                </a:solidFill>
+                <a:latin typeface="Amazon Ember"/>
+                <a:ea typeface="メイリオ"/>
+                <a:cs typeface="メイリオ"/>
+              </a:rPr>
+              <a:t>8,663,334,912</a:t>
+            </a:r>
+          </a:p>
+        </p:txBody>
+      </p:sp>
+      <p:sp>
+        <p:nvSpPr>
+          <p:cNvPr id="34" name="TextBox 33"/>
+          <p:cNvSpPr txBox="1"/>
+          <p:nvPr/>
+        </p:nvSpPr>
+        <p:spPr>
+          <a:xfrm>
+            <a:off x="8791575" y="4095750"/>
+            <a:ext cx="2705100" cy="381000"/>
+          </a:xfrm>
+          <a:prstGeom prst="rect">
+            <a:avLst/>
+          </a:prstGeom>
+          <a:noFill/>
+        </p:spPr>
+        <p:txBody>
+          <a:bodyPr wrap="square" lIns="0" rIns="0" tIns="0" bIns="0" anchor="ctr">
+            <a:spAutoFit/>
+          </a:bodyPr>
+          <a:lstStyle/>
+          <a:p>
+            <a:pPr algn="ctr">
+              <a:lnSpc>
+                <a:spcPct val="122000"/>
+              </a:lnSpc>
+            </a:pPr>
+            <a:r>
+              <a:rPr sz="1700" b="1">
+                <a:solidFill>
+                  <a:srgbClr val="FBD332"/>
+                </a:solidFill>
+                <a:latin typeface="Amazon Ember"/>
+                <a:ea typeface="メイリオ"/>
+                <a:cs typeface="メイリオ"/>
+              </a:rPr>
+              <a:t>ratio 1.0000063</a:t>
+            </a:r>
+          </a:p>
+        </p:txBody>
+      </p:sp>
+      <p:sp>
+        <p:nvSpPr>
+          <p:cNvPr id="35" name="TextBox 34"/>
+          <p:cNvSpPr txBox="1"/>
+          <p:nvPr/>
+        </p:nvSpPr>
+        <p:spPr>
+          <a:xfrm>
+            <a:off x="8601075" y="4762500"/>
+            <a:ext cx="3086100" cy="666750"/>
+          </a:xfrm>
+          <a:prstGeom prst="rect">
+            <a:avLst/>
+          </a:prstGeom>
+          <a:noFill/>
+        </p:spPr>
+        <p:txBody>
+          <a:bodyPr wrap="square" lIns="0" rIns="0" tIns="0" bIns="0" anchor="ctr">
+            <a:spAutoFit/>
+          </a:bodyPr>
+          <a:lstStyle/>
+          <a:p>
+            <a:pPr algn="ctr">
+              <a:lnSpc>
+                <a:spcPct val="122000"/>
+              </a:lnSpc>
+            </a:pPr>
+            <a:r>
+              <a:rPr sz="1300" b="0">
+                <a:solidFill>
+                  <a:srgbClr val="96969E"/>
+                </a:solidFill>
+                <a:latin typeface="Amazon Ember"/>
+                <a:ea typeface="メイリオ"/>
+                <a:cs typeface="メイリオ"/>
+              </a:rPr>
+              <a:t>computed: 31,104 B/token</a:t>
+            </a:r>
+          </a:p>
+          <a:p>
+            <a:pPr algn="ctr">
+              <a:lnSpc>
+                <a:spcPct val="122000"/>
+              </a:lnSpc>
+            </a:pPr>
+            <a:r>
+              <a:rPr sz="1300" b="0">
+                <a:solidFill>
+                  <a:srgbClr val="96969E"/>
+                </a:solidFill>
+                <a:latin typeface="Amazon Ember"/>
+                <a:ea typeface="メイリオ"/>
+                <a:cs typeface="メイリオ"/>
+              </a:rPr>
+              <a:t>x 8,192 tokens x 2 ranks x 17</a:t>
+            </a:r>
+          </a:p>
+        </p:txBody>
+      </p:sp>
+    </p:spTree>
+  </p:cSld>
+  <p:clrMapOvr>
+    <a:masterClrMapping/>
+  </p:clrMapOvr>
+</p:sld>
+</file>
+
 <file path=ppt/slides/slide2.xml><?xml version="1.0" encoding="utf-8"?>
 <p:sld xmlns:a="http://schemas.openxmlformats.org/drawingml/2006/main" xmlns:p="http://schemas.openxmlformats.org/presentationml/2006/main" xmlns:r="http://schemas.openxmlformats.org/officeDocument/2006/relationships" showMasterSp="0">
   <p:cSld>

</xml_diff>

<commit_message>
zenn/741e79cf2e9bf2: show the sysfs path and how reading it fetches the EFA counter
</commit_message>
<xml_diff>
--- a/zenn/articles/741e79cf2e9bf2/source/figs.pptx
+++ b/zenn/articles/741e79cf2e9bf2/source/figs.pptx
@@ -7626,7 +7626,135 @@
         <p:spPr>
           <a:xfrm>
             <a:off x="409575" y="1047750"/>
-            <a:ext cx="7810500" cy="4476750"/>
+            <a:ext cx="11372850" cy="666750"/>
+          </a:xfrm>
+          <a:prstGeom prst="roundRect">
+            <a:avLst>
+              <a:gd name="adj" fmla="val 15000"/>
+            </a:avLst>
+          </a:prstGeom>
+          <a:solidFill>
+            <a:srgbClr val="50420E"/>
+          </a:solidFill>
+          <a:ln w="15875">
+            <a:solidFill>
+              <a:srgbClr val="FBD332"/>
+            </a:solidFill>
+          </a:ln>
+          <a:effectLst/>
+        </p:spPr>
+        <p:style>
+          <a:lnRef idx="1">
+            <a:schemeClr val="accent1"/>
+          </a:lnRef>
+          <a:fillRef idx="3">
+            <a:schemeClr val="accent1"/>
+          </a:fillRef>
+          <a:effectRef idx="2">
+            <a:schemeClr val="accent1"/>
+          </a:effectRef>
+          <a:fontRef idx="minor">
+            <a:schemeClr val="lt1"/>
+          </a:fontRef>
+        </p:style>
+        <p:txBody>
+          <a:bodyPr rtlCol="0" anchor="ctr"/>
+          <a:lstStyle/>
+          <a:p>
+            <a:pPr algn="ctr"/>
+          </a:p>
+        </p:txBody>
+      </p:sp>
+      <p:sp>
+        <p:nvSpPr>
+          <p:cNvPr id="5" name="TextBox 4"/>
+          <p:cNvSpPr txBox="1"/>
+          <p:nvPr/>
+        </p:nvSpPr>
+        <p:spPr>
+          <a:xfrm>
+            <a:off x="600075" y="1123950"/>
+            <a:ext cx="10991850" cy="304800"/>
+          </a:xfrm>
+          <a:prstGeom prst="rect">
+            <a:avLst/>
+          </a:prstGeom>
+          <a:noFill/>
+        </p:spPr>
+        <p:txBody>
+          <a:bodyPr wrap="square" lIns="0" rIns="0" tIns="0" bIns="0" anchor="ctr">
+            <a:spAutoFit/>
+          </a:bodyPr>
+          <a:lstStyle/>
+          <a:p>
+            <a:pPr algn="ctr">
+              <a:lnSpc>
+                <a:spcPct val="122000"/>
+              </a:lnSpc>
+            </a:pPr>
+            <a:r>
+              <a:rPr sz="2100" b="1">
+                <a:solidFill>
+                  <a:srgbClr val="F5F5F8"/>
+                </a:solidFill>
+                <a:latin typeface="Consolas"/>
+              </a:rPr>
+              <a:t>/sys/class/infiniband/&lt;device&gt;/ports/1/hw_counters/rdma_write_bytes</a:t>
+            </a:r>
+          </a:p>
+        </p:txBody>
+      </p:sp>
+      <p:sp>
+        <p:nvSpPr>
+          <p:cNvPr id="6" name="TextBox 5"/>
+          <p:cNvSpPr txBox="1"/>
+          <p:nvPr/>
+        </p:nvSpPr>
+        <p:spPr>
+          <a:xfrm>
+            <a:off x="600075" y="1428750"/>
+            <a:ext cx="10991850" cy="247650"/>
+          </a:xfrm>
+          <a:prstGeom prst="rect">
+            <a:avLst/>
+          </a:prstGeom>
+          <a:noFill/>
+        </p:spPr>
+        <p:txBody>
+          <a:bodyPr wrap="square" lIns="0" rIns="0" tIns="0" bIns="0" anchor="ctr">
+            <a:spAutoFit/>
+          </a:bodyPr>
+          <a:lstStyle/>
+          <a:p>
+            <a:pPr algn="ctr">
+              <a:lnSpc>
+                <a:spcPct val="122000"/>
+              </a:lnSpc>
+            </a:pPr>
+            <a:r>
+              <a:rPr sz="1300" b="0">
+                <a:solidFill>
+                  <a:srgbClr val="FBD332"/>
+                </a:solidFill>
+                <a:latin typeface="Amazon Ember"/>
+                <a:ea typeface="メイリオ"/>
+                <a:cs typeface="メイリオ"/>
+              </a:rPr>
+              <a:t>reading this file returns the device's counter at that moment (fetched again if the last read is older than 10 ms)</a:t>
+            </a:r>
+          </a:p>
+        </p:txBody>
+      </p:sp>
+      <p:sp>
+        <p:nvSpPr>
+          <p:cNvPr id="7" name="Rounded Rectangle 6"/>
+          <p:cNvSpPr/>
+          <p:nvPr/>
+        </p:nvSpPr>
+        <p:spPr>
+          <a:xfrm>
+            <a:off x="409575" y="1905000"/>
+            <a:ext cx="7810500" cy="4286250"/>
           </a:xfrm>
           <a:prstGeom prst="roundRect">
             <a:avLst>
@@ -7667,13 +7795,13 @@
       </p:sp>
       <p:sp>
         <p:nvSpPr>
-          <p:cNvPr id="5" name="TextBox 4"/>
+          <p:cNvPr id="8" name="TextBox 7"/>
           <p:cNvSpPr txBox="1"/>
           <p:nvPr/>
         </p:nvSpPr>
         <p:spPr>
           <a:xfrm>
-            <a:off x="552450" y="1104900"/>
+            <a:off x="552450" y="1962150"/>
             <a:ext cx="3810000" cy="247650"/>
           </a:xfrm>
           <a:prstGeom prst="rect">
@@ -7708,14 +7836,311 @@
       </p:sp>
       <p:sp>
         <p:nvSpPr>
-          <p:cNvPr id="6" name="Rounded Rectangle 5"/>
+          <p:cNvPr id="9" name="Rounded Rectangle 8"/>
           <p:cNvSpPr/>
           <p:nvPr/>
         </p:nvSpPr>
         <p:spPr>
           <a:xfrm>
-            <a:off x="600075" y="1428750"/>
-            <a:ext cx="3619500" cy="1714500"/>
+            <a:off x="600075" y="2381250"/>
+            <a:ext cx="1619250" cy="1047750"/>
+          </a:xfrm>
+          <a:prstGeom prst="roundRect">
+            <a:avLst>
+              <a:gd name="adj" fmla="val 10000"/>
+            </a:avLst>
+          </a:prstGeom>
+          <a:solidFill>
+            <a:srgbClr val="161A1E"/>
+          </a:solidFill>
+          <a:ln w="15875">
+            <a:solidFill>
+              <a:srgbClr val="F5F5F8"/>
+            </a:solidFill>
+          </a:ln>
+          <a:effectLst/>
+        </p:spPr>
+        <p:style>
+          <a:lnRef idx="1">
+            <a:schemeClr val="accent1"/>
+          </a:lnRef>
+          <a:fillRef idx="3">
+            <a:schemeClr val="accent1"/>
+          </a:fillRef>
+          <a:effectRef idx="2">
+            <a:schemeClr val="accent1"/>
+          </a:effectRef>
+          <a:fontRef idx="minor">
+            <a:schemeClr val="lt1"/>
+          </a:fontRef>
+        </p:style>
+        <p:txBody>
+          <a:bodyPr rtlCol="0" anchor="ctr" wrap="square" lIns="19050" rIns="19050" tIns="19050" bIns="19050"/>
+          <a:lstStyle/>
+          <a:p>
+            <a:pPr algn="ctr">
+              <a:lnSpc>
+                <a:spcPct val="122000"/>
+              </a:lnSpc>
+            </a:pPr>
+            <a:r>
+              <a:rPr sz="1400" b="1">
+                <a:solidFill>
+                  <a:srgbClr val="F5F5F8"/>
+                </a:solidFill>
+                <a:latin typeface="Amazon Ember"/>
+                <a:ea typeface="メイリオ"/>
+                <a:cs typeface="メイリオ"/>
+              </a:rPr>
+              <a:t>probe Pod</a:t>
+            </a:r>
+          </a:p>
+          <a:p>
+            <a:pPr algn="ctr">
+              <a:lnSpc>
+                <a:spcPct val="122000"/>
+              </a:lnSpc>
+            </a:pPr>
+            <a:r>
+              <a:rPr sz="1400" b="1">
+                <a:solidFill>
+                  <a:srgbClr val="F5F5F8"/>
+                </a:solidFill>
+                <a:latin typeface="Amazon Ember"/>
+                <a:ea typeface="メイリオ"/>
+                <a:cs typeface="メイリオ"/>
+              </a:rPr>
+              <a:t>(hostNetwork)</a:t>
+            </a:r>
+          </a:p>
+          <a:p>
+            <a:pPr algn="ctr">
+              <a:lnSpc>
+                <a:spcPct val="122000"/>
+              </a:lnSpc>
+            </a:pPr>
+            <a:r>
+              <a:rPr sz="1400" b="1">
+                <a:solidFill>
+                  <a:srgbClr val="F5F5F8"/>
+                </a:solidFill>
+                <a:latin typeface="Amazon Ember"/>
+                <a:ea typeface="メイリオ"/>
+                <a:cs typeface="メイリオ"/>
+              </a:rPr>
+              <a:t>reads the file</a:t>
+            </a:r>
+          </a:p>
+        </p:txBody>
+      </p:sp>
+      <p:sp>
+        <p:nvSpPr>
+          <p:cNvPr id="10" name="Rounded Rectangle 9"/>
+          <p:cNvSpPr/>
+          <p:nvPr/>
+        </p:nvSpPr>
+        <p:spPr>
+          <a:xfrm>
+            <a:off x="2505075" y="2381250"/>
+            <a:ext cx="1619250" cy="1047750"/>
+          </a:xfrm>
+          <a:prstGeom prst="roundRect">
+            <a:avLst>
+              <a:gd name="adj" fmla="val 10000"/>
+            </a:avLst>
+          </a:prstGeom>
+          <a:solidFill>
+            <a:srgbClr val="102C48"/>
+          </a:solidFill>
+          <a:ln w="15875">
+            <a:solidFill>
+              <a:srgbClr val="2896F0"/>
+            </a:solidFill>
+          </a:ln>
+          <a:effectLst/>
+        </p:spPr>
+        <p:style>
+          <a:lnRef idx="1">
+            <a:schemeClr val="accent1"/>
+          </a:lnRef>
+          <a:fillRef idx="3">
+            <a:schemeClr val="accent1"/>
+          </a:fillRef>
+          <a:effectRef idx="2">
+            <a:schemeClr val="accent1"/>
+          </a:effectRef>
+          <a:fontRef idx="minor">
+            <a:schemeClr val="lt1"/>
+          </a:fontRef>
+        </p:style>
+        <p:txBody>
+          <a:bodyPr rtlCol="0" anchor="ctr" wrap="square" lIns="19050" rIns="19050" tIns="19050" bIns="19050"/>
+          <a:lstStyle/>
+          <a:p>
+            <a:pPr algn="ctr">
+              <a:lnSpc>
+                <a:spcPct val="122000"/>
+              </a:lnSpc>
+            </a:pPr>
+            <a:r>
+              <a:rPr sz="1400" b="1">
+                <a:solidFill>
+                  <a:srgbClr val="F5F5F8"/>
+                </a:solidFill>
+                <a:latin typeface="Amazon Ember"/>
+                <a:ea typeface="メイリオ"/>
+                <a:cs typeface="メイリオ"/>
+              </a:rPr>
+              <a:t>kernel</a:t>
+            </a:r>
+          </a:p>
+          <a:p>
+            <a:pPr algn="ctr">
+              <a:lnSpc>
+                <a:spcPct val="122000"/>
+              </a:lnSpc>
+            </a:pPr>
+            <a:r>
+              <a:rPr sz="1400" b="1">
+                <a:solidFill>
+                  <a:srgbClr val="F5F5F8"/>
+                </a:solidFill>
+                <a:latin typeface="Amazon Ember"/>
+                <a:ea typeface="メイリオ"/>
+                <a:cs typeface="メイリオ"/>
+              </a:rPr>
+              <a:t>RDMA core</a:t>
+            </a:r>
+          </a:p>
+          <a:p>
+            <a:pPr algn="ctr">
+              <a:lnSpc>
+                <a:spcPct val="122000"/>
+              </a:lnSpc>
+            </a:pPr>
+            <a:r>
+              <a:rPr sz="1400" b="1">
+                <a:solidFill>
+                  <a:srgbClr val="F5F5F8"/>
+                </a:solidFill>
+                <a:latin typeface="Amazon Ember"/>
+                <a:ea typeface="メイリオ"/>
+                <a:cs typeface="メイリオ"/>
+              </a:rPr>
+              <a:t>(sysfs read)</a:t>
+            </a:r>
+          </a:p>
+        </p:txBody>
+      </p:sp>
+      <p:sp>
+        <p:nvSpPr>
+          <p:cNvPr id="11" name="Rounded Rectangle 10"/>
+          <p:cNvSpPr/>
+          <p:nvPr/>
+        </p:nvSpPr>
+        <p:spPr>
+          <a:xfrm>
+            <a:off x="4410075" y="2381250"/>
+            <a:ext cx="1619250" cy="1047750"/>
+          </a:xfrm>
+          <a:prstGeom prst="roundRect">
+            <a:avLst>
+              <a:gd name="adj" fmla="val 10000"/>
+            </a:avLst>
+          </a:prstGeom>
+          <a:solidFill>
+            <a:srgbClr val="102C48"/>
+          </a:solidFill>
+          <a:ln w="15875">
+            <a:solidFill>
+              <a:srgbClr val="2896F0"/>
+            </a:solidFill>
+          </a:ln>
+          <a:effectLst/>
+        </p:spPr>
+        <p:style>
+          <a:lnRef idx="1">
+            <a:schemeClr val="accent1"/>
+          </a:lnRef>
+          <a:fillRef idx="3">
+            <a:schemeClr val="accent1"/>
+          </a:fillRef>
+          <a:effectRef idx="2">
+            <a:schemeClr val="accent1"/>
+          </a:effectRef>
+          <a:fontRef idx="minor">
+            <a:schemeClr val="lt1"/>
+          </a:fontRef>
+        </p:style>
+        <p:txBody>
+          <a:bodyPr rtlCol="0" anchor="ctr" wrap="square" lIns="19050" rIns="19050" tIns="19050" bIns="19050"/>
+          <a:lstStyle/>
+          <a:p>
+            <a:pPr algn="ctr">
+              <a:lnSpc>
+                <a:spcPct val="122000"/>
+              </a:lnSpc>
+            </a:pPr>
+            <a:r>
+              <a:rPr sz="1400" b="1">
+                <a:solidFill>
+                  <a:srgbClr val="F5F5F8"/>
+                </a:solidFill>
+                <a:latin typeface="Amazon Ember"/>
+                <a:ea typeface="メイリオ"/>
+                <a:cs typeface="メイリオ"/>
+              </a:rPr>
+              <a:t>kernel</a:t>
+            </a:r>
+          </a:p>
+          <a:p>
+            <a:pPr algn="ctr">
+              <a:lnSpc>
+                <a:spcPct val="122000"/>
+              </a:lnSpc>
+            </a:pPr>
+            <a:r>
+              <a:rPr sz="1400" b="1">
+                <a:solidFill>
+                  <a:srgbClr val="F5F5F8"/>
+                </a:solidFill>
+                <a:latin typeface="Amazon Ember"/>
+                <a:ea typeface="メイリオ"/>
+                <a:cs typeface="メイリオ"/>
+              </a:rPr>
+              <a:t>efa driver</a:t>
+            </a:r>
+          </a:p>
+          <a:p>
+            <a:pPr algn="ctr">
+              <a:lnSpc>
+                <a:spcPct val="122000"/>
+              </a:lnSpc>
+            </a:pPr>
+            <a:r>
+              <a:rPr sz="1400" b="1">
+                <a:solidFill>
+                  <a:srgbClr val="F5F5F8"/>
+                </a:solidFill>
+                <a:latin typeface="Amazon Ember"/>
+                <a:ea typeface="メイリオ"/>
+                <a:cs typeface="メイリオ"/>
+              </a:rPr>
+              <a:t>GET_STATS</a:t>
+            </a:r>
+          </a:p>
+        </p:txBody>
+      </p:sp>
+      <p:sp>
+        <p:nvSpPr>
+          <p:cNvPr id="12" name="Rounded Rectangle 11"/>
+          <p:cNvSpPr/>
+          <p:nvPr/>
+        </p:nvSpPr>
+        <p:spPr>
+          <a:xfrm>
+            <a:off x="6315075" y="2381250"/>
+            <a:ext cx="1714500" cy="3619500"/>
           </a:xfrm>
           <a:prstGeom prst="roundRect">
             <a:avLst>
@@ -7723,11 +8148,11 @@
             </a:avLst>
           </a:prstGeom>
           <a:solidFill>
-            <a:srgbClr val="124022"/>
+            <a:srgbClr val="50420E"/>
           </a:solidFill>
           <a:ln w="15875">
             <a:solidFill>
-              <a:srgbClr val="24A046"/>
+              <a:srgbClr val="FBD332"/>
             </a:solidFill>
           </a:ln>
           <a:effectLst/>
@@ -7756,14 +8181,14 @@
       </p:sp>
       <p:sp>
         <p:nvSpPr>
-          <p:cNvPr id="7" name="TextBox 6"/>
+          <p:cNvPr id="13" name="TextBox 12"/>
           <p:cNvSpPr txBox="1"/>
           <p:nvPr/>
         </p:nvSpPr>
         <p:spPr>
           <a:xfrm>
-            <a:off x="695325" y="1485900"/>
-            <a:ext cx="3429000" cy="247650"/>
+            <a:off x="6410325" y="2457450"/>
+            <a:ext cx="1524000" cy="285750"/>
           </a:xfrm>
           <a:prstGeom prst="rect">
             <a:avLst/>
@@ -7782,29 +8207,29 @@
               </a:lnSpc>
             </a:pPr>
             <a:r>
-              <a:rPr sz="1500" b="1">
-                <a:solidFill>
-                  <a:srgbClr val="F5F5F8"/>
-                </a:solidFill>
-                <a:latin typeface="Amazon Ember"/>
-                <a:ea typeface="メイリオ"/>
-                <a:cs typeface="メイリオ"/>
-              </a:rPr>
-              <a:t>engine Pod (no hostNetwork)</a:t>
-            </a:r>
-          </a:p>
-        </p:txBody>
-      </p:sp>
-      <p:sp>
-        <p:nvSpPr>
-          <p:cNvPr id="8" name="Rounded Rectangle 7"/>
+              <a:rPr sz="1600" b="1">
+                <a:solidFill>
+                  <a:srgbClr val="FBD332"/>
+                </a:solidFill>
+                <a:latin typeface="Amazon Ember"/>
+                <a:ea typeface="メイリオ"/>
+                <a:cs typeface="メイリオ"/>
+              </a:rPr>
+              <a:t>EFA device</a:t>
+            </a:r>
+          </a:p>
+        </p:txBody>
+      </p:sp>
+      <p:sp>
+        <p:nvSpPr>
+          <p:cNvPr id="14" name="Rounded Rectangle 13"/>
           <p:cNvSpPr/>
           <p:nvPr/>
         </p:nvSpPr>
         <p:spPr>
           <a:xfrm>
-            <a:off x="790575" y="1828800"/>
-            <a:ext cx="1524000" cy="609600"/>
+            <a:off x="6410325" y="2857500"/>
+            <a:ext cx="1524000" cy="571500"/>
           </a:xfrm>
           <a:prstGeom prst="roundRect">
             <a:avLst>
@@ -7812,11 +8237,11 @@
             </a:avLst>
           </a:prstGeom>
           <a:solidFill>
-            <a:srgbClr val="343840"/>
+            <a:srgbClr val="161A1E"/>
           </a:solidFill>
           <a:ln w="15875">
             <a:solidFill>
-              <a:srgbClr val="464A50"/>
+              <a:srgbClr val="FBD332"/>
             </a:solidFill>
           </a:ln>
           <a:effectLst/>
@@ -7845,6 +8270,376 @@
               </a:lnSpc>
             </a:pPr>
             <a:r>
+              <a:rPr sz="1400" b="1">
+                <a:solidFill>
+                  <a:srgbClr val="F5F5F8"/>
+                </a:solidFill>
+                <a:latin typeface="Amazon Ember"/>
+                <a:ea typeface="メイリオ"/>
+                <a:cs typeface="メイリオ"/>
+              </a:rPr>
+              <a:t>RDMA write</a:t>
+            </a:r>
+          </a:p>
+          <a:p>
+            <a:pPr algn="ctr">
+              <a:lnSpc>
+                <a:spcPct val="122000"/>
+              </a:lnSpc>
+            </a:pPr>
+            <a:r>
+              <a:rPr sz="1400" b="1">
+                <a:solidFill>
+                  <a:srgbClr val="F5F5F8"/>
+                </a:solidFill>
+                <a:latin typeface="Amazon Ember"/>
+                <a:ea typeface="メイリオ"/>
+                <a:cs typeface="メイリオ"/>
+              </a:rPr>
+              <a:t>byte counter</a:t>
+            </a:r>
+          </a:p>
+        </p:txBody>
+      </p:sp>
+      <p:cxnSp>
+        <p:nvCxnSpPr>
+          <p:cNvPr id="15" name="Connector 14"/>
+          <p:cNvCxnSpPr/>
+          <p:nvPr/>
+        </p:nvCxnSpPr>
+        <p:spPr>
+          <a:xfrm>
+            <a:off x="2219325" y="2714625"/>
+            <a:ext cx="285750" cy="0"/>
+          </a:xfrm>
+          <a:prstGeom prst="line">
+            <a:avLst/>
+          </a:prstGeom>
+          <a:ln w="25400">
+            <a:solidFill>
+              <a:srgbClr val="F5F5F8"/>
+            </a:solidFill>
+            <a:tailEnd type="triangle" w="med" len="med"/>
+          </a:ln>
+          <a:effectLst/>
+        </p:spPr>
+        <p:style>
+          <a:lnRef idx="2">
+            <a:schemeClr val="accent1"/>
+          </a:lnRef>
+          <a:fillRef idx="0">
+            <a:schemeClr val="accent1"/>
+          </a:fillRef>
+          <a:effectRef idx="1">
+            <a:schemeClr val="accent1"/>
+          </a:effectRef>
+          <a:fontRef idx="minor">
+            <a:schemeClr val="tx1"/>
+          </a:fontRef>
+        </p:style>
+      </p:cxnSp>
+      <p:cxnSp>
+        <p:nvCxnSpPr>
+          <p:cNvPr id="16" name="Connector 15"/>
+          <p:cNvCxnSpPr/>
+          <p:nvPr/>
+        </p:nvCxnSpPr>
+        <p:spPr>
+          <a:xfrm flipH="1">
+            <a:off x="2219325" y="3143250"/>
+            <a:ext cx="285750" cy="0"/>
+          </a:xfrm>
+          <a:prstGeom prst="line">
+            <a:avLst/>
+          </a:prstGeom>
+          <a:ln w="25400">
+            <a:solidFill>
+              <a:srgbClr val="FBD332"/>
+            </a:solidFill>
+            <a:tailEnd type="triangle" w="med" len="med"/>
+          </a:ln>
+          <a:effectLst/>
+        </p:spPr>
+        <p:style>
+          <a:lnRef idx="2">
+            <a:schemeClr val="accent1"/>
+          </a:lnRef>
+          <a:fillRef idx="0">
+            <a:schemeClr val="accent1"/>
+          </a:fillRef>
+          <a:effectRef idx="1">
+            <a:schemeClr val="accent1"/>
+          </a:effectRef>
+          <a:fontRef idx="minor">
+            <a:schemeClr val="tx1"/>
+          </a:fontRef>
+        </p:style>
+      </p:cxnSp>
+      <p:cxnSp>
+        <p:nvCxnSpPr>
+          <p:cNvPr id="17" name="Connector 16"/>
+          <p:cNvCxnSpPr/>
+          <p:nvPr/>
+        </p:nvCxnSpPr>
+        <p:spPr>
+          <a:xfrm>
+            <a:off x="4124325" y="2714625"/>
+            <a:ext cx="285750" cy="0"/>
+          </a:xfrm>
+          <a:prstGeom prst="line">
+            <a:avLst/>
+          </a:prstGeom>
+          <a:ln w="25400">
+            <a:solidFill>
+              <a:srgbClr val="F5F5F8"/>
+            </a:solidFill>
+            <a:tailEnd type="triangle" w="med" len="med"/>
+          </a:ln>
+          <a:effectLst/>
+        </p:spPr>
+        <p:style>
+          <a:lnRef idx="2">
+            <a:schemeClr val="accent1"/>
+          </a:lnRef>
+          <a:fillRef idx="0">
+            <a:schemeClr val="accent1"/>
+          </a:fillRef>
+          <a:effectRef idx="1">
+            <a:schemeClr val="accent1"/>
+          </a:effectRef>
+          <a:fontRef idx="minor">
+            <a:schemeClr val="tx1"/>
+          </a:fontRef>
+        </p:style>
+      </p:cxnSp>
+      <p:cxnSp>
+        <p:nvCxnSpPr>
+          <p:cNvPr id="18" name="Connector 17"/>
+          <p:cNvCxnSpPr/>
+          <p:nvPr/>
+        </p:nvCxnSpPr>
+        <p:spPr>
+          <a:xfrm flipH="1">
+            <a:off x="4124325" y="3143250"/>
+            <a:ext cx="285750" cy="0"/>
+          </a:xfrm>
+          <a:prstGeom prst="line">
+            <a:avLst/>
+          </a:prstGeom>
+          <a:ln w="25400">
+            <a:solidFill>
+              <a:srgbClr val="FBD332"/>
+            </a:solidFill>
+            <a:tailEnd type="triangle" w="med" len="med"/>
+          </a:ln>
+          <a:effectLst/>
+        </p:spPr>
+        <p:style>
+          <a:lnRef idx="2">
+            <a:schemeClr val="accent1"/>
+          </a:lnRef>
+          <a:fillRef idx="0">
+            <a:schemeClr val="accent1"/>
+          </a:fillRef>
+          <a:effectRef idx="1">
+            <a:schemeClr val="accent1"/>
+          </a:effectRef>
+          <a:fontRef idx="minor">
+            <a:schemeClr val="tx1"/>
+          </a:fontRef>
+        </p:style>
+      </p:cxnSp>
+      <p:cxnSp>
+        <p:nvCxnSpPr>
+          <p:cNvPr id="19" name="Connector 18"/>
+          <p:cNvCxnSpPr/>
+          <p:nvPr/>
+        </p:nvCxnSpPr>
+        <p:spPr>
+          <a:xfrm>
+            <a:off x="6029325" y="2714625"/>
+            <a:ext cx="285750" cy="0"/>
+          </a:xfrm>
+          <a:prstGeom prst="line">
+            <a:avLst/>
+          </a:prstGeom>
+          <a:ln w="25400">
+            <a:solidFill>
+              <a:srgbClr val="F5F5F8"/>
+            </a:solidFill>
+            <a:tailEnd type="triangle" w="med" len="med"/>
+          </a:ln>
+          <a:effectLst/>
+        </p:spPr>
+        <p:style>
+          <a:lnRef idx="2">
+            <a:schemeClr val="accent1"/>
+          </a:lnRef>
+          <a:fillRef idx="0">
+            <a:schemeClr val="accent1"/>
+          </a:fillRef>
+          <a:effectRef idx="1">
+            <a:schemeClr val="accent1"/>
+          </a:effectRef>
+          <a:fontRef idx="minor">
+            <a:schemeClr val="tx1"/>
+          </a:fontRef>
+        </p:style>
+      </p:cxnSp>
+      <p:cxnSp>
+        <p:nvCxnSpPr>
+          <p:cNvPr id="20" name="Connector 19"/>
+          <p:cNvCxnSpPr/>
+          <p:nvPr/>
+        </p:nvCxnSpPr>
+        <p:spPr>
+          <a:xfrm flipH="1">
+            <a:off x="6029325" y="3143250"/>
+            <a:ext cx="285750" cy="0"/>
+          </a:xfrm>
+          <a:prstGeom prst="line">
+            <a:avLst/>
+          </a:prstGeom>
+          <a:ln w="25400">
+            <a:solidFill>
+              <a:srgbClr val="FBD332"/>
+            </a:solidFill>
+            <a:tailEnd type="triangle" w="med" len="med"/>
+          </a:ln>
+          <a:effectLst/>
+        </p:spPr>
+        <p:style>
+          <a:lnRef idx="2">
+            <a:schemeClr val="accent1"/>
+          </a:lnRef>
+          <a:fillRef idx="0">
+            <a:schemeClr val="accent1"/>
+          </a:fillRef>
+          <a:effectRef idx="1">
+            <a:schemeClr val="accent1"/>
+          </a:effectRef>
+          <a:fontRef idx="minor">
+            <a:schemeClr val="tx1"/>
+          </a:fontRef>
+        </p:style>
+      </p:cxnSp>
+      <p:sp>
+        <p:nvSpPr>
+          <p:cNvPr id="21" name="TextBox 20"/>
+          <p:cNvSpPr txBox="1"/>
+          <p:nvPr/>
+        </p:nvSpPr>
+        <p:spPr>
+          <a:xfrm>
+            <a:off x="600075" y="3486150"/>
+            <a:ext cx="5715000" cy="247650"/>
+          </a:xfrm>
+          <a:prstGeom prst="rect">
+            <a:avLst/>
+          </a:prstGeom>
+          <a:noFill/>
+        </p:spPr>
+        <p:txBody>
+          <a:bodyPr wrap="square" lIns="0" rIns="0" tIns="0" bIns="0" anchor="ctr">
+            <a:spAutoFit/>
+          </a:bodyPr>
+          <a:lstStyle/>
+          <a:p>
+            <a:pPr algn="l">
+              <a:lnSpc>
+                <a:spcPct val="122000"/>
+              </a:lnSpc>
+            </a:pPr>
+            <a:r>
+              <a:rPr sz="1300" b="0">
+                <a:solidFill>
+                  <a:srgbClr val="96969E"/>
+                </a:solidFill>
+                <a:latin typeface="Amazon Ember"/>
+                <a:ea typeface="メイリオ"/>
+                <a:cs typeface="メイリオ"/>
+              </a:rPr>
+              <a:t>white: read request      yellow: counter value returned</a:t>
+            </a:r>
+          </a:p>
+        </p:txBody>
+      </p:sp>
+      <p:sp>
+        <p:nvSpPr>
+          <p:cNvPr id="22" name="Rounded Rectangle 21"/>
+          <p:cNvSpPr/>
+          <p:nvPr/>
+        </p:nvSpPr>
+        <p:spPr>
+          <a:xfrm>
+            <a:off x="600075" y="4095750"/>
+            <a:ext cx="5334000" cy="1905000"/>
+          </a:xfrm>
+          <a:prstGeom prst="roundRect">
+            <a:avLst>
+              <a:gd name="adj" fmla="val 6000"/>
+            </a:avLst>
+          </a:prstGeom>
+          <a:solidFill>
+            <a:srgbClr val="124022"/>
+          </a:solidFill>
+          <a:ln w="15875">
+            <a:solidFill>
+              <a:srgbClr val="24A046"/>
+            </a:solidFill>
+          </a:ln>
+          <a:effectLst/>
+        </p:spPr>
+        <p:style>
+          <a:lnRef idx="1">
+            <a:schemeClr val="accent1"/>
+          </a:lnRef>
+          <a:fillRef idx="3">
+            <a:schemeClr val="accent1"/>
+          </a:fillRef>
+          <a:effectRef idx="2">
+            <a:schemeClr val="accent1"/>
+          </a:effectRef>
+          <a:fontRef idx="minor">
+            <a:schemeClr val="lt1"/>
+          </a:fontRef>
+        </p:style>
+        <p:txBody>
+          <a:bodyPr rtlCol="0" anchor="ctr"/>
+          <a:lstStyle/>
+          <a:p>
+            <a:pPr algn="ctr"/>
+          </a:p>
+        </p:txBody>
+      </p:sp>
+      <p:sp>
+        <p:nvSpPr>
+          <p:cNvPr id="23" name="TextBox 22"/>
+          <p:cNvSpPr txBox="1"/>
+          <p:nvPr/>
+        </p:nvSpPr>
+        <p:spPr>
+          <a:xfrm>
+            <a:off x="695325" y="4152900"/>
+            <a:ext cx="5143500" cy="247650"/>
+          </a:xfrm>
+          <a:prstGeom prst="rect">
+            <a:avLst/>
+          </a:prstGeom>
+          <a:noFill/>
+        </p:spPr>
+        <p:txBody>
+          <a:bodyPr wrap="square" lIns="0" rIns="0" tIns="0" bIns="0" anchor="ctr">
+            <a:spAutoFit/>
+          </a:bodyPr>
+          <a:lstStyle/>
+          <a:p>
+            <a:pPr algn="ctr">
+              <a:lnSpc>
+                <a:spcPct val="122000"/>
+              </a:lnSpc>
+            </a:pPr>
+            <a:r>
               <a:rPr sz="1500" b="1">
                 <a:solidFill>
                   <a:srgbClr val="F5F5F8"/>
@@ -7853,39 +8648,21 @@
                 <a:ea typeface="メイリオ"/>
                 <a:cs typeface="メイリオ"/>
               </a:rPr>
-              <a:t>prefill</a:t>
-            </a:r>
-          </a:p>
-          <a:p>
-            <a:pPr algn="ctr">
-              <a:lnSpc>
-                <a:spcPct val="122000"/>
-              </a:lnSpc>
-            </a:pPr>
-            <a:r>
-              <a:rPr sz="1500" b="1">
-                <a:solidFill>
-                  <a:srgbClr val="F5F5F8"/>
-                </a:solidFill>
-                <a:latin typeface="Amazon Ember"/>
-                <a:ea typeface="メイリオ"/>
-                <a:cs typeface="メイリオ"/>
-              </a:rPr>
-              <a:t>TP0  TP1</a:t>
-            </a:r>
-          </a:p>
-        </p:txBody>
-      </p:sp>
-      <p:sp>
-        <p:nvSpPr>
-          <p:cNvPr id="9" name="Rounded Rectangle 8"/>
+              <a:t>engine Pod (no hostNetwork)</a:t>
+            </a:r>
+          </a:p>
+        </p:txBody>
+      </p:sp>
+      <p:sp>
+        <p:nvSpPr>
+          <p:cNvPr id="24" name="Rounded Rectangle 23"/>
           <p:cNvSpPr/>
           <p:nvPr/>
         </p:nvSpPr>
         <p:spPr>
           <a:xfrm>
-            <a:off x="2505075" y="1828800"/>
-            <a:ext cx="1524000" cy="609600"/>
+            <a:off x="885825" y="4495800"/>
+            <a:ext cx="2190750" cy="609600"/>
           </a:xfrm>
           <a:prstGeom prst="roundRect">
             <a:avLst>
@@ -7934,6 +8711,87 @@
                 <a:ea typeface="メイリオ"/>
                 <a:cs typeface="メイリオ"/>
               </a:rPr>
+              <a:t>prefill</a:t>
+            </a:r>
+          </a:p>
+          <a:p>
+            <a:pPr algn="ctr">
+              <a:lnSpc>
+                <a:spcPct val="122000"/>
+              </a:lnSpc>
+            </a:pPr>
+            <a:r>
+              <a:rPr sz="1500" b="1">
+                <a:solidFill>
+                  <a:srgbClr val="F5F5F8"/>
+                </a:solidFill>
+                <a:latin typeface="Amazon Ember"/>
+                <a:ea typeface="メイリオ"/>
+                <a:cs typeface="メイリオ"/>
+              </a:rPr>
+              <a:t>TP0  TP1</a:t>
+            </a:r>
+          </a:p>
+        </p:txBody>
+      </p:sp>
+      <p:sp>
+        <p:nvSpPr>
+          <p:cNvPr id="25" name="Rounded Rectangle 24"/>
+          <p:cNvSpPr/>
+          <p:nvPr/>
+        </p:nvSpPr>
+        <p:spPr>
+          <a:xfrm>
+            <a:off x="3457575" y="4495800"/>
+            <a:ext cx="2190750" cy="609600"/>
+          </a:xfrm>
+          <a:prstGeom prst="roundRect">
+            <a:avLst>
+              <a:gd name="adj" fmla="val 10000"/>
+            </a:avLst>
+          </a:prstGeom>
+          <a:solidFill>
+            <a:srgbClr val="343840"/>
+          </a:solidFill>
+          <a:ln w="15875">
+            <a:solidFill>
+              <a:srgbClr val="464A50"/>
+            </a:solidFill>
+          </a:ln>
+          <a:effectLst/>
+        </p:spPr>
+        <p:style>
+          <a:lnRef idx="1">
+            <a:schemeClr val="accent1"/>
+          </a:lnRef>
+          <a:fillRef idx="3">
+            <a:schemeClr val="accent1"/>
+          </a:fillRef>
+          <a:effectRef idx="2">
+            <a:schemeClr val="accent1"/>
+          </a:effectRef>
+          <a:fontRef idx="minor">
+            <a:schemeClr val="lt1"/>
+          </a:fontRef>
+        </p:style>
+        <p:txBody>
+          <a:bodyPr rtlCol="0" anchor="ctr" wrap="square" lIns="19050" rIns="19050" tIns="19050" bIns="19050"/>
+          <a:lstStyle/>
+          <a:p>
+            <a:pPr algn="ctr">
+              <a:lnSpc>
+                <a:spcPct val="122000"/>
+              </a:lnSpc>
+            </a:pPr>
+            <a:r>
+              <a:rPr sz="1500" b="1">
+                <a:solidFill>
+                  <a:srgbClr val="F5F5F8"/>
+                </a:solidFill>
+                <a:latin typeface="Amazon Ember"/>
+                <a:ea typeface="メイリオ"/>
+                <a:cs typeface="メイリオ"/>
+              </a:rPr>
               <a:t>decode</a:t>
             </a:r>
           </a:p>
@@ -7959,14 +8817,14 @@
       </p:sp>
       <p:sp>
         <p:nvSpPr>
-          <p:cNvPr id="10" name="TextBox 9"/>
+          <p:cNvPr id="26" name="TextBox 25"/>
           <p:cNvSpPr txBox="1"/>
           <p:nvPr/>
         </p:nvSpPr>
         <p:spPr>
           <a:xfrm>
-            <a:off x="695325" y="2590800"/>
-            <a:ext cx="3429000" cy="438150"/>
+            <a:off x="695325" y="5257800"/>
+            <a:ext cx="5143500" cy="476250"/>
           </a:xfrm>
           <a:prstGeom prst="rect">
             <a:avLst/>
@@ -7993,39 +8851,261 @@
                 <a:ea typeface="メイリオ"/>
                 <a:cs typeface="メイリオ"/>
               </a:rPr>
-              <a:t>hw_counters</a:t>
-            </a:r>
-          </a:p>
-          <a:p>
-            <a:pPr algn="ctr">
-              <a:lnSpc>
-                <a:spcPct val="122000"/>
-              </a:lnSpc>
-            </a:pPr>
-            <a:r>
-              <a:rPr sz="1400" b="0">
-                <a:solidFill>
-                  <a:srgbClr val="E65046"/>
-                </a:solidFill>
-                <a:latin typeface="Amazon Ember"/>
-                <a:ea typeface="メイリオ"/>
-                <a:cs typeface="メイリオ"/>
-              </a:rPr>
-              <a:t>not visible here</a:t>
-            </a:r>
-          </a:p>
-        </p:txBody>
-      </p:sp>
-      <p:sp>
-        <p:nvSpPr>
-          <p:cNvPr id="11" name="Rounded Rectangle 10"/>
+              <a:t>hw_counters is not visible inside this Pod</a:t>
+            </a:r>
+          </a:p>
+        </p:txBody>
+      </p:sp>
+      <p:cxnSp>
+        <p:nvCxnSpPr>
+          <p:cNvPr id="27" name="Connector 26"/>
+          <p:cNvCxnSpPr/>
+          <p:nvPr/>
+        </p:nvCxnSpPr>
+        <p:spPr>
+          <a:xfrm>
+            <a:off x="5934075" y="4667250"/>
+            <a:ext cx="381000" cy="0"/>
+          </a:xfrm>
+          <a:prstGeom prst="line">
+            <a:avLst/>
+          </a:prstGeom>
+          <a:ln w="38100">
+            <a:solidFill>
+              <a:srgbClr val="2896F0"/>
+            </a:solidFill>
+            <a:tailEnd type="triangle" w="med" len="med"/>
+          </a:ln>
+          <a:effectLst/>
+        </p:spPr>
+        <p:style>
+          <a:lnRef idx="2">
+            <a:schemeClr val="accent1"/>
+          </a:lnRef>
+          <a:fillRef idx="0">
+            <a:schemeClr val="accent1"/>
+          </a:fillRef>
+          <a:effectRef idx="1">
+            <a:schemeClr val="accent1"/>
+          </a:effectRef>
+          <a:fontRef idx="minor">
+            <a:schemeClr val="tx1"/>
+          </a:fontRef>
+        </p:style>
+      </p:cxnSp>
+      <p:cxnSp>
+        <p:nvCxnSpPr>
+          <p:cNvPr id="28" name="Connector 27"/>
+          <p:cNvCxnSpPr/>
+          <p:nvPr/>
+        </p:nvCxnSpPr>
+        <p:spPr>
+          <a:xfrm flipH="1">
+            <a:off x="5934075" y="5334000"/>
+            <a:ext cx="381000" cy="0"/>
+          </a:xfrm>
+          <a:prstGeom prst="line">
+            <a:avLst/>
+          </a:prstGeom>
+          <a:ln w="38100">
+            <a:solidFill>
+              <a:srgbClr val="2896F0"/>
+            </a:solidFill>
+            <a:tailEnd type="triangle" w="med" len="med"/>
+          </a:ln>
+          <a:effectLst/>
+        </p:spPr>
+        <p:style>
+          <a:lnRef idx="2">
+            <a:schemeClr val="accent1"/>
+          </a:lnRef>
+          <a:fillRef idx="0">
+            <a:schemeClr val="accent1"/>
+          </a:fillRef>
+          <a:effectRef idx="1">
+            <a:schemeClr val="accent1"/>
+          </a:effectRef>
+          <a:fontRef idx="minor">
+            <a:schemeClr val="tx1"/>
+          </a:fontRef>
+        </p:style>
+      </p:cxnSp>
+      <p:sp>
+        <p:nvSpPr>
+          <p:cNvPr id="29" name="TextBox 28"/>
+          <p:cNvSpPr txBox="1"/>
+          <p:nvPr/>
+        </p:nvSpPr>
+        <p:spPr>
+          <a:xfrm>
+            <a:off x="6410325" y="4476750"/>
+            <a:ext cx="1571625" cy="1047750"/>
+          </a:xfrm>
+          <a:prstGeom prst="rect">
+            <a:avLst/>
+          </a:prstGeom>
+          <a:noFill/>
+        </p:spPr>
+        <p:txBody>
+          <a:bodyPr wrap="square" lIns="0" rIns="0" tIns="0" bIns="0" anchor="ctr">
+            <a:spAutoFit/>
+          </a:bodyPr>
+          <a:lstStyle/>
+          <a:p>
+            <a:pPr algn="ctr">
+              <a:lnSpc>
+                <a:spcPct val="122000"/>
+              </a:lnSpc>
+            </a:pPr>
+            <a:r>
+              <a:rPr sz="1300" b="0">
+                <a:solidFill>
+                  <a:srgbClr val="2896F0"/>
+                </a:solidFill>
+                <a:latin typeface="Amazon Ember"/>
+                <a:ea typeface="メイリオ"/>
+                <a:cs typeface="メイリオ"/>
+              </a:rPr>
+              <a:t>KV cache</a:t>
+            </a:r>
+          </a:p>
+          <a:p>
+            <a:pPr algn="ctr">
+              <a:lnSpc>
+                <a:spcPct val="122000"/>
+              </a:lnSpc>
+            </a:pPr>
+            <a:r>
+              <a:rPr sz="1300" b="0">
+                <a:solidFill>
+                  <a:srgbClr val="2896F0"/>
+                </a:solidFill>
+                <a:latin typeface="Amazon Ember"/>
+                <a:ea typeface="メイリオ"/>
+                <a:cs typeface="メイリオ"/>
+              </a:rPr>
+              <a:t>as RDMA writes</a:t>
+            </a:r>
+          </a:p>
+          <a:p>
+            <a:pPr algn="ctr">
+              <a:lnSpc>
+                <a:spcPct val="122000"/>
+              </a:lnSpc>
+            </a:pPr>
+            <a:r>
+              <a:rPr sz="1300" b="0">
+                <a:solidFill>
+                  <a:srgbClr val="2896F0"/>
+                </a:solidFill>
+                <a:latin typeface="Amazon Ember"/>
+                <a:ea typeface="メイリオ"/>
+                <a:cs typeface="メイリオ"/>
+              </a:rPr>
+              <a:t>(shm off)</a:t>
+            </a:r>
+          </a:p>
+        </p:txBody>
+      </p:sp>
+      <p:sp>
+        <p:nvSpPr>
+          <p:cNvPr id="30" name="Rounded Rectangle 29"/>
           <p:cNvSpPr/>
           <p:nvPr/>
         </p:nvSpPr>
         <p:spPr>
           <a:xfrm>
-            <a:off x="600075" y="4286250"/>
-            <a:ext cx="3619500" cy="1047750"/>
+            <a:off x="8505825" y="1905000"/>
+            <a:ext cx="3276600" cy="4286250"/>
+          </a:xfrm>
+          <a:prstGeom prst="roundRect">
+            <a:avLst>
+              <a:gd name="adj" fmla="val 3000"/>
+            </a:avLst>
+          </a:prstGeom>
+          <a:solidFill>
+            <a:srgbClr val="161A1E"/>
+          </a:solidFill>
+          <a:ln w="15875">
+            <a:solidFill>
+              <a:srgbClr val="464A50"/>
+            </a:solidFill>
+          </a:ln>
+          <a:effectLst/>
+        </p:spPr>
+        <p:style>
+          <a:lnRef idx="1">
+            <a:schemeClr val="accent1"/>
+          </a:lnRef>
+          <a:fillRef idx="3">
+            <a:schemeClr val="accent1"/>
+          </a:fillRef>
+          <a:effectRef idx="2">
+            <a:schemeClr val="accent1"/>
+          </a:effectRef>
+          <a:fontRef idx="minor">
+            <a:schemeClr val="lt1"/>
+          </a:fontRef>
+        </p:style>
+        <p:txBody>
+          <a:bodyPr rtlCol="0" anchor="ctr"/>
+          <a:lstStyle/>
+          <a:p>
+            <a:pPr algn="ctr"/>
+          </a:p>
+        </p:txBody>
+      </p:sp>
+      <p:sp>
+        <p:nvSpPr>
+          <p:cNvPr id="31" name="TextBox 30"/>
+          <p:cNvSpPr txBox="1"/>
+          <p:nvPr/>
+        </p:nvSpPr>
+        <p:spPr>
+          <a:xfrm>
+            <a:off x="8601075" y="1981200"/>
+            <a:ext cx="3086100" cy="247650"/>
+          </a:xfrm>
+          <a:prstGeom prst="rect">
+            <a:avLst/>
+          </a:prstGeom>
+          <a:noFill/>
+        </p:spPr>
+        <p:txBody>
+          <a:bodyPr wrap="square" lIns="0" rIns="0" tIns="0" bIns="0" anchor="ctr">
+            <a:spAutoFit/>
+          </a:bodyPr>
+          <a:lstStyle/>
+          <a:p>
+            <a:pPr algn="ctr">
+              <a:lnSpc>
+                <a:spcPct val="122000"/>
+              </a:lnSpc>
+            </a:pPr>
+            <a:r>
+              <a:rPr sz="1500" b="1">
+                <a:solidFill>
+                  <a:srgbClr val="F5F5F8"/>
+                </a:solidFill>
+                <a:latin typeface="Amazon Ember"/>
+                <a:ea typeface="メイリオ"/>
+                <a:cs typeface="メイリオ"/>
+              </a:rPr>
+              <a:t>rdma_write_bytes, 17 requests</a:t>
+            </a:r>
+          </a:p>
+        </p:txBody>
+      </p:sp>
+      <p:sp>
+        <p:nvSpPr>
+          <p:cNvPr id="32" name="Rounded Rectangle 31"/>
+          <p:cNvSpPr/>
+          <p:nvPr/>
+        </p:nvSpPr>
+        <p:spPr>
+          <a:xfrm>
+            <a:off x="8696325" y="2333625"/>
+            <a:ext cx="2895600" cy="762000"/>
           </a:xfrm>
           <a:prstGeom prst="roundRect">
             <a:avLst>
@@ -8033,11 +9113,11 @@
             </a:avLst>
           </a:prstGeom>
           <a:solidFill>
-            <a:srgbClr val="50420E"/>
+            <a:srgbClr val="343840"/>
           </a:solidFill>
           <a:ln w="15875">
             <a:solidFill>
-              <a:srgbClr val="FBD332"/>
+              <a:srgbClr val="464A50"/>
             </a:solidFill>
           </a:ln>
           <a:effectLst/>
@@ -8066,14 +9146,14 @@
       </p:sp>
       <p:sp>
         <p:nvSpPr>
-          <p:cNvPr id="12" name="TextBox 11"/>
+          <p:cNvPr id="33" name="TextBox 32"/>
           <p:cNvSpPr txBox="1"/>
           <p:nvPr/>
         </p:nvSpPr>
         <p:spPr>
           <a:xfrm>
-            <a:off x="695325" y="4343400"/>
-            <a:ext cx="3429000" cy="247650"/>
+            <a:off x="8791575" y="2381250"/>
+            <a:ext cx="2705100" cy="247650"/>
           </a:xfrm>
           <a:prstGeom prst="rect">
             <a:avLst/>
@@ -8092,166 +9172,29 @@
               </a:lnSpc>
             </a:pPr>
             <a:r>
-              <a:rPr sz="1600" b="1">
-                <a:solidFill>
-                  <a:srgbClr val="FBD332"/>
-                </a:solidFill>
-                <a:latin typeface="Amazon Ember"/>
-                <a:ea typeface="メイリオ"/>
-                <a:cs typeface="メイリオ"/>
-              </a:rPr>
-              <a:t>EFA device</a:t>
-            </a:r>
-          </a:p>
-        </p:txBody>
-      </p:sp>
-      <p:sp>
-        <p:nvSpPr>
-          <p:cNvPr id="13" name="Rounded Rectangle 12"/>
-          <p:cNvSpPr/>
-          <p:nvPr/>
-        </p:nvSpPr>
-        <p:spPr>
-          <a:xfrm>
-            <a:off x="885825" y="4705350"/>
-            <a:ext cx="3048000" cy="457200"/>
-          </a:xfrm>
-          <a:prstGeom prst="roundRect">
-            <a:avLst>
-              <a:gd name="adj" fmla="val 10000"/>
-            </a:avLst>
-          </a:prstGeom>
-          <a:solidFill>
-            <a:srgbClr val="161A1E"/>
-          </a:solidFill>
-          <a:ln w="15875">
-            <a:solidFill>
-              <a:srgbClr val="FBD332"/>
-            </a:solidFill>
-          </a:ln>
-          <a:effectLst/>
-        </p:spPr>
-        <p:style>
-          <a:lnRef idx="1">
-            <a:schemeClr val="accent1"/>
-          </a:lnRef>
-          <a:fillRef idx="3">
-            <a:schemeClr val="accent1"/>
-          </a:fillRef>
-          <a:effectRef idx="2">
-            <a:schemeClr val="accent1"/>
-          </a:effectRef>
-          <a:fontRef idx="minor">
-            <a:schemeClr val="lt1"/>
-          </a:fontRef>
-        </p:style>
-        <p:txBody>
-          <a:bodyPr rtlCol="0" anchor="ctr" wrap="square" lIns="19050" rIns="19050" tIns="19050" bIns="19050"/>
-          <a:lstStyle/>
-          <a:p>
-            <a:pPr algn="ctr">
-              <a:lnSpc>
-                <a:spcPct val="122000"/>
-              </a:lnSpc>
-            </a:pPr>
-            <a:r>
-              <a:rPr sz="1500" b="1">
-                <a:solidFill>
-                  <a:srgbClr val="F5F5F8"/>
-                </a:solidFill>
-                <a:latin typeface="Amazon Ember"/>
-                <a:ea typeface="メイリオ"/>
-                <a:cs typeface="メイリオ"/>
-              </a:rPr>
-              <a:t>counter rdma_write_bytes</a:t>
-            </a:r>
-          </a:p>
-        </p:txBody>
-      </p:sp>
-      <p:cxnSp>
-        <p:nvCxnSpPr>
-          <p:cNvPr id="14" name="Connector 13"/>
-          <p:cNvCxnSpPr/>
-          <p:nvPr/>
-        </p:nvCxnSpPr>
-        <p:spPr>
-          <a:xfrm>
-            <a:off x="1552575" y="2438400"/>
-            <a:ext cx="0" cy="1847850"/>
-          </a:xfrm>
-          <a:prstGeom prst="line">
-            <a:avLst/>
-          </a:prstGeom>
-          <a:ln w="38100">
-            <a:solidFill>
-              <a:srgbClr val="2896F0"/>
-            </a:solidFill>
-            <a:tailEnd type="triangle" w="med" len="med"/>
-          </a:ln>
-          <a:effectLst/>
-        </p:spPr>
-        <p:style>
-          <a:lnRef idx="2">
-            <a:schemeClr val="accent1"/>
-          </a:lnRef>
-          <a:fillRef idx="0">
-            <a:schemeClr val="accent1"/>
-          </a:fillRef>
-          <a:effectRef idx="1">
-            <a:schemeClr val="accent1"/>
-          </a:effectRef>
-          <a:fontRef idx="minor">
-            <a:schemeClr val="tx1"/>
-          </a:fontRef>
-        </p:style>
-      </p:cxnSp>
-      <p:cxnSp>
-        <p:nvCxnSpPr>
-          <p:cNvPr id="15" name="Connector 14"/>
-          <p:cNvCxnSpPr/>
-          <p:nvPr/>
-        </p:nvCxnSpPr>
-        <p:spPr>
-          <a:xfrm flipV="1">
-            <a:off x="3267075" y="2438400"/>
-            <a:ext cx="0" cy="1847850"/>
-          </a:xfrm>
-          <a:prstGeom prst="line">
-            <a:avLst/>
-          </a:prstGeom>
-          <a:ln w="38100">
-            <a:solidFill>
-              <a:srgbClr val="2896F0"/>
-            </a:solidFill>
-            <a:tailEnd type="triangle" w="med" len="med"/>
-          </a:ln>
-          <a:effectLst/>
-        </p:spPr>
-        <p:style>
-          <a:lnRef idx="2">
-            <a:schemeClr val="accent1"/>
-          </a:lnRef>
-          <a:fillRef idx="0">
-            <a:schemeClr val="accent1"/>
-          </a:fillRef>
-          <a:effectRef idx="1">
-            <a:schemeClr val="accent1"/>
-          </a:effectRef>
-          <a:fontRef idx="minor">
-            <a:schemeClr val="tx1"/>
-          </a:fontRef>
-        </p:style>
-      </p:cxnSp>
-      <p:sp>
-        <p:nvSpPr>
-          <p:cNvPr id="16" name="TextBox 15"/>
+              <a:rPr sz="1400" b="0">
+                <a:solidFill>
+                  <a:srgbClr val="96969E"/>
+                </a:solidFill>
+                <a:latin typeface="Amazon Ember"/>
+                <a:ea typeface="メイリオ"/>
+                <a:cs typeface="メイリオ"/>
+              </a:rPr>
+              <a:t>shm on (default)</a:t>
+            </a:r>
+          </a:p>
+        </p:txBody>
+      </p:sp>
+      <p:sp>
+        <p:nvSpPr>
+          <p:cNvPr id="34" name="TextBox 33"/>
           <p:cNvSpPr txBox="1"/>
           <p:nvPr/>
         </p:nvSpPr>
         <p:spPr>
           <a:xfrm>
-            <a:off x="1600200" y="3238500"/>
-            <a:ext cx="1619250" cy="476250"/>
+            <a:off x="8791575" y="2647950"/>
+            <a:ext cx="2705100" cy="342900"/>
           </a:xfrm>
           <a:prstGeom prst="rect">
             <a:avLst/>
@@ -8264,175 +9207,39 @@
           </a:bodyPr>
           <a:lstStyle/>
           <a:p>
-            <a:pPr algn="l">
-              <a:lnSpc>
-                <a:spcPct val="122000"/>
-              </a:lnSpc>
-            </a:pPr>
-            <a:r>
-              <a:rPr sz="1300" b="0">
-                <a:solidFill>
-                  <a:srgbClr val="2896F0"/>
-                </a:solidFill>
-                <a:latin typeface="Amazon Ember"/>
-                <a:ea typeface="メイリオ"/>
-                <a:cs typeface="メイリオ"/>
-              </a:rPr>
-              <a:t>KV as RDMA</a:t>
-            </a:r>
-          </a:p>
-          <a:p>
-            <a:pPr algn="l">
-              <a:lnSpc>
-                <a:spcPct val="122000"/>
-              </a:lnSpc>
-            </a:pPr>
-            <a:r>
-              <a:rPr sz="1300" b="0">
-                <a:solidFill>
-                  <a:srgbClr val="2896F0"/>
-                </a:solidFill>
-                <a:latin typeface="Amazon Ember"/>
-                <a:ea typeface="メイリオ"/>
-                <a:cs typeface="メイリオ"/>
-              </a:rPr>
-              <a:t>writes (shm off)</a:t>
-            </a:r>
-          </a:p>
-        </p:txBody>
-      </p:sp>
-      <p:sp>
-        <p:nvSpPr>
-          <p:cNvPr id="17" name="Rounded Rectangle 16"/>
+            <a:pPr algn="ctr">
+              <a:lnSpc>
+                <a:spcPct val="122000"/>
+              </a:lnSpc>
+            </a:pPr>
+            <a:r>
+              <a:rPr sz="1800" b="1">
+                <a:solidFill>
+                  <a:srgbClr val="F5F5F8"/>
+                </a:solidFill>
+                <a:latin typeface="Amazon Ember"/>
+                <a:ea typeface="メイリオ"/>
+                <a:cs typeface="メイリオ"/>
+              </a:rPr>
+              <a:t>measured: 0</a:t>
+            </a:r>
+          </a:p>
+        </p:txBody>
+      </p:sp>
+      <p:sp>
+        <p:nvSpPr>
+          <p:cNvPr id="35" name="Rounded Rectangle 34"/>
           <p:cNvSpPr/>
           <p:nvPr/>
         </p:nvSpPr>
         <p:spPr>
           <a:xfrm>
-            <a:off x="4600575" y="4476750"/>
-            <a:ext cx="3429000" cy="857250"/>
+            <a:off x="8696325" y="3238500"/>
+            <a:ext cx="2895600" cy="2000250"/>
           </a:xfrm>
           <a:prstGeom prst="roundRect">
             <a:avLst>
-              <a:gd name="adj" fmla="val 10000"/>
-            </a:avLst>
-          </a:prstGeom>
-          <a:solidFill>
-            <a:srgbClr val="102C48"/>
-          </a:solidFill>
-          <a:ln w="15875">
-            <a:solidFill>
-              <a:srgbClr val="2896F0"/>
-            </a:solidFill>
-          </a:ln>
-          <a:effectLst/>
-        </p:spPr>
-        <p:style>
-          <a:lnRef idx="1">
-            <a:schemeClr val="accent1"/>
-          </a:lnRef>
-          <a:fillRef idx="3">
-            <a:schemeClr val="accent1"/>
-          </a:fillRef>
-          <a:effectRef idx="2">
-            <a:schemeClr val="accent1"/>
-          </a:effectRef>
-          <a:fontRef idx="minor">
-            <a:schemeClr val="lt1"/>
-          </a:fontRef>
-        </p:style>
-        <p:txBody>
-          <a:bodyPr rtlCol="0" anchor="ctr" wrap="square" lIns="19050" rIns="19050" tIns="19050" bIns="19050"/>
-          <a:lstStyle/>
-          <a:p>
-            <a:pPr algn="ctr">
-              <a:lnSpc>
-                <a:spcPct val="122000"/>
-              </a:lnSpc>
-            </a:pPr>
-            <a:r>
-              <a:rPr sz="1400" b="1">
-                <a:solidFill>
-                  <a:srgbClr val="F5F5F8"/>
-                </a:solidFill>
-                <a:latin typeface="Amazon Ember"/>
-                <a:ea typeface="メイリオ"/>
-                <a:cs typeface="メイリオ"/>
-              </a:rPr>
-              <a:t>kernel: efa driver registers hw_stats</a:t>
-            </a:r>
-          </a:p>
-          <a:p>
-            <a:pPr algn="ctr">
-              <a:lnSpc>
-                <a:spcPct val="122000"/>
-              </a:lnSpc>
-            </a:pPr>
-            <a:r>
-              <a:rPr sz="1400" b="1">
-                <a:solidFill>
-                  <a:srgbClr val="F5F5F8"/>
-                </a:solidFill>
-                <a:latin typeface="Amazon Ember"/>
-                <a:ea typeface="メイリオ"/>
-                <a:cs typeface="メイリオ"/>
-              </a:rPr>
-              <a:t>RDMA core exposes hw_counters</a:t>
-            </a:r>
-          </a:p>
-        </p:txBody>
-      </p:sp>
-      <p:cxnSp>
-        <p:nvCxnSpPr>
-          <p:cNvPr id="18" name="Connector 17"/>
-          <p:cNvCxnSpPr/>
-          <p:nvPr/>
-        </p:nvCxnSpPr>
-        <p:spPr>
-          <a:xfrm>
-            <a:off x="4219575" y="4905375"/>
-            <a:ext cx="381000" cy="0"/>
-          </a:xfrm>
-          <a:prstGeom prst="line">
-            <a:avLst/>
-          </a:prstGeom>
-          <a:ln w="25400">
-            <a:solidFill>
-              <a:srgbClr val="F5F5F8"/>
-            </a:solidFill>
-            <a:tailEnd type="triangle" w="med" len="med"/>
-          </a:ln>
-          <a:effectLst/>
-        </p:spPr>
-        <p:style>
-          <a:lnRef idx="2">
-            <a:schemeClr val="accent1"/>
-          </a:lnRef>
-          <a:fillRef idx="0">
-            <a:schemeClr val="accent1"/>
-          </a:fillRef>
-          <a:effectRef idx="1">
-            <a:schemeClr val="accent1"/>
-          </a:effectRef>
-          <a:fontRef idx="minor">
-            <a:schemeClr val="tx1"/>
-          </a:fontRef>
-        </p:style>
-      </p:cxnSp>
-      <p:sp>
-        <p:nvSpPr>
-          <p:cNvPr id="19" name="Rounded Rectangle 18"/>
-          <p:cNvSpPr/>
-          <p:nvPr/>
-        </p:nvSpPr>
-        <p:spPr>
-          <a:xfrm>
-            <a:off x="4600575" y="3238500"/>
-            <a:ext cx="3429000" cy="857250"/>
-          </a:xfrm>
-          <a:prstGeom prst="roundRect">
-            <a:avLst>
-              <a:gd name="adj" fmla="val 10000"/>
+              <a:gd name="adj" fmla="val 6000"/>
             </a:avLst>
           </a:prstGeom>
           <a:solidFill>
@@ -8440,7 +9247,7 @@
           </a:solidFill>
           <a:ln w="15875">
             <a:solidFill>
-              <a:srgbClr val="464A50"/>
+              <a:srgbClr val="FBD332"/>
             </a:solidFill>
           </a:ln>
           <a:effectLst/>
@@ -8460,124 +9267,6 @@
           </a:fontRef>
         </p:style>
         <p:txBody>
-          <a:bodyPr rtlCol="0" anchor="ctr" wrap="square" lIns="19050" rIns="19050" tIns="19050" bIns="19050"/>
-          <a:lstStyle/>
-          <a:p>
-            <a:pPr algn="ctr">
-              <a:lnSpc>
-                <a:spcPct val="122000"/>
-              </a:lnSpc>
-            </a:pPr>
-            <a:r>
-              <a:rPr sz="1300" b="1">
-                <a:solidFill>
-                  <a:srgbClr val="F5F5F8"/>
-                </a:solidFill>
-                <a:latin typeface="Amazon Ember"/>
-                <a:ea typeface="メイリオ"/>
-                <a:cs typeface="メイリオ"/>
-              </a:rPr>
-              <a:t>sysfs file</a:t>
-            </a:r>
-          </a:p>
-          <a:p>
-            <a:pPr algn="ctr">
-              <a:lnSpc>
-                <a:spcPct val="122000"/>
-              </a:lnSpc>
-            </a:pPr>
-            <a:r>
-              <a:rPr sz="1300" b="1">
-                <a:solidFill>
-                  <a:srgbClr val="F5F5F8"/>
-                </a:solidFill>
-                <a:latin typeface="Amazon Ember"/>
-                <a:ea typeface="メイリオ"/>
-                <a:cs typeface="メイリオ"/>
-              </a:rPr>
-              <a:t>.../ports/1/hw_counters/rdma_write_bytes</a:t>
-            </a:r>
-          </a:p>
-        </p:txBody>
-      </p:sp>
-      <p:cxnSp>
-        <p:nvCxnSpPr>
-          <p:cNvPr id="20" name="Connector 19"/>
-          <p:cNvCxnSpPr/>
-          <p:nvPr/>
-        </p:nvCxnSpPr>
-        <p:spPr>
-          <a:xfrm flipV="1">
-            <a:off x="6315075" y="4095750"/>
-            <a:ext cx="0" cy="381000"/>
-          </a:xfrm>
-          <a:prstGeom prst="line">
-            <a:avLst/>
-          </a:prstGeom>
-          <a:ln w="25400">
-            <a:solidFill>
-              <a:srgbClr val="F5F5F8"/>
-            </a:solidFill>
-            <a:tailEnd type="triangle" w="med" len="med"/>
-          </a:ln>
-          <a:effectLst/>
-        </p:spPr>
-        <p:style>
-          <a:lnRef idx="2">
-            <a:schemeClr val="accent1"/>
-          </a:lnRef>
-          <a:fillRef idx="0">
-            <a:schemeClr val="accent1"/>
-          </a:fillRef>
-          <a:effectRef idx="1">
-            <a:schemeClr val="accent1"/>
-          </a:effectRef>
-          <a:fontRef idx="minor">
-            <a:schemeClr val="tx1"/>
-          </a:fontRef>
-        </p:style>
-      </p:cxnSp>
-      <p:sp>
-        <p:nvSpPr>
-          <p:cNvPr id="21" name="Rounded Rectangle 20"/>
-          <p:cNvSpPr/>
-          <p:nvPr/>
-        </p:nvSpPr>
-        <p:spPr>
-          <a:xfrm>
-            <a:off x="4600575" y="1428750"/>
-            <a:ext cx="3429000" cy="1428750"/>
-          </a:xfrm>
-          <a:prstGeom prst="roundRect">
-            <a:avLst>
-              <a:gd name="adj" fmla="val 6000"/>
-            </a:avLst>
-          </a:prstGeom>
-          <a:solidFill>
-            <a:srgbClr val="161A1E"/>
-          </a:solidFill>
-          <a:ln w="15875">
-            <a:solidFill>
-              <a:srgbClr val="F5F5F8"/>
-            </a:solidFill>
-          </a:ln>
-          <a:effectLst/>
-        </p:spPr>
-        <p:style>
-          <a:lnRef idx="1">
-            <a:schemeClr val="accent1"/>
-          </a:lnRef>
-          <a:fillRef idx="3">
-            <a:schemeClr val="accent1"/>
-          </a:fillRef>
-          <a:effectRef idx="2">
-            <a:schemeClr val="accent1"/>
-          </a:effectRef>
-          <a:fontRef idx="minor">
-            <a:schemeClr val="lt1"/>
-          </a:fontRef>
-        </p:style>
-        <p:txBody>
           <a:bodyPr rtlCol="0" anchor="ctr"/>
           <a:lstStyle/>
           <a:p>
@@ -8587,14 +9276,14 @@
       </p:sp>
       <p:sp>
         <p:nvSpPr>
-          <p:cNvPr id="22" name="TextBox 21"/>
+          <p:cNvPr id="36" name="TextBox 35"/>
           <p:cNvSpPr txBox="1"/>
           <p:nvPr/>
         </p:nvSpPr>
         <p:spPr>
           <a:xfrm>
-            <a:off x="4695825" y="1504950"/>
-            <a:ext cx="3238500" cy="247650"/>
+            <a:off x="8791575" y="3295650"/>
+            <a:ext cx="2705100" cy="247650"/>
           </a:xfrm>
           <a:prstGeom prst="rect">
             <a:avLst/>
@@ -8613,29 +9302,29 @@
               </a:lnSpc>
             </a:pPr>
             <a:r>
-              <a:rPr sz="1500" b="1">
-                <a:solidFill>
-                  <a:srgbClr val="F5F5F8"/>
-                </a:solidFill>
-                <a:latin typeface="Amazon Ember"/>
-                <a:ea typeface="メイリオ"/>
-                <a:cs typeface="メイリオ"/>
-              </a:rPr>
-              <a:t>probe Pod (hostNetwork)</a:t>
-            </a:r>
-          </a:p>
-        </p:txBody>
-      </p:sp>
-      <p:sp>
-        <p:nvSpPr>
-          <p:cNvPr id="23" name="TextBox 22"/>
+              <a:rPr sz="1400" b="0">
+                <a:solidFill>
+                  <a:srgbClr val="FBD332"/>
+                </a:solidFill>
+                <a:latin typeface="Amazon Ember"/>
+                <a:ea typeface="メイリオ"/>
+                <a:cs typeface="メイリオ"/>
+              </a:rPr>
+              <a:t>shm off</a:t>
+            </a:r>
+          </a:p>
+        </p:txBody>
+      </p:sp>
+      <p:sp>
+        <p:nvSpPr>
+          <p:cNvPr id="37" name="TextBox 36"/>
           <p:cNvSpPr txBox="1"/>
           <p:nvPr/>
         </p:nvSpPr>
         <p:spPr>
           <a:xfrm>
-            <a:off x="4695825" y="1828800"/>
-            <a:ext cx="3238500" cy="876300"/>
+            <a:off x="8791575" y="3562350"/>
+            <a:ext cx="2705100" cy="476250"/>
           </a:xfrm>
           <a:prstGeom prst="rect">
             <a:avLst/>
@@ -8654,150 +9343,47 @@
               </a:lnSpc>
             </a:pPr>
             <a:r>
-              <a:rPr sz="1400" b="0">
-                <a:solidFill>
-                  <a:srgbClr val="96969E"/>
-                </a:solidFill>
-                <a:latin typeface="Amazon Ember"/>
-                <a:ea typeface="メイリオ"/>
-                <a:cs typeface="メイリオ"/>
-              </a:rPr>
-              <a:t>same node</a:t>
-            </a:r>
-          </a:p>
-          <a:p>
-            <a:pPr algn="ctr">
-              <a:lnSpc>
-                <a:spcPct val="122000"/>
-              </a:lnSpc>
-            </a:pPr>
-            <a:r>
-              <a:rPr sz="1400" b="0">
-                <a:solidFill>
-                  <a:srgbClr val="96969E"/>
-                </a:solidFill>
-                <a:latin typeface="Amazon Ember"/>
-                <a:ea typeface="メイリオ"/>
-                <a:cs typeface="メイリオ"/>
-              </a:rPr>
-              <a:t>reads every counter</a:t>
-            </a:r>
-          </a:p>
-          <a:p>
-            <a:pPr algn="ctr">
-              <a:lnSpc>
-                <a:spcPct val="122000"/>
-              </a:lnSpc>
-            </a:pPr>
-            <a:r>
-              <a:rPr sz="1400" b="0">
-                <a:solidFill>
-                  <a:srgbClr val="96969E"/>
-                </a:solidFill>
-                <a:latin typeface="Amazon Ember"/>
-                <a:ea typeface="メイリオ"/>
-                <a:cs typeface="メイリオ"/>
-              </a:rPr>
-              <a:t>before and after the run</a:t>
-            </a:r>
-          </a:p>
-        </p:txBody>
-      </p:sp>
-      <p:cxnSp>
-        <p:nvCxnSpPr>
-          <p:cNvPr id="24" name="Connector 23"/>
-          <p:cNvCxnSpPr/>
-          <p:nvPr/>
-        </p:nvCxnSpPr>
-        <p:spPr>
-          <a:xfrm flipV="1">
-            <a:off x="6315075" y="2857500"/>
-            <a:ext cx="0" cy="381000"/>
-          </a:xfrm>
-          <a:prstGeom prst="line">
-            <a:avLst/>
-          </a:prstGeom>
-          <a:ln w="25400">
-            <a:solidFill>
-              <a:srgbClr val="F5F5F8"/>
-            </a:solidFill>
-            <a:tailEnd type="triangle" w="med" len="med"/>
-          </a:ln>
-          <a:effectLst/>
-        </p:spPr>
-        <p:style>
-          <a:lnRef idx="2">
-            <a:schemeClr val="accent1"/>
-          </a:lnRef>
-          <a:fillRef idx="0">
-            <a:schemeClr val="accent1"/>
-          </a:fillRef>
-          <a:effectRef idx="1">
-            <a:schemeClr val="accent1"/>
-          </a:effectRef>
-          <a:fontRef idx="minor">
-            <a:schemeClr val="tx1"/>
-          </a:fontRef>
-        </p:style>
-      </p:cxnSp>
-      <p:sp>
-        <p:nvSpPr>
-          <p:cNvPr id="25" name="Rounded Rectangle 24"/>
-          <p:cNvSpPr/>
-          <p:nvPr/>
-        </p:nvSpPr>
-        <p:spPr>
-          <a:xfrm>
-            <a:off x="8505825" y="1047750"/>
-            <a:ext cx="3276600" cy="4476750"/>
-          </a:xfrm>
-          <a:prstGeom prst="roundRect">
-            <a:avLst>
-              <a:gd name="adj" fmla="val 3000"/>
-            </a:avLst>
-          </a:prstGeom>
-          <a:solidFill>
-            <a:srgbClr val="161A1E"/>
-          </a:solidFill>
-          <a:ln w="15875">
-            <a:solidFill>
-              <a:srgbClr val="464A50"/>
-            </a:solidFill>
-          </a:ln>
-          <a:effectLst/>
-        </p:spPr>
-        <p:style>
-          <a:lnRef idx="1">
-            <a:schemeClr val="accent1"/>
-          </a:lnRef>
-          <a:fillRef idx="3">
-            <a:schemeClr val="accent1"/>
-          </a:fillRef>
-          <a:effectRef idx="2">
-            <a:schemeClr val="accent1"/>
-          </a:effectRef>
-          <a:fontRef idx="minor">
-            <a:schemeClr val="lt1"/>
-          </a:fontRef>
-        </p:style>
-        <p:txBody>
-          <a:bodyPr rtlCol="0" anchor="ctr"/>
-          <a:lstStyle/>
-          <a:p>
-            <a:pPr algn="ctr"/>
-          </a:p>
-        </p:txBody>
-      </p:sp>
-      <p:sp>
-        <p:nvSpPr>
-          <p:cNvPr id="26" name="TextBox 25"/>
+              <a:rPr sz="1700" b="1">
+                <a:solidFill>
+                  <a:srgbClr val="F5F5F8"/>
+                </a:solidFill>
+                <a:latin typeface="Amazon Ember"/>
+                <a:ea typeface="メイリオ"/>
+                <a:cs typeface="メイリオ"/>
+              </a:rPr>
+              <a:t>measured</a:t>
+            </a:r>
+          </a:p>
+          <a:p>
+            <a:pPr algn="ctr">
+              <a:lnSpc>
+                <a:spcPct val="122000"/>
+              </a:lnSpc>
+            </a:pPr>
+            <a:r>
+              <a:rPr sz="1700" b="1">
+                <a:solidFill>
+                  <a:srgbClr val="F5F5F8"/>
+                </a:solidFill>
+                <a:latin typeface="Amazon Ember"/>
+                <a:ea typeface="メイリオ"/>
+                <a:cs typeface="メイリオ"/>
+              </a:rPr>
+              <a:t>8,663,389,312</a:t>
+            </a:r>
+          </a:p>
+        </p:txBody>
+      </p:sp>
+      <p:sp>
+        <p:nvSpPr>
+          <p:cNvPr id="38" name="TextBox 37"/>
           <p:cNvSpPr txBox="1"/>
           <p:nvPr/>
         </p:nvSpPr>
         <p:spPr>
           <a:xfrm>
-            <a:off x="8601075" y="1123950"/>
-            <a:ext cx="3086100" cy="247650"/>
+            <a:off x="8791575" y="4114800"/>
+            <a:ext cx="2705100" cy="476250"/>
           </a:xfrm>
           <a:prstGeom prst="rect">
             <a:avLst/>
@@ -8816,77 +9402,47 @@
               </a:lnSpc>
             </a:pPr>
             <a:r>
-              <a:rPr sz="1500" b="1">
-                <a:solidFill>
-                  <a:srgbClr val="F5F5F8"/>
-                </a:solidFill>
-                <a:latin typeface="Amazon Ember"/>
-                <a:ea typeface="メイリオ"/>
-                <a:cs typeface="メイリオ"/>
-              </a:rPr>
-              <a:t>rdma_write_bytes, 17 requests</a:t>
-            </a:r>
-          </a:p>
-        </p:txBody>
-      </p:sp>
-      <p:sp>
-        <p:nvSpPr>
-          <p:cNvPr id="27" name="Rounded Rectangle 26"/>
-          <p:cNvSpPr/>
-          <p:nvPr/>
-        </p:nvSpPr>
-        <p:spPr>
-          <a:xfrm>
-            <a:off x="8696325" y="1524000"/>
-            <a:ext cx="2895600" cy="857250"/>
-          </a:xfrm>
-          <a:prstGeom prst="roundRect">
-            <a:avLst>
-              <a:gd name="adj" fmla="val 6000"/>
-            </a:avLst>
-          </a:prstGeom>
-          <a:solidFill>
-            <a:srgbClr val="343840"/>
-          </a:solidFill>
-          <a:ln w="15875">
-            <a:solidFill>
-              <a:srgbClr val="464A50"/>
-            </a:solidFill>
-          </a:ln>
-          <a:effectLst/>
-        </p:spPr>
-        <p:style>
-          <a:lnRef idx="1">
-            <a:schemeClr val="accent1"/>
-          </a:lnRef>
-          <a:fillRef idx="3">
-            <a:schemeClr val="accent1"/>
-          </a:fillRef>
-          <a:effectRef idx="2">
-            <a:schemeClr val="accent1"/>
-          </a:effectRef>
-          <a:fontRef idx="minor">
-            <a:schemeClr val="lt1"/>
-          </a:fontRef>
-        </p:style>
-        <p:txBody>
-          <a:bodyPr rtlCol="0" anchor="ctr"/>
-          <a:lstStyle/>
-          <a:p>
-            <a:pPr algn="ctr"/>
-          </a:p>
-        </p:txBody>
-      </p:sp>
-      <p:sp>
-        <p:nvSpPr>
-          <p:cNvPr id="28" name="TextBox 27"/>
+              <a:rPr sz="1500" b="0">
+                <a:solidFill>
+                  <a:srgbClr val="96969E"/>
+                </a:solidFill>
+                <a:latin typeface="Amazon Ember"/>
+                <a:ea typeface="メイリオ"/>
+                <a:cs typeface="メイリオ"/>
+              </a:rPr>
+              <a:t>computed KV volume</a:t>
+            </a:r>
+          </a:p>
+          <a:p>
+            <a:pPr algn="ctr">
+              <a:lnSpc>
+                <a:spcPct val="122000"/>
+              </a:lnSpc>
+            </a:pPr>
+            <a:r>
+              <a:rPr sz="1500" b="0">
+                <a:solidFill>
+                  <a:srgbClr val="96969E"/>
+                </a:solidFill>
+                <a:latin typeface="Amazon Ember"/>
+                <a:ea typeface="メイリオ"/>
+                <a:cs typeface="メイリオ"/>
+              </a:rPr>
+              <a:t>8,663,334,912</a:t>
+            </a:r>
+          </a:p>
+        </p:txBody>
+      </p:sp>
+      <p:sp>
+        <p:nvSpPr>
+          <p:cNvPr id="39" name="TextBox 38"/>
           <p:cNvSpPr txBox="1"/>
           <p:nvPr/>
         </p:nvSpPr>
         <p:spPr>
           <a:xfrm>
-            <a:off x="8791575" y="1581150"/>
-            <a:ext cx="2705100" cy="247650"/>
+            <a:off x="8791575" y="4705350"/>
+            <a:ext cx="2705100" cy="381000"/>
           </a:xfrm>
           <a:prstGeom prst="rect">
             <a:avLst/>
@@ -8905,317 +9461,28 @@
               </a:lnSpc>
             </a:pPr>
             <a:r>
-              <a:rPr sz="1400" b="0">
-                <a:solidFill>
-                  <a:srgbClr val="96969E"/>
-                </a:solidFill>
-                <a:latin typeface="Amazon Ember"/>
-                <a:ea typeface="メイリオ"/>
-                <a:cs typeface="メイリオ"/>
-              </a:rPr>
-              <a:t>shm on (default)</a:t>
-            </a:r>
-          </a:p>
-        </p:txBody>
-      </p:sp>
-      <p:sp>
-        <p:nvSpPr>
-          <p:cNvPr id="29" name="TextBox 28"/>
+              <a:rPr sz="1700" b="1">
+                <a:solidFill>
+                  <a:srgbClr val="FBD332"/>
+                </a:solidFill>
+                <a:latin typeface="Amazon Ember"/>
+                <a:ea typeface="メイリオ"/>
+                <a:cs typeface="メイリオ"/>
+              </a:rPr>
+              <a:t>ratio 1.0000063</a:t>
+            </a:r>
+          </a:p>
+        </p:txBody>
+      </p:sp>
+      <p:sp>
+        <p:nvSpPr>
+          <p:cNvPr id="40" name="TextBox 39"/>
           <p:cNvSpPr txBox="1"/>
           <p:nvPr/>
         </p:nvSpPr>
         <p:spPr>
           <a:xfrm>
-            <a:off x="8791575" y="1866900"/>
-            <a:ext cx="2705100" cy="381000"/>
-          </a:xfrm>
-          <a:prstGeom prst="rect">
-            <a:avLst/>
-          </a:prstGeom>
-          <a:noFill/>
-        </p:spPr>
-        <p:txBody>
-          <a:bodyPr wrap="square" lIns="0" rIns="0" tIns="0" bIns="0" anchor="ctr">
-            <a:spAutoFit/>
-          </a:bodyPr>
-          <a:lstStyle/>
-          <a:p>
-            <a:pPr algn="ctr">
-              <a:lnSpc>
-                <a:spcPct val="122000"/>
-              </a:lnSpc>
-            </a:pPr>
-            <a:r>
-              <a:rPr sz="1800" b="1">
-                <a:solidFill>
-                  <a:srgbClr val="F5F5F8"/>
-                </a:solidFill>
-                <a:latin typeface="Amazon Ember"/>
-                <a:ea typeface="メイリオ"/>
-                <a:cs typeface="メイリオ"/>
-              </a:rPr>
-              <a:t>measured: 0</a:t>
-            </a:r>
-          </a:p>
-        </p:txBody>
-      </p:sp>
-      <p:sp>
-        <p:nvSpPr>
-          <p:cNvPr id="30" name="Rounded Rectangle 29"/>
-          <p:cNvSpPr/>
-          <p:nvPr/>
-        </p:nvSpPr>
-        <p:spPr>
-          <a:xfrm>
-            <a:off x="8696325" y="2571750"/>
-            <a:ext cx="2895600" cy="2095500"/>
-          </a:xfrm>
-          <a:prstGeom prst="roundRect">
-            <a:avLst>
-              <a:gd name="adj" fmla="val 6000"/>
-            </a:avLst>
-          </a:prstGeom>
-          <a:solidFill>
-            <a:srgbClr val="343840"/>
-          </a:solidFill>
-          <a:ln w="15875">
-            <a:solidFill>
-              <a:srgbClr val="FBD332"/>
-            </a:solidFill>
-          </a:ln>
-          <a:effectLst/>
-        </p:spPr>
-        <p:style>
-          <a:lnRef idx="1">
-            <a:schemeClr val="accent1"/>
-          </a:lnRef>
-          <a:fillRef idx="3">
-            <a:schemeClr val="accent1"/>
-          </a:fillRef>
-          <a:effectRef idx="2">
-            <a:schemeClr val="accent1"/>
-          </a:effectRef>
-          <a:fontRef idx="minor">
-            <a:schemeClr val="lt1"/>
-          </a:fontRef>
-        </p:style>
-        <p:txBody>
-          <a:bodyPr rtlCol="0" anchor="ctr"/>
-          <a:lstStyle/>
-          <a:p>
-            <a:pPr algn="ctr"/>
-          </a:p>
-        </p:txBody>
-      </p:sp>
-      <p:sp>
-        <p:nvSpPr>
-          <p:cNvPr id="31" name="TextBox 30"/>
-          <p:cNvSpPr txBox="1"/>
-          <p:nvPr/>
-        </p:nvSpPr>
-        <p:spPr>
-          <a:xfrm>
-            <a:off x="8791575" y="2628900"/>
-            <a:ext cx="2705100" cy="247650"/>
-          </a:xfrm>
-          <a:prstGeom prst="rect">
-            <a:avLst/>
-          </a:prstGeom>
-          <a:noFill/>
-        </p:spPr>
-        <p:txBody>
-          <a:bodyPr wrap="square" lIns="0" rIns="0" tIns="0" bIns="0" anchor="ctr">
-            <a:spAutoFit/>
-          </a:bodyPr>
-          <a:lstStyle/>
-          <a:p>
-            <a:pPr algn="ctr">
-              <a:lnSpc>
-                <a:spcPct val="122000"/>
-              </a:lnSpc>
-            </a:pPr>
-            <a:r>
-              <a:rPr sz="1400" b="0">
-                <a:solidFill>
-                  <a:srgbClr val="FBD332"/>
-                </a:solidFill>
-                <a:latin typeface="Amazon Ember"/>
-                <a:ea typeface="メイリオ"/>
-                <a:cs typeface="メイリオ"/>
-              </a:rPr>
-              <a:t>shm off</a:t>
-            </a:r>
-          </a:p>
-        </p:txBody>
-      </p:sp>
-      <p:sp>
-        <p:nvSpPr>
-          <p:cNvPr id="32" name="TextBox 31"/>
-          <p:cNvSpPr txBox="1"/>
-          <p:nvPr/>
-        </p:nvSpPr>
-        <p:spPr>
-          <a:xfrm>
-            <a:off x="8791575" y="2914650"/>
-            <a:ext cx="2705100" cy="476250"/>
-          </a:xfrm>
-          <a:prstGeom prst="rect">
-            <a:avLst/>
-          </a:prstGeom>
-          <a:noFill/>
-        </p:spPr>
-        <p:txBody>
-          <a:bodyPr wrap="square" lIns="0" rIns="0" tIns="0" bIns="0" anchor="ctr">
-            <a:spAutoFit/>
-          </a:bodyPr>
-          <a:lstStyle/>
-          <a:p>
-            <a:pPr algn="ctr">
-              <a:lnSpc>
-                <a:spcPct val="122000"/>
-              </a:lnSpc>
-            </a:pPr>
-            <a:r>
-              <a:rPr sz="1700" b="1">
-                <a:solidFill>
-                  <a:srgbClr val="F5F5F8"/>
-                </a:solidFill>
-                <a:latin typeface="Amazon Ember"/>
-                <a:ea typeface="メイリオ"/>
-                <a:cs typeface="メイリオ"/>
-              </a:rPr>
-              <a:t>measured</a:t>
-            </a:r>
-          </a:p>
-          <a:p>
-            <a:pPr algn="ctr">
-              <a:lnSpc>
-                <a:spcPct val="122000"/>
-              </a:lnSpc>
-            </a:pPr>
-            <a:r>
-              <a:rPr sz="1700" b="1">
-                <a:solidFill>
-                  <a:srgbClr val="F5F5F8"/>
-                </a:solidFill>
-                <a:latin typeface="Amazon Ember"/>
-                <a:ea typeface="メイリオ"/>
-                <a:cs typeface="メイリオ"/>
-              </a:rPr>
-              <a:t>8,663,389,312</a:t>
-            </a:r>
-          </a:p>
-        </p:txBody>
-      </p:sp>
-      <p:sp>
-        <p:nvSpPr>
-          <p:cNvPr id="33" name="TextBox 32"/>
-          <p:cNvSpPr txBox="1"/>
-          <p:nvPr/>
-        </p:nvSpPr>
-        <p:spPr>
-          <a:xfrm>
-            <a:off x="8791575" y="3486150"/>
-            <a:ext cx="2705100" cy="476250"/>
-          </a:xfrm>
-          <a:prstGeom prst="rect">
-            <a:avLst/>
-          </a:prstGeom>
-          <a:noFill/>
-        </p:spPr>
-        <p:txBody>
-          <a:bodyPr wrap="square" lIns="0" rIns="0" tIns="0" bIns="0" anchor="ctr">
-            <a:spAutoFit/>
-          </a:bodyPr>
-          <a:lstStyle/>
-          <a:p>
-            <a:pPr algn="ctr">
-              <a:lnSpc>
-                <a:spcPct val="122000"/>
-              </a:lnSpc>
-            </a:pPr>
-            <a:r>
-              <a:rPr sz="1500" b="0">
-                <a:solidFill>
-                  <a:srgbClr val="96969E"/>
-                </a:solidFill>
-                <a:latin typeface="Amazon Ember"/>
-                <a:ea typeface="メイリオ"/>
-                <a:cs typeface="メイリオ"/>
-              </a:rPr>
-              <a:t>computed KV volume</a:t>
-            </a:r>
-          </a:p>
-          <a:p>
-            <a:pPr algn="ctr">
-              <a:lnSpc>
-                <a:spcPct val="122000"/>
-              </a:lnSpc>
-            </a:pPr>
-            <a:r>
-              <a:rPr sz="1500" b="0">
-                <a:solidFill>
-                  <a:srgbClr val="96969E"/>
-                </a:solidFill>
-                <a:latin typeface="Amazon Ember"/>
-                <a:ea typeface="メイリオ"/>
-                <a:cs typeface="メイリオ"/>
-              </a:rPr>
-              <a:t>8,663,334,912</a:t>
-            </a:r>
-          </a:p>
-        </p:txBody>
-      </p:sp>
-      <p:sp>
-        <p:nvSpPr>
-          <p:cNvPr id="34" name="TextBox 33"/>
-          <p:cNvSpPr txBox="1"/>
-          <p:nvPr/>
-        </p:nvSpPr>
-        <p:spPr>
-          <a:xfrm>
-            <a:off x="8791575" y="4095750"/>
-            <a:ext cx="2705100" cy="381000"/>
-          </a:xfrm>
-          <a:prstGeom prst="rect">
-            <a:avLst/>
-          </a:prstGeom>
-          <a:noFill/>
-        </p:spPr>
-        <p:txBody>
-          <a:bodyPr wrap="square" lIns="0" rIns="0" tIns="0" bIns="0" anchor="ctr">
-            <a:spAutoFit/>
-          </a:bodyPr>
-          <a:lstStyle/>
-          <a:p>
-            <a:pPr algn="ctr">
-              <a:lnSpc>
-                <a:spcPct val="122000"/>
-              </a:lnSpc>
-            </a:pPr>
-            <a:r>
-              <a:rPr sz="1700" b="1">
-                <a:solidFill>
-                  <a:srgbClr val="FBD332"/>
-                </a:solidFill>
-                <a:latin typeface="Amazon Ember"/>
-                <a:ea typeface="メイリオ"/>
-                <a:cs typeface="メイリオ"/>
-              </a:rPr>
-              <a:t>ratio 1.0000063</a:t>
-            </a:r>
-          </a:p>
-        </p:txBody>
-      </p:sp>
-      <p:sp>
-        <p:nvSpPr>
-          <p:cNvPr id="35" name="TextBox 34"/>
-          <p:cNvSpPr txBox="1"/>
-          <p:nvPr/>
-        </p:nvSpPr>
-        <p:spPr>
-          <a:xfrm>
-            <a:off x="8601075" y="4762500"/>
+            <a:off x="8601075" y="5381625"/>
             <a:ext cx="3086100" cy="666750"/>
           </a:xfrm>
           <a:prstGeom prst="rect">

</xml_diff>